<commit_message>
Update Bomb Lab download instructions on slide 5
</commit_message>
<xml_diff>
--- a/public/presentations/CS211_Recitation_5.pptx
+++ b/public/presentations/CS211_Recitation_5.pptx
@@ -2,39 +2,39 @@
 <file path=ppt/presentation.xml><?xml version="1.0" encoding="utf-8"?>
 <p:presentation xmlns:p="http://schemas.openxmlformats.org/presentationml/2006/main" embedTrueTypeFonts="1" saveSubsetFonts="0">
   <p:sldMasterIdLst>
-    <p:sldMasterId xmlns:r="http://schemas.openxmlformats.org/officeDocument/2006/relationships" id="2147483648" r:id="Re711fb8a3cfe455e"/>
+    <p:sldMasterId xmlns:r="http://schemas.openxmlformats.org/officeDocument/2006/relationships" id="2147483648" r:id="Rce93c849cc9b431f"/>
   </p:sldMasterIdLst>
   <p:notesMasterIdLst>
-    <p:notesMasterId xmlns:r="http://schemas.openxmlformats.org/officeDocument/2006/relationships" r:id="R9575686988574a23"/>
+    <p:notesMasterId xmlns:r="http://schemas.openxmlformats.org/officeDocument/2006/relationships" r:id="R2a483e93cc4541a2"/>
   </p:notesMasterIdLst>
   <p:sldIdLst>
-    <p:sldId xmlns:r="http://schemas.openxmlformats.org/officeDocument/2006/relationships" id="256" r:id="Ra6ab52a28deb46fe"/>
-    <p:sldId xmlns:r="http://schemas.openxmlformats.org/officeDocument/2006/relationships" id="257" r:id="R15495bfad6f448b2"/>
-    <p:sldId xmlns:r="http://schemas.openxmlformats.org/officeDocument/2006/relationships" id="258" r:id="R5a55a240955a4f3c"/>
-    <p:sldId xmlns:r="http://schemas.openxmlformats.org/officeDocument/2006/relationships" id="259" r:id="Raec3a4a62dc34ee0"/>
-    <p:sldId xmlns:r="http://schemas.openxmlformats.org/officeDocument/2006/relationships" id="260" r:id="R286e35c971d9407f"/>
-    <p:sldId xmlns:r="http://schemas.openxmlformats.org/officeDocument/2006/relationships" id="261" r:id="Rad3511c45c474b67"/>
-    <p:sldId xmlns:r="http://schemas.openxmlformats.org/officeDocument/2006/relationships" id="262" r:id="R5c100fac5427411e"/>
-    <p:sldId xmlns:r="http://schemas.openxmlformats.org/officeDocument/2006/relationships" id="263" r:id="R49563e82af8546e3"/>
-    <p:sldId xmlns:r="http://schemas.openxmlformats.org/officeDocument/2006/relationships" id="264" r:id="R8e9ca82241484f80"/>
-    <p:sldId xmlns:r="http://schemas.openxmlformats.org/officeDocument/2006/relationships" id="265" r:id="Rbcbd37a902e4477d"/>
-    <p:sldId xmlns:r="http://schemas.openxmlformats.org/officeDocument/2006/relationships" id="266" r:id="Rdad8e184d5994782"/>
-    <p:sldId xmlns:r="http://schemas.openxmlformats.org/officeDocument/2006/relationships" id="267" r:id="R697b8b3ecf4b432e"/>
-    <p:sldId xmlns:r="http://schemas.openxmlformats.org/officeDocument/2006/relationships" id="268" r:id="R050f0189b7d54038"/>
-    <p:sldId xmlns:r="http://schemas.openxmlformats.org/officeDocument/2006/relationships" id="269" r:id="R95e926c0447a4bb7"/>
-    <p:sldId xmlns:r="http://schemas.openxmlformats.org/officeDocument/2006/relationships" id="270" r:id="Rf5c9a9dcbc2348e6"/>
-    <p:sldId xmlns:r="http://schemas.openxmlformats.org/officeDocument/2006/relationships" id="271" r:id="R7d9f25864b7c4cb7"/>
-    <p:sldId xmlns:r="http://schemas.openxmlformats.org/officeDocument/2006/relationships" id="272" r:id="R04ea2d49106e432d"/>
+    <p:sldId xmlns:r="http://schemas.openxmlformats.org/officeDocument/2006/relationships" id="256" r:id="R4aa2db8587d04ebb"/>
+    <p:sldId xmlns:r="http://schemas.openxmlformats.org/officeDocument/2006/relationships" id="257" r:id="Ra4678641c3da423f"/>
+    <p:sldId xmlns:r="http://schemas.openxmlformats.org/officeDocument/2006/relationships" id="258" r:id="Rc2801329098a4f14"/>
+    <p:sldId xmlns:r="http://schemas.openxmlformats.org/officeDocument/2006/relationships" id="259" r:id="Rc3502b0cc1714a0a"/>
+    <p:sldId xmlns:r="http://schemas.openxmlformats.org/officeDocument/2006/relationships" id="260" r:id="Racb650f764eb485d"/>
+    <p:sldId xmlns:r="http://schemas.openxmlformats.org/officeDocument/2006/relationships" id="261" r:id="R71d7fc3f904849d7"/>
+    <p:sldId xmlns:r="http://schemas.openxmlformats.org/officeDocument/2006/relationships" id="262" r:id="R2fa89800fd704d90"/>
+    <p:sldId xmlns:r="http://schemas.openxmlformats.org/officeDocument/2006/relationships" id="263" r:id="R7208713a7bec454e"/>
+    <p:sldId xmlns:r="http://schemas.openxmlformats.org/officeDocument/2006/relationships" id="264" r:id="Rd3835181b7884cfd"/>
+    <p:sldId xmlns:r="http://schemas.openxmlformats.org/officeDocument/2006/relationships" id="265" r:id="Rfbf4056c195b4610"/>
+    <p:sldId xmlns:r="http://schemas.openxmlformats.org/officeDocument/2006/relationships" id="266" r:id="R494fdd76537b4d72"/>
+    <p:sldId xmlns:r="http://schemas.openxmlformats.org/officeDocument/2006/relationships" id="267" r:id="Raa53aebcba614e40"/>
+    <p:sldId xmlns:r="http://schemas.openxmlformats.org/officeDocument/2006/relationships" id="268" r:id="R406edf840cc94660"/>
+    <p:sldId xmlns:r="http://schemas.openxmlformats.org/officeDocument/2006/relationships" id="269" r:id="R9e508529d50440db"/>
+    <p:sldId xmlns:r="http://schemas.openxmlformats.org/officeDocument/2006/relationships" id="270" r:id="Rdd3eead231f74926"/>
+    <p:sldId xmlns:r="http://schemas.openxmlformats.org/officeDocument/2006/relationships" id="271" r:id="R4043fc2be45f4768"/>
+    <p:sldId xmlns:r="http://schemas.openxmlformats.org/officeDocument/2006/relationships" id="272" r:id="R16ca284b90e5405b"/>
   </p:sldIdLst>
   <p:sldSz cx="12192000" cy="6858000"/>
   <p:notesSz cx="6858000" cy="9144000"/>
   <p:embeddedFontLst>
     <p:embeddedFont>
       <p:font typeface="OpenAI Sans"/>
-      <p:regular xmlns:r="http://schemas.openxmlformats.org/officeDocument/2006/relationships" r:id="Rbbf9ba06dc324101"/>
-      <p:bold xmlns:r="http://schemas.openxmlformats.org/officeDocument/2006/relationships" r:id="Ra0e542b09be34afc"/>
-      <p:italic xmlns:r="http://schemas.openxmlformats.org/officeDocument/2006/relationships" r:id="Rdde150fb060d420d"/>
-      <p:boldItalic xmlns:r="http://schemas.openxmlformats.org/officeDocument/2006/relationships" r:id="Rce2b6cc941204ff0"/>
+      <p:regular xmlns:r="http://schemas.openxmlformats.org/officeDocument/2006/relationships" r:id="R5d19dffdf7664c08"/>
+      <p:bold xmlns:r="http://schemas.openxmlformats.org/officeDocument/2006/relationships" r:id="Rf35f1a2f1cda4dcd"/>
+      <p:italic xmlns:r="http://schemas.openxmlformats.org/officeDocument/2006/relationships" r:id="Raa23d78dd89946d3"/>
+      <p:boldItalic xmlns:r="http://schemas.openxmlformats.org/officeDocument/2006/relationships" r:id="R70feb308b6684587"/>
     </p:embeddedFont>
   </p:embeddedFontLst>
   <p:defaultTextStyle>
@@ -1486,7 +1486,7 @@
               <a:buNone/>
             </a:pPr>
             <a:r>
-              <a:t>The remote path ~/ is the home directory. If the archive is already on iLab, skip scp. tar xvf handles a .tar archive; use the course's exact filename and archive format. These are example names, not a course download URL. Source for the student tar archive: supplied instructor README.</a:t>
+              <a:t>The TA states that download instructions will appear on the course markup; use those instructions rather than assuming a local download and scp workflow. Do not invent a wget URL. tar xvf handles a .tar archive; use the course's exact filename and archive format. These are example names. Source for the student tar archive: supplied instructor README.</a:t>
             </a:r>
             <a:endParaRPr/>
           </a:p>
@@ -3690,14 +3690,14 @@
   </p:cSld>
   <p:clrMap bg1="dk1" tx1="lt1" bg2="dk2" tx2="lt2" accent1="accent1" accent2="accent2" accent3="accent3" accent4="accent4" accent5="accent5" accent6="accent6" hlink="hlink" folHlink="folHlink"/>
   <p:sldLayoutIdLst>
-    <p:sldLayoutId xmlns:r="http://schemas.openxmlformats.org/officeDocument/2006/relationships" id="2147483649" r:id="R672d6585b3f64b72"/>
-    <p:sldLayoutId xmlns:r="http://schemas.openxmlformats.org/officeDocument/2006/relationships" id="2147483650" r:id="R2a318a0ca65c4dad"/>
-    <p:sldLayoutId xmlns:r="http://schemas.openxmlformats.org/officeDocument/2006/relationships" id="2147483651" r:id="R21db0614fc9a447a"/>
-    <p:sldLayoutId xmlns:r="http://schemas.openxmlformats.org/officeDocument/2006/relationships" id="2147483652" r:id="R803abbf75d0a4c22"/>
-    <p:sldLayoutId xmlns:r="http://schemas.openxmlformats.org/officeDocument/2006/relationships" id="2147483653" r:id="Rdb7445cf2e67453a"/>
-    <p:sldLayoutId xmlns:r="http://schemas.openxmlformats.org/officeDocument/2006/relationships" id="2147483654" r:id="Rb825a04fe87f4e33"/>
-    <p:sldLayoutId xmlns:r="http://schemas.openxmlformats.org/officeDocument/2006/relationships" id="2147483655" r:id="R9026b0b128f2420b"/>
-    <p:sldLayoutId xmlns:r="http://schemas.openxmlformats.org/officeDocument/2006/relationships" id="2147483656" r:id="Rac0445518e8c40b6"/>
+    <p:sldLayoutId xmlns:r="http://schemas.openxmlformats.org/officeDocument/2006/relationships" id="2147483649" r:id="R98823e38da414913"/>
+    <p:sldLayoutId xmlns:r="http://schemas.openxmlformats.org/officeDocument/2006/relationships" id="2147483650" r:id="R6542dbbc8d0347a4"/>
+    <p:sldLayoutId xmlns:r="http://schemas.openxmlformats.org/officeDocument/2006/relationships" id="2147483651" r:id="Rdb380e781bc34042"/>
+    <p:sldLayoutId xmlns:r="http://schemas.openxmlformats.org/officeDocument/2006/relationships" id="2147483652" r:id="Rfcf7d14712cb4c93"/>
+    <p:sldLayoutId xmlns:r="http://schemas.openxmlformats.org/officeDocument/2006/relationships" id="2147483653" r:id="R0d12cebb5018409a"/>
+    <p:sldLayoutId xmlns:r="http://schemas.openxmlformats.org/officeDocument/2006/relationships" id="2147483654" r:id="R394d4f0c381a4ff3"/>
+    <p:sldLayoutId xmlns:r="http://schemas.openxmlformats.org/officeDocument/2006/relationships" id="2147483655" r:id="R1f24e2eea756429e"/>
+    <p:sldLayoutId xmlns:r="http://schemas.openxmlformats.org/officeDocument/2006/relationships" id="2147483656" r:id="R6f67188e369345e6"/>
   </p:sldLayoutIdLst>
   <p:hf hdr="0" dt="0"/>
   <p:txStyles>
@@ -6161,7 +6161,7 @@
           <p:cNvPr id="534" name="Takeaway">
             <a:extLst xmlns:a="http://schemas.openxmlformats.org/drawingml/2006/main">
               <a:ext uri="{FF2B5EF4-FFF2-40B4-BE49-F238E27FC236}">
-                <a16:creationId xmlns:a16="http://schemas.microsoft.com/office/drawing/2014/main" id="{65EDB234-9521-4D92-A35D-BA4A4FF2E9D4}"/>
+                <a16:creationId xmlns:a16="http://schemas.microsoft.com/office/drawing/2014/main" id="{AAB3CE6D-E621-49F3-A9E7-04E228BC6054}"/>
               </a:ext>
             </a:extLst>
           </p:cNvPr>
@@ -7250,7 +7250,7 @@
           <p:cNvPr id="534" name="Takeaway">
             <a:extLst xmlns:a="http://schemas.openxmlformats.org/drawingml/2006/main">
               <a:ext uri="{FF2B5EF4-FFF2-40B4-BE49-F238E27FC236}">
-                <a16:creationId xmlns:a16="http://schemas.microsoft.com/office/drawing/2014/main" id="{5BE4B346-B518-43EB-9388-D2C5D3893AFB}"/>
+                <a16:creationId xmlns:a16="http://schemas.microsoft.com/office/drawing/2014/main" id="{C271EF40-F329-4862-8F9D-D70C0EF840F3}"/>
               </a:ext>
             </a:extLst>
           </p:cNvPr>
@@ -8406,7 +8406,7 @@
           <p:cNvPr id="534" name="Takeaway">
             <a:extLst xmlns:a="http://schemas.openxmlformats.org/drawingml/2006/main">
               <a:ext uri="{FF2B5EF4-FFF2-40B4-BE49-F238E27FC236}">
-                <a16:creationId xmlns:a16="http://schemas.microsoft.com/office/drawing/2014/main" id="{BA964AC5-1B0C-4D4A-A379-AA19E12D9E90}"/>
+                <a16:creationId xmlns:a16="http://schemas.microsoft.com/office/drawing/2014/main" id="{D8AED4A9-1C73-4454-828C-B2BC6FA8B061}"/>
               </a:ext>
             </a:extLst>
           </p:cNvPr>
@@ -9496,7 +9496,7 @@
           <p:cNvPr id="534" name="Takeaway">
             <a:extLst xmlns:a="http://schemas.openxmlformats.org/drawingml/2006/main">
               <a:ext uri="{FF2B5EF4-FFF2-40B4-BE49-F238E27FC236}">
-                <a16:creationId xmlns:a16="http://schemas.microsoft.com/office/drawing/2014/main" id="{94771DC6-1509-4CB5-A751-73FD318940E8}"/>
+                <a16:creationId xmlns:a16="http://schemas.microsoft.com/office/drawing/2014/main" id="{2D7CA752-A039-47A5-82F4-57EAA013361B}"/>
               </a:ext>
             </a:extLst>
           </p:cNvPr>
@@ -10586,7 +10586,7 @@
           <p:cNvPr id="534" name="Takeaway">
             <a:extLst xmlns:a="http://schemas.openxmlformats.org/drawingml/2006/main">
               <a:ext uri="{FF2B5EF4-FFF2-40B4-BE49-F238E27FC236}">
-                <a16:creationId xmlns:a16="http://schemas.microsoft.com/office/drawing/2014/main" id="{7F9659FC-D534-4A9D-8CFE-8F3675904373}"/>
+                <a16:creationId xmlns:a16="http://schemas.microsoft.com/office/drawing/2014/main" id="{A8C40A3E-506F-46F1-B1BF-ABB874D3FA56}"/>
               </a:ext>
             </a:extLst>
           </p:cNvPr>
@@ -11676,7 +11676,7 @@
           <p:cNvPr id="534" name="Takeaway">
             <a:extLst xmlns:a="http://schemas.openxmlformats.org/drawingml/2006/main">
               <a:ext uri="{FF2B5EF4-FFF2-40B4-BE49-F238E27FC236}">
-                <a16:creationId xmlns:a16="http://schemas.microsoft.com/office/drawing/2014/main" id="{234B609B-B848-4C71-B056-A0A5DCB5B07A}"/>
+                <a16:creationId xmlns:a16="http://schemas.microsoft.com/office/drawing/2014/main" id="{DCC8A476-25A2-4001-852E-5E0C297EDBC2}"/>
               </a:ext>
             </a:extLst>
           </p:cNvPr>
@@ -12766,7 +12766,7 @@
           <p:cNvPr id="534" name="Takeaway">
             <a:extLst xmlns:a="http://schemas.openxmlformats.org/drawingml/2006/main">
               <a:ext uri="{FF2B5EF4-FFF2-40B4-BE49-F238E27FC236}">
-                <a16:creationId xmlns:a16="http://schemas.microsoft.com/office/drawing/2014/main" id="{EE1D1BF0-87D2-4171-AE69-0A0C4633BEAE}"/>
+                <a16:creationId xmlns:a16="http://schemas.microsoft.com/office/drawing/2014/main" id="{DC11381B-8210-4AE0-A0D3-4FD7F554D230}"/>
               </a:ext>
             </a:extLst>
           </p:cNvPr>
@@ -13889,7 +13889,7 @@
           <p:cNvPr id="534" name="Takeaway">
             <a:extLst xmlns:a="http://schemas.openxmlformats.org/drawingml/2006/main">
               <a:ext uri="{FF2B5EF4-FFF2-40B4-BE49-F238E27FC236}">
-                <a16:creationId xmlns:a16="http://schemas.microsoft.com/office/drawing/2014/main" id="{0465710C-C6A9-43BC-A413-EDA4DC9276BD}"/>
+                <a16:creationId xmlns:a16="http://schemas.microsoft.com/office/drawing/2014/main" id="{192D27CF-D224-4A85-AFC9-2795210040DB}"/>
               </a:ext>
             </a:extLst>
           </p:cNvPr>
@@ -14912,7 +14912,7 @@
           <p:cNvPr id="534" name="Takeaway">
             <a:extLst xmlns:a="http://schemas.openxmlformats.org/drawingml/2006/main">
               <a:ext uri="{FF2B5EF4-FFF2-40B4-BE49-F238E27FC236}">
-                <a16:creationId xmlns:a16="http://schemas.microsoft.com/office/drawing/2014/main" id="{3F0F1B77-9CA3-49D5-82D2-A90457E08DDE}"/>
+                <a16:creationId xmlns:a16="http://schemas.microsoft.com/office/drawing/2014/main" id="{46A1926D-C2E0-4039-8050-B497FA53711C}"/>
               </a:ext>
             </a:extLst>
           </p:cNvPr>
@@ -16997,7 +16997,7 @@
           <p:cNvPr id="534" name="Takeaway">
             <a:extLst xmlns:a="http://schemas.openxmlformats.org/drawingml/2006/main">
               <a:ext uri="{FF2B5EF4-FFF2-40B4-BE49-F238E27FC236}">
-                <a16:creationId xmlns:a16="http://schemas.microsoft.com/office/drawing/2014/main" id="{89D15BEE-537F-4115-86F8-12EC7A0198E3}"/>
+                <a16:creationId xmlns:a16="http://schemas.microsoft.com/office/drawing/2014/main" id="{B8A9EEAC-A864-48AC-B26F-1BFBBFA9C5EF}"/>
               </a:ext>
             </a:extLst>
           </p:cNvPr>
@@ -17542,7 +17542,7 @@
                 <a:ea typeface="Arial"/>
                 <a:cs typeface="Arial"/>
               </a:rPr>
-              <a:t>Download your assigned archive using the course link. Copy it to iLab if you downloaded it locally.</a:t>
+              <a:t>Download instructions for your assigned bomb will be on the course markup.</a:t>
             </a:r>
           </a:p>
           <a:p xmlns:a="http://schemas.openxmlformats.org/drawingml/2006/main">
@@ -17592,7 +17592,57 @@
                 <a:ea typeface="Arial"/>
                 <a:cs typeface="Arial"/>
               </a:rPr>
-              <a:t>Replace N with your bomb number and YOUR_NETID with your NetID. Use the actual archive name.</a:t>
+              <a:t>Follow those instructions on iLab, then extract the archive and open your bomb in GDB.</a:t>
+            </a:r>
+          </a:p>
+          <a:p xmlns:a="http://schemas.openxmlformats.org/drawingml/2006/main">
+            <a:pPr marL="0" indent="0">
+              <a:lnSpc>
+                <a:spcPct val="112000"/>
+              </a:lnSpc>
+              <a:spcBef>
+                <a:spcPts val="0"/>
+              </a:spcBef>
+              <a:spcAft>
+                <a:spcPts val="0"/>
+              </a:spcAft>
+              <a:buNone/>
+            </a:pPr>
+            <a:r>
+              <a:t/>
+            </a:r>
+          </a:p>
+          <a:p xmlns:a="http://schemas.openxmlformats.org/drawingml/2006/main">
+            <a:pPr marL="0" indent="0">
+              <a:lnSpc>
+                <a:spcPct val="112000"/>
+              </a:lnSpc>
+              <a:spcBef>
+                <a:spcPts val="0"/>
+              </a:spcBef>
+              <a:spcAft>
+                <a:spcPts val="0"/>
+              </a:spcAft>
+              <a:buNone/>
+              <a:defRPr sz="1875">
+                <a:solidFill>
+                  <a:srgbClr val="FFFFFF"/>
+                </a:solidFill>
+                <a:latin typeface="Arial"/>
+                <a:ea typeface="Arial"/>
+                <a:cs typeface="Arial"/>
+              </a:defRPr>
+            </a:pPr>
+            <a:r>
+              <a:rPr sz="1875">
+                <a:solidFill>
+                  <a:srgbClr val="FFFFFF"/>
+                </a:solidFill>
+                <a:latin typeface="Arial"/>
+                <a:ea typeface="Arial"/>
+                <a:cs typeface="Arial"/>
+              </a:rPr>
+              <a:t>Replace N with your bomb number. Use the actual archive and folder names.</a:t>
             </a:r>
           </a:p>
         </p:txBody>
@@ -17626,7 +17676,7 @@
           </a:bodyPr>
           <a:lstStyle xmlns:a="http://schemas.openxmlformats.org/drawingml/2006/main">
             <a:defPPr>
-              <a:defRPr sz="1500">
+              <a:defRPr sz="1800">
                 <a:solidFill>
                   <a:srgbClr val="FFFFFF"/>
                 </a:solidFill>
@@ -17810,7 +17860,7 @@
                 <a:spcPts val="0"/>
               </a:spcAft>
               <a:buNone/>
-              <a:defRPr sz="1500">
+              <a:defRPr sz="1800">
                 <a:solidFill>
                   <a:srgbClr val="FFFFFF"/>
                 </a:solidFill>
@@ -17820,7 +17870,7 @@
               </a:defRPr>
             </a:pPr>
             <a:r>
-              <a:rPr sz="1500">
+              <a:rPr sz="1800">
                 <a:solidFill>
                   <a:srgbClr val="FFFFFF"/>
                 </a:solidFill>
@@ -17828,22 +17878,22 @@
                 <a:ea typeface="Consolas"/>
                 <a:cs typeface="Consolas"/>
               </a:rPr>
-              <a:t># Local terminal, in Downloads</a:t>
-            </a:r>
-          </a:p>
-          <a:p xmlns:a="http://schemas.openxmlformats.org/drawingml/2006/main">
-            <a:pPr marL="0" indent="0">
-              <a:lnSpc>
-                <a:spcPct val="112000"/>
-              </a:lnSpc>
-              <a:spcBef>
-                <a:spcPts val="0"/>
-              </a:spcBef>
-              <a:spcAft>
-                <a:spcPts val="0"/>
-              </a:spcAft>
-              <a:buNone/>
-              <a:defRPr sz="1500">
+              <a:t># On iLab, after downloading</a:t>
+            </a:r>
+          </a:p>
+          <a:p xmlns:a="http://schemas.openxmlformats.org/drawingml/2006/main">
+            <a:pPr marL="0" indent="0">
+              <a:lnSpc>
+                <a:spcPct val="112000"/>
+              </a:lnSpc>
+              <a:spcBef>
+                <a:spcPts val="0"/>
+              </a:spcBef>
+              <a:spcAft>
+                <a:spcPts val="0"/>
+              </a:spcAft>
+              <a:buNone/>
+              <a:defRPr sz="1800">
                 <a:solidFill>
                   <a:srgbClr val="FFFFFF"/>
                 </a:solidFill>
@@ -17853,123 +17903,7 @@
               </a:defRPr>
             </a:pPr>
             <a:r>
-              <a:rPr sz="1500">
-                <a:solidFill>
-                  <a:srgbClr val="FFFFFF"/>
-                </a:solidFill>
-                <a:latin typeface="Consolas"/>
-                <a:ea typeface="Consolas"/>
-                <a:cs typeface="Consolas"/>
-              </a:rPr>
-              <a:t>scp bombN.tar YOUR_NETID@ilab.cs.rutgers.edu:~/</a:t>
-            </a:r>
-          </a:p>
-          <a:p xmlns:a="http://schemas.openxmlformats.org/drawingml/2006/main">
-            <a:pPr marL="0" indent="0">
-              <a:lnSpc>
-                <a:spcPct val="112000"/>
-              </a:lnSpc>
-              <a:spcBef>
-                <a:spcPts val="0"/>
-              </a:spcBef>
-              <a:spcAft>
-                <a:spcPts val="0"/>
-              </a:spcAft>
-              <a:buNone/>
-              <a:defRPr sz="1500">
-                <a:solidFill>
-                  <a:srgbClr val="FFFFFF"/>
-                </a:solidFill>
-                <a:latin typeface="Consolas"/>
-                <a:ea typeface="Consolas"/>
-                <a:cs typeface="Consolas"/>
-              </a:defRPr>
-            </a:pPr>
-            <a:r>
-              <a:rPr sz="1500">
-                <a:solidFill>
-                  <a:srgbClr val="FFFFFF"/>
-                </a:solidFill>
-                <a:latin typeface="Consolas"/>
-                <a:ea typeface="Consolas"/>
-                <a:cs typeface="Consolas"/>
-              </a:rPr>
-              <a:t>ssh YOUR_NETID@ilab.cs.rutgers.edu</a:t>
-            </a:r>
-          </a:p>
-          <a:p xmlns:a="http://schemas.openxmlformats.org/drawingml/2006/main">
-            <a:pPr marL="0" indent="0">
-              <a:lnSpc>
-                <a:spcPct val="112000"/>
-              </a:lnSpc>
-              <a:spcBef>
-                <a:spcPts val="0"/>
-              </a:spcBef>
-              <a:spcAft>
-                <a:spcPts val="0"/>
-              </a:spcAft>
-              <a:buNone/>
-            </a:pPr>
-            <a:r>
-              <a:t/>
-            </a:r>
-          </a:p>
-          <a:p xmlns:a="http://schemas.openxmlformats.org/drawingml/2006/main">
-            <a:pPr marL="0" indent="0">
-              <a:lnSpc>
-                <a:spcPct val="112000"/>
-              </a:lnSpc>
-              <a:spcBef>
-                <a:spcPts val="0"/>
-              </a:spcBef>
-              <a:spcAft>
-                <a:spcPts val="0"/>
-              </a:spcAft>
-              <a:buNone/>
-              <a:defRPr sz="1500">
-                <a:solidFill>
-                  <a:srgbClr val="FFFFFF"/>
-                </a:solidFill>
-                <a:latin typeface="Consolas"/>
-                <a:ea typeface="Consolas"/>
-                <a:cs typeface="Consolas"/>
-              </a:defRPr>
-            </a:pPr>
-            <a:r>
-              <a:rPr sz="1500">
-                <a:solidFill>
-                  <a:srgbClr val="FFFFFF"/>
-                </a:solidFill>
-                <a:latin typeface="Consolas"/>
-                <a:ea typeface="Consolas"/>
-                <a:cs typeface="Consolas"/>
-              </a:rPr>
-              <a:t># Now on iLab</a:t>
-            </a:r>
-          </a:p>
-          <a:p xmlns:a="http://schemas.openxmlformats.org/drawingml/2006/main">
-            <a:pPr marL="0" indent="0">
-              <a:lnSpc>
-                <a:spcPct val="112000"/>
-              </a:lnSpc>
-              <a:spcBef>
-                <a:spcPts val="0"/>
-              </a:spcBef>
-              <a:spcAft>
-                <a:spcPts val="0"/>
-              </a:spcAft>
-              <a:buNone/>
-              <a:defRPr sz="1500">
-                <a:solidFill>
-                  <a:srgbClr val="FFFFFF"/>
-                </a:solidFill>
-                <a:latin typeface="Consolas"/>
-                <a:ea typeface="Consolas"/>
-                <a:cs typeface="Consolas"/>
-              </a:defRPr>
-            </a:pPr>
-            <a:r>
-              <a:rPr sz="1500">
+              <a:rPr sz="1800">
                 <a:solidFill>
                   <a:srgbClr val="FFFFFF"/>
                 </a:solidFill>
@@ -17992,7 +17926,7 @@
                 <a:spcPts val="0"/>
               </a:spcAft>
               <a:buNone/>
-              <a:defRPr sz="1500">
+              <a:defRPr sz="1800">
                 <a:solidFill>
                   <a:srgbClr val="FFFFFF"/>
                 </a:solidFill>
@@ -18002,7 +17936,7 @@
               </a:defRPr>
             </a:pPr>
             <a:r>
-              <a:rPr sz="1500">
+              <a:rPr sz="1800">
                 <a:solidFill>
                   <a:srgbClr val="FFFFFF"/>
                 </a:solidFill>
@@ -18025,7 +17959,7 @@
                 <a:spcPts val="0"/>
               </a:spcAft>
               <a:buNone/>
-              <a:defRPr sz="1500">
+              <a:defRPr sz="1800">
                 <a:solidFill>
                   <a:srgbClr val="FFFFFF"/>
                 </a:solidFill>
@@ -18035,7 +17969,7 @@
               </a:defRPr>
             </a:pPr>
             <a:r>
-              <a:rPr sz="1500">
+              <a:rPr sz="1800">
                 <a:solidFill>
                   <a:srgbClr val="FFFFFF"/>
                 </a:solidFill>
@@ -18058,7 +17992,7 @@
                 <a:spcPts val="0"/>
               </a:spcAft>
               <a:buNone/>
-              <a:defRPr sz="1500">
+              <a:defRPr sz="1800">
                 <a:solidFill>
                   <a:srgbClr val="FFFFFF"/>
                 </a:solidFill>
@@ -18068,7 +18002,7 @@
               </a:defRPr>
             </a:pPr>
             <a:r>
-              <a:rPr sz="1500">
+              <a:rPr sz="1800">
                 <a:solidFill>
                   <a:srgbClr val="FFFFFF"/>
                 </a:solidFill>
@@ -18091,7 +18025,7 @@
                 <a:spcPts val="0"/>
               </a:spcAft>
               <a:buNone/>
-              <a:defRPr sz="1500">
+              <a:defRPr sz="1800">
                 <a:solidFill>
                   <a:srgbClr val="FFFFFF"/>
                 </a:solidFill>
@@ -18101,7 +18035,7 @@
               </a:defRPr>
             </a:pPr>
             <a:r>
-              <a:rPr sz="1500">
+              <a:rPr sz="1800">
                 <a:solidFill>
                   <a:srgbClr val="FFFFFF"/>
                 </a:solidFill>
@@ -18119,7 +18053,7 @@
           <p:cNvPr id="534" name="Takeaway">
             <a:extLst xmlns:a="http://schemas.openxmlformats.org/drawingml/2006/main">
               <a:ext uri="{FF2B5EF4-FFF2-40B4-BE49-F238E27FC236}">
-                <a16:creationId xmlns:a16="http://schemas.microsoft.com/office/drawing/2014/main" id="{54FDD11F-3FAD-4351-91D1-E448A0342E89}"/>
+                <a16:creationId xmlns:a16="http://schemas.microsoft.com/office/drawing/2014/main" id="{B1A677F5-A19B-4146-B274-87442261AA12}"/>
               </a:ext>
             </a:extLst>
           </p:cNvPr>
@@ -18187,7 +18121,7 @@
                 <a:ea typeface="Arial"/>
                 <a:cs typeface="Arial"/>
               </a:rPr>
-              <a:t>The shell runs scp, tar, and gdb. The (gdb) prompt accepts debugger commands.</a:t>
+              <a:t>The shell runs tar and gdb. The (gdb) prompt accepts debugger commands.</a:t>
             </a:r>
           </a:p>
         </p:txBody>
@@ -19192,7 +19126,7 @@
           <p:cNvPr id="534" name="Takeaway">
             <a:extLst xmlns:a="http://schemas.openxmlformats.org/drawingml/2006/main">
               <a:ext uri="{FF2B5EF4-FFF2-40B4-BE49-F238E27FC236}">
-                <a16:creationId xmlns:a16="http://schemas.microsoft.com/office/drawing/2014/main" id="{461CDB11-042C-4A1B-AB18-BB20A686A4BD}"/>
+                <a16:creationId xmlns:a16="http://schemas.microsoft.com/office/drawing/2014/main" id="{047BE8B3-2108-45A9-9F0A-09E92BF7729C}"/>
               </a:ext>
             </a:extLst>
           </p:cNvPr>
@@ -20298,7 +20232,7 @@
           <p:cNvPr id="534" name="Takeaway">
             <a:extLst xmlns:a="http://schemas.openxmlformats.org/drawingml/2006/main">
               <a:ext uri="{FF2B5EF4-FFF2-40B4-BE49-F238E27FC236}">
-                <a16:creationId xmlns:a16="http://schemas.microsoft.com/office/drawing/2014/main" id="{F8145363-33C2-4E07-A23F-FACC283DFF35}"/>
+                <a16:creationId xmlns:a16="http://schemas.microsoft.com/office/drawing/2014/main" id="{39B3855E-5DC1-4EAC-A7C8-E2D3EB8FD466}"/>
               </a:ext>
             </a:extLst>
           </p:cNvPr>
@@ -21404,7 +21338,7 @@
           <p:cNvPr id="534" name="Takeaway">
             <a:extLst xmlns:a="http://schemas.openxmlformats.org/drawingml/2006/main">
               <a:ext uri="{FF2B5EF4-FFF2-40B4-BE49-F238E27FC236}">
-                <a16:creationId xmlns:a16="http://schemas.microsoft.com/office/drawing/2014/main" id="{F0D6B8FB-DB44-4AEE-9F99-D5F79AEE0C2C}"/>
+                <a16:creationId xmlns:a16="http://schemas.microsoft.com/office/drawing/2014/main" id="{C5AA301E-04CA-402D-A0F1-443E4C549CCF}"/>
               </a:ext>
             </a:extLst>
           </p:cNvPr>
@@ -22527,7 +22461,7 @@
           <p:cNvPr id="534" name="Takeaway">
             <a:extLst xmlns:a="http://schemas.openxmlformats.org/drawingml/2006/main">
               <a:ext uri="{FF2B5EF4-FFF2-40B4-BE49-F238E27FC236}">
-                <a16:creationId xmlns:a16="http://schemas.microsoft.com/office/drawing/2014/main" id="{0D813056-A772-40CA-9E85-09BFB32D33C1}"/>
+                <a16:creationId xmlns:a16="http://schemas.microsoft.com/office/drawing/2014/main" id="{3B6BDD52-036F-4D2B-9C10-B6DA69746DD8}"/>
               </a:ext>
             </a:extLst>
           </p:cNvPr>

</xml_diff>

<commit_message>
Add assembly walkthroughs to Bomb Lab recitation
</commit_message>
<xml_diff>
--- a/public/presentations/CS211_Recitation_5.pptx
+++ b/public/presentations/CS211_Recitation_5.pptx
@@ -2,39 +2,38 @@
 <file path=ppt/presentation.xml><?xml version="1.0" encoding="utf-8"?>
 <p:presentation xmlns:p="http://schemas.openxmlformats.org/presentationml/2006/main" embedTrueTypeFonts="1" saveSubsetFonts="0">
   <p:sldMasterIdLst>
-    <p:sldMasterId xmlns:r="http://schemas.openxmlformats.org/officeDocument/2006/relationships" id="2147483648" r:id="Rce93c849cc9b431f"/>
+    <p:sldMasterId xmlns:r="http://schemas.openxmlformats.org/officeDocument/2006/relationships" id="2147483648" r:id="R380236326d454a17"/>
   </p:sldMasterIdLst>
   <p:notesMasterIdLst>
-    <p:notesMasterId xmlns:r="http://schemas.openxmlformats.org/officeDocument/2006/relationships" r:id="R2a483e93cc4541a2"/>
+    <p:notesMasterId xmlns:r="http://schemas.openxmlformats.org/officeDocument/2006/relationships" r:id="R04eaa965632d46c6"/>
   </p:notesMasterIdLst>
   <p:sldIdLst>
-    <p:sldId xmlns:r="http://schemas.openxmlformats.org/officeDocument/2006/relationships" id="256" r:id="R4aa2db8587d04ebb"/>
-    <p:sldId xmlns:r="http://schemas.openxmlformats.org/officeDocument/2006/relationships" id="257" r:id="Ra4678641c3da423f"/>
-    <p:sldId xmlns:r="http://schemas.openxmlformats.org/officeDocument/2006/relationships" id="258" r:id="Rc2801329098a4f14"/>
-    <p:sldId xmlns:r="http://schemas.openxmlformats.org/officeDocument/2006/relationships" id="259" r:id="Rc3502b0cc1714a0a"/>
-    <p:sldId xmlns:r="http://schemas.openxmlformats.org/officeDocument/2006/relationships" id="260" r:id="Racb650f764eb485d"/>
-    <p:sldId xmlns:r="http://schemas.openxmlformats.org/officeDocument/2006/relationships" id="261" r:id="R71d7fc3f904849d7"/>
-    <p:sldId xmlns:r="http://schemas.openxmlformats.org/officeDocument/2006/relationships" id="262" r:id="R2fa89800fd704d90"/>
-    <p:sldId xmlns:r="http://schemas.openxmlformats.org/officeDocument/2006/relationships" id="263" r:id="R7208713a7bec454e"/>
-    <p:sldId xmlns:r="http://schemas.openxmlformats.org/officeDocument/2006/relationships" id="264" r:id="Rd3835181b7884cfd"/>
-    <p:sldId xmlns:r="http://schemas.openxmlformats.org/officeDocument/2006/relationships" id="265" r:id="Rfbf4056c195b4610"/>
-    <p:sldId xmlns:r="http://schemas.openxmlformats.org/officeDocument/2006/relationships" id="266" r:id="R494fdd76537b4d72"/>
-    <p:sldId xmlns:r="http://schemas.openxmlformats.org/officeDocument/2006/relationships" id="267" r:id="Raa53aebcba614e40"/>
-    <p:sldId xmlns:r="http://schemas.openxmlformats.org/officeDocument/2006/relationships" id="268" r:id="R406edf840cc94660"/>
-    <p:sldId xmlns:r="http://schemas.openxmlformats.org/officeDocument/2006/relationships" id="269" r:id="R9e508529d50440db"/>
-    <p:sldId xmlns:r="http://schemas.openxmlformats.org/officeDocument/2006/relationships" id="270" r:id="Rdd3eead231f74926"/>
-    <p:sldId xmlns:r="http://schemas.openxmlformats.org/officeDocument/2006/relationships" id="271" r:id="R4043fc2be45f4768"/>
-    <p:sldId xmlns:r="http://schemas.openxmlformats.org/officeDocument/2006/relationships" id="272" r:id="R16ca284b90e5405b"/>
+    <p:sldId xmlns:r="http://schemas.openxmlformats.org/officeDocument/2006/relationships" id="256" r:id="R44f9d355782546cb"/>
+    <p:sldId xmlns:r="http://schemas.openxmlformats.org/officeDocument/2006/relationships" id="257" r:id="R44fc2cecd4be4b26"/>
+    <p:sldId xmlns:r="http://schemas.openxmlformats.org/officeDocument/2006/relationships" id="258" r:id="R37f01edf4740497d"/>
+    <p:sldId xmlns:r="http://schemas.openxmlformats.org/officeDocument/2006/relationships" id="259" r:id="R22581dbdaa2a4fc2"/>
+    <p:sldId xmlns:r="http://schemas.openxmlformats.org/officeDocument/2006/relationships" id="260" r:id="R3badfffe070f4ec9"/>
+    <p:sldId xmlns:r="http://schemas.openxmlformats.org/officeDocument/2006/relationships" id="261" r:id="R6cadd6088005434f"/>
+    <p:sldId xmlns:r="http://schemas.openxmlformats.org/officeDocument/2006/relationships" id="262" r:id="R9f35b00384f34c50"/>
+    <p:sldId xmlns:r="http://schemas.openxmlformats.org/officeDocument/2006/relationships" id="263" r:id="R43aeb3865a394ab0"/>
+    <p:sldId xmlns:r="http://schemas.openxmlformats.org/officeDocument/2006/relationships" id="264" r:id="R4364cd0b49ef4554"/>
+    <p:sldId xmlns:r="http://schemas.openxmlformats.org/officeDocument/2006/relationships" id="265" r:id="R38ace93525be4ca8"/>
+    <p:sldId xmlns:r="http://schemas.openxmlformats.org/officeDocument/2006/relationships" id="266" r:id="Rc41d29da64be4ccd"/>
+    <p:sldId xmlns:r="http://schemas.openxmlformats.org/officeDocument/2006/relationships" id="267" r:id="Raa3ba324c9644168"/>
+    <p:sldId xmlns:r="http://schemas.openxmlformats.org/officeDocument/2006/relationships" id="268" r:id="Rc5e5c1165cf44e7e"/>
+    <p:sldId xmlns:r="http://schemas.openxmlformats.org/officeDocument/2006/relationships" id="269" r:id="R9096813e7fb340b6"/>
+    <p:sldId xmlns:r="http://schemas.openxmlformats.org/officeDocument/2006/relationships" id="270" r:id="Rf74ea3026fcf49b9"/>
+    <p:sldId xmlns:r="http://schemas.openxmlformats.org/officeDocument/2006/relationships" id="271" r:id="Rc2a4fde253024657"/>
   </p:sldIdLst>
   <p:sldSz cx="12192000" cy="6858000"/>
   <p:notesSz cx="6858000" cy="9144000"/>
   <p:embeddedFontLst>
     <p:embeddedFont>
       <p:font typeface="OpenAI Sans"/>
-      <p:regular xmlns:r="http://schemas.openxmlformats.org/officeDocument/2006/relationships" r:id="R5d19dffdf7664c08"/>
-      <p:bold xmlns:r="http://schemas.openxmlformats.org/officeDocument/2006/relationships" r:id="Rf35f1a2f1cda4dcd"/>
-      <p:italic xmlns:r="http://schemas.openxmlformats.org/officeDocument/2006/relationships" r:id="Raa23d78dd89946d3"/>
-      <p:boldItalic xmlns:r="http://schemas.openxmlformats.org/officeDocument/2006/relationships" r:id="R70feb308b6684587"/>
+      <p:regular xmlns:r="http://schemas.openxmlformats.org/officeDocument/2006/relationships" r:id="R32d25cb964094149"/>
+      <p:bold xmlns:r="http://schemas.openxmlformats.org/officeDocument/2006/relationships" r:id="R2831515c73ae4274"/>
+      <p:italic xmlns:r="http://schemas.openxmlformats.org/officeDocument/2006/relationships" r:id="R1010ce9c6b3e4382"/>
+      <p:boldItalic xmlns:r="http://schemas.openxmlformats.org/officeDocument/2006/relationships" r:id="Rfd32b32f48f04368"/>
     </p:embeddedFont>
   </p:embeddedFontLst>
   <p:defaultTextStyle>
@@ -526,7 +525,7 @@
               <a:buNone/>
             </a:pPr>
             <a:r>
-              <a:t>Use iLab for the live demonstration. Demonstrate debugging technique using the separate example.c exercise before inspecting a bomb.</a:t>
+              <a:t>Use iLab for the live demonstration. Walk through the toy loop and pointer examples before inspecting a bomb.</a:t>
             </a:r>
             <a:endParaRPr/>
           </a:p>
@@ -606,7 +605,7 @@
               <a:buNone/>
             </a:pPr>
             <a:r>
-              <a:t>Source: https://sourceware.org/gdb/current/onlinedocs/gdb.html/Continuing-and-Stepping.html . A breakpoint or signal can interrupt stepping. finish runs until the current function returns and can also execute a failure path, so it is not a safe substitute for understanding the function. Ctrl+C pauses a running program. kill terminates the inferior while keeping GDB open. run may ask whether to restart if a program is already active.</a:t>
+              <a:t>Sources: https://sourceware.org/gdb/current/onlinedocs/gdb.html/Memory.html and https://sourceware.org/gdb/current/onlinedocs/gdb.html/Registers.html . x/4dw: 4 units, decimal format, word units of 4 bytes. x/2gx: 2 units, 8-byte giant words, hexadecimal format. p/d displays the register as a signed integer according to its type. For parsed 32-bit results, p/d $eax can be more appropriate. On System V AMD64, integer and pointer arguments commonly begin in rdi and rsi, and integer return values use rax/eax. Only interpret arguments at the appropriate call boundary.</a:t>
             </a:r>
             <a:endParaRPr/>
           </a:p>
@@ -686,7 +685,7 @@
               <a:buNone/>
             </a:pPr>
             <a:r>
-              <a:t>Sources: https://sourceware.org/gdb/current/onlinedocs/gdb.html/Memory.html and https://sourceware.org/gdb/current/onlinedocs/gdb.html/Registers.html . x/4dw: 4 units, decimal format, word units of 4 bytes. x/2gx: 2 units, 8-byte giant words, hexadecimal format. p/d displays the register as a signed integer according to its type. For parsed 32-bit results, p/d $eax can be more appropriate. On System V AMD64, integer and pointer arguments commonly begin in rdi and rsi, and integer return values use rax/eax. Only interpret arguments at the appropriate call boundary.</a:t>
+              <a:t>Connect to the earlier house-address discussion: copying the address versus fetching the contents. lea is often used to form pointers to strings or stack slots before a helper call. x/gd reads an 8-byte value and formats it as signed decimal. Memory command reference: https://sourceware.org/gdb/current/onlinedocs/gdb.html/Memory.html .</a:t>
             </a:r>
             <a:endParaRPr/>
           </a:p>
@@ -766,7 +765,7 @@
               <a:buNone/>
             </a:pPr>
             <a:r>
-              <a:t>Connect to the earlier house-address discussion: copying the address versus fetching the contents. lea is often used to form pointers to strings or stack slots before a helper call. x/gd reads an 8-byte value and formats it as signed decimal. Memory command reference: https://sourceware.org/gdb/current/onlinedocs/gdb.html/Memory.html .</a:t>
+              <a:t>Use this as a method hint without associating any helper or input format with a specific phase. Inspect a format-string pointer at the relevant parsing call and inspect the return count afterward. cmp source,destination sets flags as if computing destination - source. jne follows unequal values. The spaces in a scanf-family format matter because %c alone does not skip whitespace. The format and constant here are invented for teaching and are not phase answers.</a:t>
             </a:r>
             <a:endParaRPr/>
           </a:p>
@@ -846,7 +845,7 @@
               <a:buNone/>
             </a:pPr>
             <a:r>
-              <a:t>Use this as a method hint without associating any helper or input format with a specific phase. Inspect a format-string pointer at the relevant parsing call and inspect the return count afterward. cmp source,destination sets flags as if computing destination - source. jne follows unequal values. The spaces in a scanf-family format matter because %c alone does not skip whitespace. The format and constant here are invented for teaching and are not phase answers.</a:t>
+              <a:t>Inspired by the loop structure in the supplied phase_2 screenshot, with different checks and no initial phase inputs. This is an excerpt rather than a complete function; any surrounding function must preserve callee-saved rbx. Board walkthrough: rbx begins at a[0], ecx is 1. eax becomes a[0] + 3; cmp compares a[1] against that value. jne goes to failure when they differ. addq $4 advances one 32-bit element, then ecx increments. The comparisons check a[1], a[2], and a[3]; ecx reaches 4 and exits. Use a toy array such as 10,13,16,19, then change the third element to illustrate the failing branch. Ask students to name the memory operands before explaining the relationship. This example is not the actual phase algorithm or a phase solution.</a:t>
             </a:r>
             <a:endParaRPr/>
           </a:p>
@@ -926,7 +925,7 @@
               <a:buNone/>
             </a:pPr>
             <a:r>
-              <a:t>Board activity: make a blank trace table and fill one iteration with the room. Look at the displacement and index expressions to distinguish dependencies on different earlier entries. Tables can contain values or code addresses, so inspect the instructions that consume each entry. General method hints only. Do not show private phase variants, constants, or recurrence sequences from the staff notes.</a:t>
+              <a:t>This is an invented helper, not bomb phase code. Under System V AMD64, the first pointer argument is in rdi and a 32-bit integer return value is in eax. The caller line is a separate excerpt; do not fall through into the helper. A toy node layout has a 32-bit data field at offset 0, padding at offset 4, and an 8-byte next pointer at offset 8. xor clears the sum. test checks for a null pointer before dereferencing. add reads the current node's data; mov reads the stored next address into rdi. Trace two nodes containing 5 and 9, with the second next pointer null: eax returns 14. Distinguish advancing through a stored link from adding a fixed stride to an array pointer. call saves a return address; ret uses it. No recursion, private ordering rule, or phase solution is shown.</a:t>
             </a:r>
             <a:endParaRPr/>
           </a:p>
@@ -1006,7 +1005,7 @@
               <a:buNone/>
             </a:pPr>
             <a:r>
-              <a:t>Offer this as a broad strategy for later phases. Do not identify any private algorithm, ordering direction, tree values, or hidden-phase trigger. Inspect comparisons to infer what a value means instead of assuming an index equals the stored data. bt can show the call chain when paused in recursion.</a:t>
+              <a:t>The standard CS:APP driver often accepts a filename and switches to interactive input when that file ends, while stdin redirection may terminate at EOF. Verify the supplied bomb.c instead of promising that behavior for every version. Do not include placeholders or guessed lines in a replay file. Source for input redirection and distinct deployment modes: supplied instructor README. GDB run syntax: https://sourceware.org/gdb/current/onlinedocs/gdb.html/Arguments.html and https://sourceware.org/gdb/current/onlinedocs/gdb.html/Input_002fOutput.html .</a:t>
             </a:r>
             <a:endParaRPr/>
           </a:p>
@@ -1086,86 +1085,6 @@
               <a:buNone/>
             </a:pPr>
             <a:r>
-              <a:t>The standard CS:APP driver often accepts a filename and switches to interactive input when that file ends, while stdin redirection may terminate at EOF. Verify the supplied bomb.c instead of promising that behavior for every version. Do not include placeholders or guessed lines in a replay file. Source for input redirection and distinct deployment modes: supplied instructor README. GDB run syntax: https://sourceware.org/gdb/current/onlinedocs/gdb.html/Arguments.html and https://sourceware.org/gdb/current/onlinedocs/gdb.html/Input_002fOutput.html .</a:t>
-            </a:r>
-            <a:endParaRPr/>
-          </a:p>
-        </p:txBody>
-      </p:sp>
-      <p:sp>
-        <p:nvSpPr>
-          <p:cNvPr id="4" name="Slide Number Placeholder 3"/>
-          <p:cNvSpPr>
-            <a:spLocks xmlns:a="http://schemas.openxmlformats.org/drawingml/2006/main" noGrp="1"/>
-          </p:cNvSpPr>
-          <p:nvPr>
-            <p:ph type="sldNum" idx="5"/>
-          </p:nvPr>
-        </p:nvSpPr>
-        <p:spPr/>
-        <p:txBody>
-          <a:bodyPr xmlns:a="http://schemas.openxmlformats.org/drawingml/2006/main"/>
-          <a:lstStyle xmlns:a="http://schemas.openxmlformats.org/drawingml/2006/main"/>
-          <a:p xmlns:a="http://schemas.openxmlformats.org/drawingml/2006/main"/>
-        </p:txBody>
-      </p:sp>
-    </p:spTree>
-  </p:cSld>
-  <p:clrMapOvr>
-    <a:masterClrMapping xmlns:a="http://schemas.openxmlformats.org/drawingml/2006/main"/>
-  </p:clrMapOvr>
-</p:notes>
-</file>
-
-<file path=ppt/notesSlides/notesSlide17.xml><?xml version="1.0" encoding="utf-8"?>
-<p:notes xmlns:p="http://schemas.openxmlformats.org/presentationml/2006/main">
-  <p:cSld>
-    <p:spTree>
-      <p:nvGrpSpPr>
-        <p:cNvPr id="1" name=""/>
-        <p:cNvGrpSpPr/>
-        <p:nvPr/>
-      </p:nvGrpSpPr>
-      <p:grpSpPr>
-        <a:xfrm xmlns:a="http://schemas.openxmlformats.org/drawingml/2006/main"/>
-      </p:grpSpPr>
-      <p:sp>
-        <p:nvSpPr>
-          <p:cNvPr id="2" name="Slide Image Placeholder 1"/>
-          <p:cNvSpPr>
-            <a:spLocks xmlns:a="http://schemas.openxmlformats.org/drawingml/2006/main" noGrp="1"/>
-          </p:cNvSpPr>
-          <p:nvPr>
-            <p:ph type="sldImg" idx="0"/>
-          </p:nvPr>
-        </p:nvSpPr>
-        <p:spPr/>
-      </p:sp>
-      <p:sp>
-        <p:nvSpPr>
-          <p:cNvPr id="3" name="Notes Placeholder 2"/>
-          <p:cNvSpPr>
-            <a:spLocks xmlns:a="http://schemas.openxmlformats.org/drawingml/2006/main" noGrp="1"/>
-          </p:cNvSpPr>
-          <p:nvPr>
-            <p:ph type="body" idx="1"/>
-          </p:nvPr>
-        </p:nvSpPr>
-        <p:spPr/>
-        <p:txBody>
-          <a:bodyPr xmlns:a="http://schemas.openxmlformats.org/drawingml/2006/main"/>
-          <a:lstStyle xmlns:a="http://schemas.openxmlformats.org/drawingml/2006/main"/>
-          <a:p xmlns:a="http://schemas.openxmlformats.org/drawingml/2006/main">
-            <a:pPr marL="0" lvl="0" indent="0" algn="l">
-              <a:spcBef>
-                <a:spcPts val="0"/>
-              </a:spcBef>
-              <a:spcAft>
-                <a:spcPts val="0"/>
-              </a:spcAft>
-              <a:buNone/>
-            </a:pPr>
-            <a:r>
               <a:t>Close with a short live demonstration on the student's own assigned executable. If execution reaches the failure routine breakpoint, inspect the caller with bt and disassemble, then kill and restart after correcting the reasoning. The goal is understanding each check rather than changing registers or patching the executable to skip it.</a:t>
             </a:r>
             <a:endParaRPr/>
@@ -1566,7 +1485,7 @@
               <a:buNone/>
             </a:pPr>
             <a:r>
-              <a:t>Download example.c from the presentation toolbar and put it in an iLab practice directory. It defines transform(x) = 3*x + 2, called with 4. In GDB, break transform, run, print x, disassemble transform, and stepi. Its main returns success when the computed result is 14. Sources: https://gcc.gnu.org/onlinedocs/gcc/Overall-Options.html and https://gcc.gnu.org/onlinedocs/gcc/Debugging-Options.html .</a:t>
+              <a:t>Sources: https://sourceware.org/binutils/docs/binutils/objdump.html and https://sourceware.org/gdb/current/onlinedocs/gdb.html/Machine-Code.html . The &gt; operator writes objdump output to a text file. less supports /phase_1 to search and q to quit. GDB function names require available symbols. Compiler-generated .s text and disassembly can differ in formatting and addresses.</a:t>
             </a:r>
             <a:endParaRPr/>
           </a:p>
@@ -1646,7 +1565,7 @@
               <a:buNone/>
             </a:pPr>
             <a:r>
-              <a:t>Sources: https://sourceware.org/binutils/docs/binutils/objdump.html and https://sourceware.org/gdb/current/onlinedocs/gdb.html/Machine-Code.html . The &gt; operator writes objdump output to a text file. less supports /phase_1 to search and q to quit. GDB function names require available symbols. Compiler-generated .s text and disassembly can differ in formatting and addresses.</a:t>
+              <a:t>Use the actual symbol names in the assigned executable. A phase-entry breakpoint may occur after read_line has already requested input. Distinguish input typed to the running bomb from commands typed at (gdb). A breakpoint at explode_bomb is a backup, not a promise that all versions avoid reporting a failure. Do not step through or continue the explosion routine. Use kill to stop the inferior, then inspect and restart. Source: https://sourceware.org/gdb/current/onlinedocs/gdb.html/Set-Breaks.html .</a:t>
             </a:r>
             <a:endParaRPr/>
           </a:p>
@@ -1726,7 +1645,7 @@
               <a:buNone/>
             </a:pPr>
             <a:r>
-              <a:t>Use the actual symbol names in the assigned executable. A phase-entry breakpoint may occur after read_line has already requested input. Distinguish input typed to the running bomb from commands typed at (gdb). A breakpoint at explode_bomb is a backup, not a promise that all versions avoid reporting a failure. Do not step through or continue the explosion routine. Use kill to stop the inferior, then inspect and restart. Source: https://sourceware.org/gdb/current/onlinedocs/gdb.html/Set-Breaks.html .</a:t>
+              <a:t>Source: https://sourceware.org/gdb/current/onlinedocs/gdb.html/Set-Breaks.html . Show one address breakpoint live using an address copied from the student's running process. Absolute addresses may change across runs under address randomization. Prefer function breakpoints when possible. explain that b, info b, and d are common abbreviations but use full commands when teaching.</a:t>
             </a:r>
             <a:endParaRPr/>
           </a:p>
@@ -1806,7 +1725,7 @@
               <a:buNone/>
             </a:pPr>
             <a:r>
-              <a:t>Source: https://sourceware.org/gdb/current/onlinedocs/gdb.html/Set-Breaks.html . Show one address breakpoint live using an address copied from the student's running process. Absolute addresses may change across runs under address randomization. Prefer function breakpoints when possible. explain that b, info b, and d are common abbreviations but use full commands when teaching.</a:t>
+              <a:t>Source: https://sourceware.org/gdb/current/onlinedocs/gdb.html/Continuing-and-Stepping.html . A breakpoint or signal can interrupt stepping. finish runs until the current function returns and can also execute a failure path, so it is not a safe substitute for understanding the function. Ctrl+C pauses a running program. kill terminates the inferior while keeping GDB open. run may ask whether to restart if a program is already active.</a:t>
             </a:r>
             <a:endParaRPr/>
           </a:p>
@@ -3690,14 +3609,14 @@
   </p:cSld>
   <p:clrMap bg1="dk1" tx1="lt1" bg2="dk2" tx2="lt2" accent1="accent1" accent2="accent2" accent3="accent3" accent4="accent4" accent5="accent5" accent6="accent6" hlink="hlink" folHlink="folHlink"/>
   <p:sldLayoutIdLst>
-    <p:sldLayoutId xmlns:r="http://schemas.openxmlformats.org/officeDocument/2006/relationships" id="2147483649" r:id="R98823e38da414913"/>
-    <p:sldLayoutId xmlns:r="http://schemas.openxmlformats.org/officeDocument/2006/relationships" id="2147483650" r:id="R6542dbbc8d0347a4"/>
-    <p:sldLayoutId xmlns:r="http://schemas.openxmlformats.org/officeDocument/2006/relationships" id="2147483651" r:id="Rdb380e781bc34042"/>
-    <p:sldLayoutId xmlns:r="http://schemas.openxmlformats.org/officeDocument/2006/relationships" id="2147483652" r:id="Rfcf7d14712cb4c93"/>
-    <p:sldLayoutId xmlns:r="http://schemas.openxmlformats.org/officeDocument/2006/relationships" id="2147483653" r:id="R0d12cebb5018409a"/>
-    <p:sldLayoutId xmlns:r="http://schemas.openxmlformats.org/officeDocument/2006/relationships" id="2147483654" r:id="R394d4f0c381a4ff3"/>
-    <p:sldLayoutId xmlns:r="http://schemas.openxmlformats.org/officeDocument/2006/relationships" id="2147483655" r:id="R1f24e2eea756429e"/>
-    <p:sldLayoutId xmlns:r="http://schemas.openxmlformats.org/officeDocument/2006/relationships" id="2147483656" r:id="R6f67188e369345e6"/>
+    <p:sldLayoutId xmlns:r="http://schemas.openxmlformats.org/officeDocument/2006/relationships" id="2147483649" r:id="R7df592212e454582"/>
+    <p:sldLayoutId xmlns:r="http://schemas.openxmlformats.org/officeDocument/2006/relationships" id="2147483650" r:id="Rd3eaf559b9f24aab"/>
+    <p:sldLayoutId xmlns:r="http://schemas.openxmlformats.org/officeDocument/2006/relationships" id="2147483651" r:id="R48b83eb1d5db4c6c"/>
+    <p:sldLayoutId xmlns:r="http://schemas.openxmlformats.org/officeDocument/2006/relationships" id="2147483652" r:id="R90f5b6da6a254e3a"/>
+    <p:sldLayoutId xmlns:r="http://schemas.openxmlformats.org/officeDocument/2006/relationships" id="2147483653" r:id="R75cbd0f553524fe5"/>
+    <p:sldLayoutId xmlns:r="http://schemas.openxmlformats.org/officeDocument/2006/relationships" id="2147483654" r:id="R02133a9f51bb4763"/>
+    <p:sldLayoutId xmlns:r="http://schemas.openxmlformats.org/officeDocument/2006/relationships" id="2147483655" r:id="R40b4f75ec23b4b7d"/>
+    <p:sldLayoutId xmlns:r="http://schemas.openxmlformats.org/officeDocument/2006/relationships" id="2147483656" r:id="Rbbbf4a9447bb4297"/>
   </p:sldLayoutIdLst>
   <p:hf hdr="0" dt="0"/>
   <p:txStyles>
@@ -5364,7 +5283,7 @@
                 <a:ea typeface="Arial"/>
                 <a:cs typeface="Arial"/>
               </a:rPr>
-              <a:t>Stepping through instructions</a:t>
+              <a:t>Registers and memory in GDB</a:t>
             </a:r>
           </a:p>
         </p:txBody>
@@ -5600,7 +5519,7 @@
                 <a:ea typeface="Arial"/>
                 <a:cs typeface="Arial"/>
               </a:rPr>
-              <a:t>si executes one machine instruction and enters calls. ni executes one instruction and steps over calls.</a:t>
+              <a:t>print shows a value. x examines memory at an address.</a:t>
             </a:r>
           </a:p>
           <a:p xmlns:a="http://schemas.openxmlformats.org/drawingml/2006/main">
@@ -5650,7 +5569,7 @@
                 <a:ea typeface="Arial"/>
                 <a:cs typeface="Arial"/>
               </a:rPr>
-              <a:t>Stepping over a call still runs the function.</a:t>
+              <a:t>Choose the display format to match the data: strings, integers, or pointers.</a:t>
             </a:r>
           </a:p>
           <a:p xmlns:a="http://schemas.openxmlformats.org/drawingml/2006/main">
@@ -5700,7 +5619,7 @@
                 <a:ea typeface="Arial"/>
                 <a:cs typeface="Arial"/>
               </a:rPr>
-              <a:t>Source commands step and next operate on source lines when debug information exists.</a:t>
+              <a:t>In GDB, register names begin with $. In AT&amp;T assembly, they begin with %.</a:t>
             </a:r>
           </a:p>
         </p:txBody>
@@ -5936,7 +5855,7 @@
                 <a:ea typeface="Consolas"/>
                 <a:cs typeface="Consolas"/>
               </a:rPr>
-              <a:t>si         # stepi</a:t>
+              <a:t>info registers rax rdi rsi rsp</a:t>
             </a:r>
           </a:p>
           <a:p xmlns:a="http://schemas.openxmlformats.org/drawingml/2006/main">
@@ -5969,7 +5888,7 @@
                 <a:ea typeface="Consolas"/>
                 <a:cs typeface="Consolas"/>
               </a:rPr>
-              <a:t>ni         # nexti</a:t>
+              <a:t>p/x $rax       # register in hex</a:t>
             </a:r>
           </a:p>
           <a:p xmlns:a="http://schemas.openxmlformats.org/drawingml/2006/main">
@@ -6002,24 +5921,7 @@
                 <a:ea typeface="Consolas"/>
                 <a:cs typeface="Consolas"/>
               </a:rPr>
-              <a:t>x/i $pc    # current instruction</a:t>
-            </a:r>
-          </a:p>
-          <a:p xmlns:a="http://schemas.openxmlformats.org/drawingml/2006/main">
-            <a:pPr marL="0" indent="0">
-              <a:lnSpc>
-                <a:spcPct val="112000"/>
-              </a:lnSpc>
-              <a:spcBef>
-                <a:spcPts val="0"/>
-              </a:spcBef>
-              <a:spcAft>
-                <a:spcPts val="0"/>
-              </a:spcAft>
-              <a:buNone/>
-            </a:pPr>
-            <a:r>
-              <a:t/>
+              <a:t>p/d $rax       # register in decimal</a:t>
             </a:r>
           </a:p>
           <a:p xmlns:a="http://schemas.openxmlformats.org/drawingml/2006/main">
@@ -6052,7 +5954,7 @@
                 <a:ea typeface="Consolas"/>
                 <a:cs typeface="Consolas"/>
               </a:rPr>
-              <a:t>continue   # run until next stop</a:t>
+              <a:t>x/s $rdi       # string at address</a:t>
             </a:r>
           </a:p>
           <a:p xmlns:a="http://schemas.openxmlformats.org/drawingml/2006/main">
@@ -6085,7 +5987,7 @@
                 <a:ea typeface="Consolas"/>
                 <a:cs typeface="Consolas"/>
               </a:rPr>
-              <a:t>run        # restart from the beginning</a:t>
+              <a:t>x/4dw $rsp     # four 4-byte integers</a:t>
             </a:r>
           </a:p>
           <a:p xmlns:a="http://schemas.openxmlformats.org/drawingml/2006/main">
@@ -6118,7 +6020,7 @@
                 <a:ea typeface="Consolas"/>
                 <a:cs typeface="Consolas"/>
               </a:rPr>
-              <a:t>kill       # stop the running program</a:t>
+              <a:t>x/2gx $rsp     # two 8-byte values</a:t>
             </a:r>
           </a:p>
           <a:p xmlns:a="http://schemas.openxmlformats.org/drawingml/2006/main">
@@ -6151,7 +6053,7 @@
                 <a:ea typeface="Consolas"/>
                 <a:cs typeface="Consolas"/>
               </a:rPr>
-              <a:t>quit       # leave GDB</a:t>
+              <a:t>x/5i $pc       # five instructions</a:t>
             </a:r>
           </a:p>
         </p:txBody>
@@ -6161,7 +6063,7 @@
           <p:cNvPr id="534" name="Takeaway">
             <a:extLst xmlns:a="http://schemas.openxmlformats.org/drawingml/2006/main">
               <a:ext uri="{FF2B5EF4-FFF2-40B4-BE49-F238E27FC236}">
-                <a16:creationId xmlns:a16="http://schemas.microsoft.com/office/drawing/2014/main" id="{AAB3CE6D-E621-49F3-A9E7-04E228BC6054}"/>
+                <a16:creationId xmlns:a16="http://schemas.microsoft.com/office/drawing/2014/main" id="{C45CC3A1-990F-45B1-924F-3CEA0A1C6BBB}"/>
               </a:ext>
             </a:extLst>
           </p:cNvPr>
@@ -6229,7 +6131,7 @@
                 <a:ea typeface="Arial"/>
                 <a:cs typeface="Arial"/>
               </a:rPr>
-              <a:t>Inspect the destination of a call before using ni or continue.</a:t>
+              <a:t>Use x/s only when the register holds a readable string address.</a:t>
             </a:r>
           </a:p>
         </p:txBody>
@@ -6470,7 +6372,7 @@
                 <a:ea typeface="Arial"/>
                 <a:cs typeface="Arial"/>
               </a:rPr>
-              <a:t>Registers and memory in GDB</a:t>
+              <a:t>An address or its contents</a:t>
             </a:r>
           </a:p>
         </p:txBody>
@@ -6706,7 +6608,7 @@
                 <a:ea typeface="Arial"/>
                 <a:cs typeface="Arial"/>
               </a:rPr>
-              <a:t>print shows a value. x examines memory at an address.</a:t>
+              <a:t>A register can hold a number or an address. mov copies the operand you specify.</a:t>
             </a:r>
           </a:p>
           <a:p xmlns:a="http://schemas.openxmlformats.org/drawingml/2006/main">
@@ -6756,7 +6658,7 @@
                 <a:ea typeface="Arial"/>
                 <a:cs typeface="Arial"/>
               </a:rPr>
-              <a:t>Choose the display format to match the data: strings, integers, or pointers.</a:t>
+              <a:t>A parenthesized source operand in mov loads the contents at that address.</a:t>
             </a:r>
           </a:p>
           <a:p xmlns:a="http://schemas.openxmlformats.org/drawingml/2006/main">
@@ -6806,7 +6708,7 @@
                 <a:ea typeface="Arial"/>
                 <a:cs typeface="Arial"/>
               </a:rPr>
-              <a:t>In GDB, register names begin with $. In AT&amp;T assembly, they begin with %.</a:t>
+              <a:t>lea computes an address without reading its contents.</a:t>
             </a:r>
           </a:p>
         </p:txBody>
@@ -6840,7 +6742,7 @@
           </a:bodyPr>
           <a:lstStyle xmlns:a="http://schemas.openxmlformats.org/drawingml/2006/main">
             <a:defPPr>
-              <a:defRPr sz="1800">
+              <a:defRPr sz="1500">
                 <a:solidFill>
                   <a:srgbClr val="FFFFFF"/>
                 </a:solidFill>
@@ -7024,223 +6926,290 @@
                 <a:spcPts val="0"/>
               </a:spcAft>
               <a:buNone/>
-              <a:defRPr sz="1800">
-                <a:solidFill>
-                  <a:srgbClr val="FFFFFF"/>
-                </a:solidFill>
-                <a:latin typeface="Consolas"/>
-                <a:ea typeface="Consolas"/>
-                <a:cs typeface="Consolas"/>
-              </a:defRPr>
-            </a:pPr>
-            <a:r>
-              <a:rPr sz="1800">
-                <a:solidFill>
-                  <a:srgbClr val="FFFFFF"/>
-                </a:solidFill>
-                <a:latin typeface="Consolas"/>
-                <a:ea typeface="Consolas"/>
-                <a:cs typeface="Consolas"/>
-              </a:rPr>
-              <a:t>info registers rax rdi rsi rsp</a:t>
-            </a:r>
-          </a:p>
-          <a:p xmlns:a="http://schemas.openxmlformats.org/drawingml/2006/main">
-            <a:pPr marL="0" indent="0">
-              <a:lnSpc>
-                <a:spcPct val="112000"/>
-              </a:lnSpc>
-              <a:spcBef>
-                <a:spcPts val="0"/>
-              </a:spcBef>
-              <a:spcAft>
-                <a:spcPts val="0"/>
-              </a:spcAft>
-              <a:buNone/>
-              <a:defRPr sz="1800">
-                <a:solidFill>
-                  <a:srgbClr val="FFFFFF"/>
-                </a:solidFill>
-                <a:latin typeface="Consolas"/>
-                <a:ea typeface="Consolas"/>
-                <a:cs typeface="Consolas"/>
-              </a:defRPr>
-            </a:pPr>
-            <a:r>
-              <a:rPr sz="1800">
-                <a:solidFill>
-                  <a:srgbClr val="FFFFFF"/>
-                </a:solidFill>
-                <a:latin typeface="Consolas"/>
-                <a:ea typeface="Consolas"/>
-                <a:cs typeface="Consolas"/>
-              </a:rPr>
-              <a:t>p/x $rax       # register in hex</a:t>
-            </a:r>
-          </a:p>
-          <a:p xmlns:a="http://schemas.openxmlformats.org/drawingml/2006/main">
-            <a:pPr marL="0" indent="0">
-              <a:lnSpc>
-                <a:spcPct val="112000"/>
-              </a:lnSpc>
-              <a:spcBef>
-                <a:spcPts val="0"/>
-              </a:spcBef>
-              <a:spcAft>
-                <a:spcPts val="0"/>
-              </a:spcAft>
-              <a:buNone/>
-              <a:defRPr sz="1800">
-                <a:solidFill>
-                  <a:srgbClr val="FFFFFF"/>
-                </a:solidFill>
-                <a:latin typeface="Consolas"/>
-                <a:ea typeface="Consolas"/>
-                <a:cs typeface="Consolas"/>
-              </a:defRPr>
-            </a:pPr>
-            <a:r>
-              <a:rPr sz="1800">
-                <a:solidFill>
-                  <a:srgbClr val="FFFFFF"/>
-                </a:solidFill>
-                <a:latin typeface="Consolas"/>
-                <a:ea typeface="Consolas"/>
-                <a:cs typeface="Consolas"/>
-              </a:rPr>
-              <a:t>p/d $rax       # register in decimal</a:t>
-            </a:r>
-          </a:p>
-          <a:p xmlns:a="http://schemas.openxmlformats.org/drawingml/2006/main">
-            <a:pPr marL="0" indent="0">
-              <a:lnSpc>
-                <a:spcPct val="112000"/>
-              </a:lnSpc>
-              <a:spcBef>
-                <a:spcPts val="0"/>
-              </a:spcBef>
-              <a:spcAft>
-                <a:spcPts val="0"/>
-              </a:spcAft>
-              <a:buNone/>
-              <a:defRPr sz="1800">
-                <a:solidFill>
-                  <a:srgbClr val="FFFFFF"/>
-                </a:solidFill>
-                <a:latin typeface="Consolas"/>
-                <a:ea typeface="Consolas"/>
-                <a:cs typeface="Consolas"/>
-              </a:defRPr>
-            </a:pPr>
-            <a:r>
-              <a:rPr sz="1800">
-                <a:solidFill>
-                  <a:srgbClr val="FFFFFF"/>
-                </a:solidFill>
-                <a:latin typeface="Consolas"/>
-                <a:ea typeface="Consolas"/>
-                <a:cs typeface="Consolas"/>
-              </a:rPr>
-              <a:t>x/s $rdi       # string at address</a:t>
-            </a:r>
-          </a:p>
-          <a:p xmlns:a="http://schemas.openxmlformats.org/drawingml/2006/main">
-            <a:pPr marL="0" indent="0">
-              <a:lnSpc>
-                <a:spcPct val="112000"/>
-              </a:lnSpc>
-              <a:spcBef>
-                <a:spcPts val="0"/>
-              </a:spcBef>
-              <a:spcAft>
-                <a:spcPts val="0"/>
-              </a:spcAft>
-              <a:buNone/>
-              <a:defRPr sz="1800">
-                <a:solidFill>
-                  <a:srgbClr val="FFFFFF"/>
-                </a:solidFill>
-                <a:latin typeface="Consolas"/>
-                <a:ea typeface="Consolas"/>
-                <a:cs typeface="Consolas"/>
-              </a:defRPr>
-            </a:pPr>
-            <a:r>
-              <a:rPr sz="1800">
-                <a:solidFill>
-                  <a:srgbClr val="FFFFFF"/>
-                </a:solidFill>
-                <a:latin typeface="Consolas"/>
-                <a:ea typeface="Consolas"/>
-                <a:cs typeface="Consolas"/>
-              </a:rPr>
-              <a:t>x/4dw $rsp     # four 4-byte integers</a:t>
-            </a:r>
-          </a:p>
-          <a:p xmlns:a="http://schemas.openxmlformats.org/drawingml/2006/main">
-            <a:pPr marL="0" indent="0">
-              <a:lnSpc>
-                <a:spcPct val="112000"/>
-              </a:lnSpc>
-              <a:spcBef>
-                <a:spcPts val="0"/>
-              </a:spcBef>
-              <a:spcAft>
-                <a:spcPts val="0"/>
-              </a:spcAft>
-              <a:buNone/>
-              <a:defRPr sz="1800">
-                <a:solidFill>
-                  <a:srgbClr val="FFFFFF"/>
-                </a:solidFill>
-                <a:latin typeface="Consolas"/>
-                <a:ea typeface="Consolas"/>
-                <a:cs typeface="Consolas"/>
-              </a:defRPr>
-            </a:pPr>
-            <a:r>
-              <a:rPr sz="1800">
-                <a:solidFill>
-                  <a:srgbClr val="FFFFFF"/>
-                </a:solidFill>
-                <a:latin typeface="Consolas"/>
-                <a:ea typeface="Consolas"/>
-                <a:cs typeface="Consolas"/>
-              </a:rPr>
-              <a:t>x/2gx $rsp     # two 8-byte values</a:t>
-            </a:r>
-          </a:p>
-          <a:p xmlns:a="http://schemas.openxmlformats.org/drawingml/2006/main">
-            <a:pPr marL="0" indent="0">
-              <a:lnSpc>
-                <a:spcPct val="112000"/>
-              </a:lnSpc>
-              <a:spcBef>
-                <a:spcPts val="0"/>
-              </a:spcBef>
-              <a:spcAft>
-                <a:spcPts val="0"/>
-              </a:spcAft>
-              <a:buNone/>
-              <a:defRPr sz="1800">
-                <a:solidFill>
-                  <a:srgbClr val="FFFFFF"/>
-                </a:solidFill>
-                <a:latin typeface="Consolas"/>
-                <a:ea typeface="Consolas"/>
-                <a:cs typeface="Consolas"/>
-              </a:defRPr>
-            </a:pPr>
-            <a:r>
-              <a:rPr sz="1800">
-                <a:solidFill>
-                  <a:srgbClr val="FFFFFF"/>
-                </a:solidFill>
-                <a:latin typeface="Consolas"/>
-                <a:ea typeface="Consolas"/>
-                <a:cs typeface="Consolas"/>
-              </a:rPr>
-              <a:t>x/5i $pc       # five instructions</a:t>
+              <a:defRPr sz="1500">
+                <a:solidFill>
+                  <a:srgbClr val="FFFFFF"/>
+                </a:solidFill>
+                <a:latin typeface="Consolas"/>
+                <a:ea typeface="Consolas"/>
+                <a:cs typeface="Consolas"/>
+              </a:defRPr>
+            </a:pPr>
+            <a:r>
+              <a:rPr sz="1500">
+                <a:solidFill>
+                  <a:srgbClr val="FFFFFF"/>
+                </a:solidFill>
+                <a:latin typeface="Consolas"/>
+                <a:ea typeface="Consolas"/>
+                <a:cs typeface="Consolas"/>
+              </a:rPr>
+              <a:t># Suppose rbx = 0x2000</a:t>
+            </a:r>
+          </a:p>
+          <a:p xmlns:a="http://schemas.openxmlformats.org/drawingml/2006/main">
+            <a:pPr marL="0" indent="0">
+              <a:lnSpc>
+                <a:spcPct val="112000"/>
+              </a:lnSpc>
+              <a:spcBef>
+                <a:spcPts val="0"/>
+              </a:spcBef>
+              <a:spcAft>
+                <a:spcPts val="0"/>
+              </a:spcAft>
+              <a:buNone/>
+              <a:defRPr sz="1500">
+                <a:solidFill>
+                  <a:srgbClr val="FFFFFF"/>
+                </a:solidFill>
+                <a:latin typeface="Consolas"/>
+                <a:ea typeface="Consolas"/>
+                <a:cs typeface="Consolas"/>
+              </a:defRPr>
+            </a:pPr>
+            <a:r>
+              <a:rPr sz="1500">
+                <a:solidFill>
+                  <a:srgbClr val="FFFFFF"/>
+                </a:solidFill>
+                <a:latin typeface="Consolas"/>
+                <a:ea typeface="Consolas"/>
+                <a:cs typeface="Consolas"/>
+              </a:rPr>
+              <a:t># memory[0x2000] contains 37</a:t>
+            </a:r>
+          </a:p>
+          <a:p xmlns:a="http://schemas.openxmlformats.org/drawingml/2006/main">
+            <a:pPr marL="0" indent="0">
+              <a:lnSpc>
+                <a:spcPct val="112000"/>
+              </a:lnSpc>
+              <a:spcBef>
+                <a:spcPts val="0"/>
+              </a:spcBef>
+              <a:spcAft>
+                <a:spcPts val="0"/>
+              </a:spcAft>
+              <a:buNone/>
+            </a:pPr>
+            <a:r>
+              <a:t/>
+            </a:r>
+          </a:p>
+          <a:p xmlns:a="http://schemas.openxmlformats.org/drawingml/2006/main">
+            <a:pPr marL="0" indent="0">
+              <a:lnSpc>
+                <a:spcPct val="112000"/>
+              </a:lnSpc>
+              <a:spcBef>
+                <a:spcPts val="0"/>
+              </a:spcBef>
+              <a:spcAft>
+                <a:spcPts val="0"/>
+              </a:spcAft>
+              <a:buNone/>
+              <a:defRPr sz="1500">
+                <a:solidFill>
+                  <a:srgbClr val="FFFFFF"/>
+                </a:solidFill>
+                <a:latin typeface="Consolas"/>
+                <a:ea typeface="Consolas"/>
+                <a:cs typeface="Consolas"/>
+              </a:defRPr>
+            </a:pPr>
+            <a:r>
+              <a:rPr sz="1500">
+                <a:solidFill>
+                  <a:srgbClr val="FFFFFF"/>
+                </a:solidFill>
+                <a:latin typeface="Consolas"/>
+                <a:ea typeface="Consolas"/>
+                <a:cs typeface="Consolas"/>
+              </a:rPr>
+              <a:t>movq %rbx, %rax     # rax = 0x2000</a:t>
+            </a:r>
+          </a:p>
+          <a:p xmlns:a="http://schemas.openxmlformats.org/drawingml/2006/main">
+            <a:pPr marL="0" indent="0">
+              <a:lnSpc>
+                <a:spcPct val="112000"/>
+              </a:lnSpc>
+              <a:spcBef>
+                <a:spcPts val="0"/>
+              </a:spcBef>
+              <a:spcAft>
+                <a:spcPts val="0"/>
+              </a:spcAft>
+              <a:buNone/>
+              <a:defRPr sz="1500">
+                <a:solidFill>
+                  <a:srgbClr val="FFFFFF"/>
+                </a:solidFill>
+                <a:latin typeface="Consolas"/>
+                <a:ea typeface="Consolas"/>
+                <a:cs typeface="Consolas"/>
+              </a:defRPr>
+            </a:pPr>
+            <a:r>
+              <a:rPr sz="1500">
+                <a:solidFill>
+                  <a:srgbClr val="FFFFFF"/>
+                </a:solidFill>
+                <a:latin typeface="Consolas"/>
+                <a:ea typeface="Consolas"/>
+                <a:cs typeface="Consolas"/>
+              </a:rPr>
+              <a:t>movq (%rbx), %rax   # rax = 37</a:t>
+            </a:r>
+          </a:p>
+          <a:p xmlns:a="http://schemas.openxmlformats.org/drawingml/2006/main">
+            <a:pPr marL="0" indent="0">
+              <a:lnSpc>
+                <a:spcPct val="112000"/>
+              </a:lnSpc>
+              <a:spcBef>
+                <a:spcPts val="0"/>
+              </a:spcBef>
+              <a:spcAft>
+                <a:spcPts val="0"/>
+              </a:spcAft>
+              <a:buNone/>
+              <a:defRPr sz="1500">
+                <a:solidFill>
+                  <a:srgbClr val="FFFFFF"/>
+                </a:solidFill>
+                <a:latin typeface="Consolas"/>
+                <a:ea typeface="Consolas"/>
+                <a:cs typeface="Consolas"/>
+              </a:defRPr>
+            </a:pPr>
+            <a:r>
+              <a:rPr sz="1500">
+                <a:solidFill>
+                  <a:srgbClr val="FFFFFF"/>
+                </a:solidFill>
+                <a:latin typeface="Consolas"/>
+                <a:ea typeface="Consolas"/>
+                <a:cs typeface="Consolas"/>
+              </a:rPr>
+              <a:t>leaq 8(%rbx), %rax  # rax = 0x2008</a:t>
+            </a:r>
+          </a:p>
+          <a:p xmlns:a="http://schemas.openxmlformats.org/drawingml/2006/main">
+            <a:pPr marL="0" indent="0">
+              <a:lnSpc>
+                <a:spcPct val="112000"/>
+              </a:lnSpc>
+              <a:spcBef>
+                <a:spcPts val="0"/>
+              </a:spcBef>
+              <a:spcAft>
+                <a:spcPts val="0"/>
+              </a:spcAft>
+              <a:buNone/>
+            </a:pPr>
+            <a:r>
+              <a:t/>
+            </a:r>
+          </a:p>
+          <a:p xmlns:a="http://schemas.openxmlformats.org/drawingml/2006/main">
+            <a:pPr marL="0" indent="0">
+              <a:lnSpc>
+                <a:spcPct val="112000"/>
+              </a:lnSpc>
+              <a:spcBef>
+                <a:spcPts val="0"/>
+              </a:spcBef>
+              <a:spcAft>
+                <a:spcPts val="0"/>
+              </a:spcAft>
+              <a:buNone/>
+              <a:defRPr sz="1500">
+                <a:solidFill>
+                  <a:srgbClr val="FFFFFF"/>
+                </a:solidFill>
+                <a:latin typeface="Consolas"/>
+                <a:ea typeface="Consolas"/>
+                <a:cs typeface="Consolas"/>
+              </a:defRPr>
+            </a:pPr>
+            <a:r>
+              <a:rPr sz="1500">
+                <a:solidFill>
+                  <a:srgbClr val="FFFFFF"/>
+                </a:solidFill>
+                <a:latin typeface="Consolas"/>
+                <a:ea typeface="Consolas"/>
+                <a:cs typeface="Consolas"/>
+              </a:rPr>
+              <a:t># GDB checks</a:t>
+            </a:r>
+          </a:p>
+          <a:p xmlns:a="http://schemas.openxmlformats.org/drawingml/2006/main">
+            <a:pPr marL="0" indent="0">
+              <a:lnSpc>
+                <a:spcPct val="112000"/>
+              </a:lnSpc>
+              <a:spcBef>
+                <a:spcPts val="0"/>
+              </a:spcBef>
+              <a:spcAft>
+                <a:spcPts val="0"/>
+              </a:spcAft>
+              <a:buNone/>
+              <a:defRPr sz="1500">
+                <a:solidFill>
+                  <a:srgbClr val="FFFFFF"/>
+                </a:solidFill>
+                <a:latin typeface="Consolas"/>
+                <a:ea typeface="Consolas"/>
+                <a:cs typeface="Consolas"/>
+              </a:defRPr>
+            </a:pPr>
+            <a:r>
+              <a:rPr sz="1500">
+                <a:solidFill>
+                  <a:srgbClr val="FFFFFF"/>
+                </a:solidFill>
+                <a:latin typeface="Consolas"/>
+                <a:ea typeface="Consolas"/>
+                <a:cs typeface="Consolas"/>
+              </a:rPr>
+              <a:t>p/x $rbx</a:t>
+            </a:r>
+          </a:p>
+          <a:p xmlns:a="http://schemas.openxmlformats.org/drawingml/2006/main">
+            <a:pPr marL="0" indent="0">
+              <a:lnSpc>
+                <a:spcPct val="112000"/>
+              </a:lnSpc>
+              <a:spcBef>
+                <a:spcPts val="0"/>
+              </a:spcBef>
+              <a:spcAft>
+                <a:spcPts val="0"/>
+              </a:spcAft>
+              <a:buNone/>
+              <a:defRPr sz="1500">
+                <a:solidFill>
+                  <a:srgbClr val="FFFFFF"/>
+                </a:solidFill>
+                <a:latin typeface="Consolas"/>
+                <a:ea typeface="Consolas"/>
+                <a:cs typeface="Consolas"/>
+              </a:defRPr>
+            </a:pPr>
+            <a:r>
+              <a:rPr sz="1500">
+                <a:solidFill>
+                  <a:srgbClr val="FFFFFF"/>
+                </a:solidFill>
+                <a:latin typeface="Consolas"/>
+                <a:ea typeface="Consolas"/>
+                <a:cs typeface="Consolas"/>
+              </a:rPr>
+              <a:t>x/gd $rbx</a:t>
             </a:r>
           </a:p>
         </p:txBody>
@@ -7250,7 +7219,7 @@
           <p:cNvPr id="534" name="Takeaway">
             <a:extLst xmlns:a="http://schemas.openxmlformats.org/drawingml/2006/main">
               <a:ext uri="{FF2B5EF4-FFF2-40B4-BE49-F238E27FC236}">
-                <a16:creationId xmlns:a16="http://schemas.microsoft.com/office/drawing/2014/main" id="{C271EF40-F329-4862-8F9D-D70C0EF840F3}"/>
+                <a16:creationId xmlns:a16="http://schemas.microsoft.com/office/drawing/2014/main" id="{C3EC592E-CAEF-4514-9AA7-85E19D4C1A90}"/>
               </a:ext>
             </a:extLst>
           </p:cNvPr>
@@ -7318,7 +7287,7 @@
                 <a:ea typeface="Arial"/>
                 <a:cs typeface="Arial"/>
               </a:rPr>
-              <a:t>Use x/s only when the register holds a readable string address.</a:t>
+              <a:t>Toy values for this example. Addresses and contents in your bomb will differ.</a:t>
             </a:r>
           </a:p>
         </p:txBody>
@@ -7559,7 +7528,7 @@
                 <a:ea typeface="Arial"/>
                 <a:cs typeface="Arial"/>
               </a:rPr>
-              <a:t>An address or its contents</a:t>
+              <a:t>Input formats and comparisons</a:t>
             </a:r>
           </a:p>
         </p:txBody>
@@ -7795,7 +7764,7 @@
                 <a:ea typeface="Arial"/>
                 <a:cs typeface="Arial"/>
               </a:rPr>
-              <a:t>A register can hold a number or an address. mov copies the operand you specify.</a:t>
+              <a:t>Identify what the program parses before solving the checks.</a:t>
             </a:r>
           </a:p>
           <a:p xmlns:a="http://schemas.openxmlformats.org/drawingml/2006/main">
@@ -7845,7 +7814,7 @@
                 <a:ea typeface="Arial"/>
                 <a:cs typeface="Arial"/>
               </a:rPr>
-              <a:t>A parenthesized source operand in mov loads the contents at that address.</a:t>
+              <a:t>A parsing helper may check how many fields it read. A later comparison checks their values.</a:t>
             </a:r>
           </a:p>
           <a:p xmlns:a="http://schemas.openxmlformats.org/drawingml/2006/main">
@@ -7895,7 +7864,7 @@
                 <a:ea typeface="Arial"/>
                 <a:cs typeface="Arial"/>
               </a:rPr>
-              <a:t>lea computes an address without reading its contents.</a:t>
+              <a:t>Read the comparison and the branch together.</a:t>
             </a:r>
           </a:p>
         </p:txBody>
@@ -7929,7 +7898,7 @@
           </a:bodyPr>
           <a:lstStyle xmlns:a="http://schemas.openxmlformats.org/drawingml/2006/main">
             <a:defPPr>
-              <a:defRPr sz="1500">
+              <a:defRPr sz="1800">
                 <a:solidFill>
                   <a:srgbClr val="FFFFFF"/>
                 </a:solidFill>
@@ -8113,58 +8082,58 @@
                 <a:spcPts val="0"/>
               </a:spcAft>
               <a:buNone/>
-              <a:defRPr sz="1500">
-                <a:solidFill>
-                  <a:srgbClr val="FFFFFF"/>
-                </a:solidFill>
-                <a:latin typeface="Consolas"/>
-                <a:ea typeface="Consolas"/>
-                <a:cs typeface="Consolas"/>
-              </a:defRPr>
-            </a:pPr>
-            <a:r>
-              <a:rPr sz="1500">
-                <a:solidFill>
-                  <a:srgbClr val="FFFFFF"/>
-                </a:solidFill>
-                <a:latin typeface="Consolas"/>
-                <a:ea typeface="Consolas"/>
-                <a:cs typeface="Consolas"/>
-              </a:rPr>
-              <a:t># Suppose rbx = 0x2000</a:t>
-            </a:r>
-          </a:p>
-          <a:p xmlns:a="http://schemas.openxmlformats.org/drawingml/2006/main">
-            <a:pPr marL="0" indent="0">
-              <a:lnSpc>
-                <a:spcPct val="112000"/>
-              </a:lnSpc>
-              <a:spcBef>
-                <a:spcPts val="0"/>
-              </a:spcBef>
-              <a:spcAft>
-                <a:spcPts val="0"/>
-              </a:spcAft>
-              <a:buNone/>
-              <a:defRPr sz="1500">
-                <a:solidFill>
-                  <a:srgbClr val="FFFFFF"/>
-                </a:solidFill>
-                <a:latin typeface="Consolas"/>
-                <a:ea typeface="Consolas"/>
-                <a:cs typeface="Consolas"/>
-              </a:defRPr>
-            </a:pPr>
-            <a:r>
-              <a:rPr sz="1500">
-                <a:solidFill>
-                  <a:srgbClr val="FFFFFF"/>
-                </a:solidFill>
-                <a:latin typeface="Consolas"/>
-                <a:ea typeface="Consolas"/>
-                <a:cs typeface="Consolas"/>
-              </a:rPr>
-              <a:t># memory[0x2000] contains 37</a:t>
+              <a:defRPr sz="1800">
+                <a:solidFill>
+                  <a:srgbClr val="FFFFFF"/>
+                </a:solidFill>
+                <a:latin typeface="Consolas"/>
+                <a:ea typeface="Consolas"/>
+                <a:cs typeface="Consolas"/>
+              </a:defRPr>
+            </a:pPr>
+            <a:r>
+              <a:rPr sz="1800">
+                <a:solidFill>
+                  <a:srgbClr val="FFFFFF"/>
+                </a:solidFill>
+                <a:latin typeface="Consolas"/>
+                <a:ea typeface="Consolas"/>
+                <a:cs typeface="Consolas"/>
+              </a:rPr>
+              <a:t># Toy input format</a:t>
+            </a:r>
+          </a:p>
+          <a:p xmlns:a="http://schemas.openxmlformats.org/drawingml/2006/main">
+            <a:pPr marL="0" indent="0">
+              <a:lnSpc>
+                <a:spcPct val="112000"/>
+              </a:lnSpc>
+              <a:spcBef>
+                <a:spcPts val="0"/>
+              </a:spcBef>
+              <a:spcAft>
+                <a:spcPts val="0"/>
+              </a:spcAft>
+              <a:buNone/>
+              <a:defRPr sz="1800">
+                <a:solidFill>
+                  <a:srgbClr val="FFFFFF"/>
+                </a:solidFill>
+                <a:latin typeface="Consolas"/>
+                <a:ea typeface="Consolas"/>
+                <a:cs typeface="Consolas"/>
+              </a:defRPr>
+            </a:pPr>
+            <a:r>
+              <a:rPr sz="1800">
+                <a:solidFill>
+                  <a:srgbClr val="FFFFFF"/>
+                </a:solidFill>
+                <a:latin typeface="Consolas"/>
+                <a:ea typeface="Consolas"/>
+                <a:cs typeface="Consolas"/>
+              </a:rPr>
+              <a:t>"%d %c"     # integer, then character</a:t>
             </a:r>
           </a:p>
           <a:p xmlns:a="http://schemas.openxmlformats.org/drawingml/2006/main">
@@ -8196,91 +8165,91 @@
                 <a:spcPts val="0"/>
               </a:spcAft>
               <a:buNone/>
-              <a:defRPr sz="1500">
-                <a:solidFill>
-                  <a:srgbClr val="FFFFFF"/>
-                </a:solidFill>
-                <a:latin typeface="Consolas"/>
-                <a:ea typeface="Consolas"/>
-                <a:cs typeface="Consolas"/>
-              </a:defRPr>
-            </a:pPr>
-            <a:r>
-              <a:rPr sz="1500">
-                <a:solidFill>
-                  <a:srgbClr val="FFFFFF"/>
-                </a:solidFill>
-                <a:latin typeface="Consolas"/>
-                <a:ea typeface="Consolas"/>
-                <a:cs typeface="Consolas"/>
-              </a:rPr>
-              <a:t>movq %rbx, %rax     # rax = 0x2000</a:t>
-            </a:r>
-          </a:p>
-          <a:p xmlns:a="http://schemas.openxmlformats.org/drawingml/2006/main">
-            <a:pPr marL="0" indent="0">
-              <a:lnSpc>
-                <a:spcPct val="112000"/>
-              </a:lnSpc>
-              <a:spcBef>
-                <a:spcPts val="0"/>
-              </a:spcBef>
-              <a:spcAft>
-                <a:spcPts val="0"/>
-              </a:spcAft>
-              <a:buNone/>
-              <a:defRPr sz="1500">
-                <a:solidFill>
-                  <a:srgbClr val="FFFFFF"/>
-                </a:solidFill>
-                <a:latin typeface="Consolas"/>
-                <a:ea typeface="Consolas"/>
-                <a:cs typeface="Consolas"/>
-              </a:defRPr>
-            </a:pPr>
-            <a:r>
-              <a:rPr sz="1500">
-                <a:solidFill>
-                  <a:srgbClr val="FFFFFF"/>
-                </a:solidFill>
-                <a:latin typeface="Consolas"/>
-                <a:ea typeface="Consolas"/>
-                <a:cs typeface="Consolas"/>
-              </a:rPr>
-              <a:t>movq (%rbx), %rax   # rax = 37</a:t>
-            </a:r>
-          </a:p>
-          <a:p xmlns:a="http://schemas.openxmlformats.org/drawingml/2006/main">
-            <a:pPr marL="0" indent="0">
-              <a:lnSpc>
-                <a:spcPct val="112000"/>
-              </a:lnSpc>
-              <a:spcBef>
-                <a:spcPts val="0"/>
-              </a:spcBef>
-              <a:spcAft>
-                <a:spcPts val="0"/>
-              </a:spcAft>
-              <a:buNone/>
-              <a:defRPr sz="1500">
-                <a:solidFill>
-                  <a:srgbClr val="FFFFFF"/>
-                </a:solidFill>
-                <a:latin typeface="Consolas"/>
-                <a:ea typeface="Consolas"/>
-                <a:cs typeface="Consolas"/>
-              </a:defRPr>
-            </a:pPr>
-            <a:r>
-              <a:rPr sz="1500">
-                <a:solidFill>
-                  <a:srgbClr val="FFFFFF"/>
-                </a:solidFill>
-                <a:latin typeface="Consolas"/>
-                <a:ea typeface="Consolas"/>
-                <a:cs typeface="Consolas"/>
-              </a:rPr>
-              <a:t>leaq 8(%rbx), %rax  # rax = 0x2008</a:t>
+              <a:defRPr sz="1800">
+                <a:solidFill>
+                  <a:srgbClr val="FFFFFF"/>
+                </a:solidFill>
+                <a:latin typeface="Consolas"/>
+                <a:ea typeface="Consolas"/>
+                <a:cs typeface="Consolas"/>
+              </a:defRPr>
+            </a:pPr>
+            <a:r>
+              <a:rPr sz="1800">
+                <a:solidFill>
+                  <a:srgbClr val="FFFFFF"/>
+                </a:solidFill>
+                <a:latin typeface="Consolas"/>
+                <a:ea typeface="Consolas"/>
+                <a:cs typeface="Consolas"/>
+              </a:rPr>
+              <a:t># Toy value check</a:t>
+            </a:r>
+          </a:p>
+          <a:p xmlns:a="http://schemas.openxmlformats.org/drawingml/2006/main">
+            <a:pPr marL="0" indent="0">
+              <a:lnSpc>
+                <a:spcPct val="112000"/>
+              </a:lnSpc>
+              <a:spcBef>
+                <a:spcPts val="0"/>
+              </a:spcBef>
+              <a:spcAft>
+                <a:spcPts val="0"/>
+              </a:spcAft>
+              <a:buNone/>
+              <a:defRPr sz="1800">
+                <a:solidFill>
+                  <a:srgbClr val="FFFFFF"/>
+                </a:solidFill>
+                <a:latin typeface="Consolas"/>
+                <a:ea typeface="Consolas"/>
+                <a:cs typeface="Consolas"/>
+              </a:defRPr>
+            </a:pPr>
+            <a:r>
+              <a:rPr sz="1800">
+                <a:solidFill>
+                  <a:srgbClr val="FFFFFF"/>
+                </a:solidFill>
+                <a:latin typeface="Consolas"/>
+                <a:ea typeface="Consolas"/>
+                <a:cs typeface="Consolas"/>
+              </a:rPr>
+              <a:t>cmp $9, %eax</a:t>
+            </a:r>
+          </a:p>
+          <a:p xmlns:a="http://schemas.openxmlformats.org/drawingml/2006/main">
+            <a:pPr marL="0" indent="0">
+              <a:lnSpc>
+                <a:spcPct val="112000"/>
+              </a:lnSpc>
+              <a:spcBef>
+                <a:spcPts val="0"/>
+              </a:spcBef>
+              <a:spcAft>
+                <a:spcPts val="0"/>
+              </a:spcAft>
+              <a:buNone/>
+              <a:defRPr sz="1800">
+                <a:solidFill>
+                  <a:srgbClr val="FFFFFF"/>
+                </a:solidFill>
+                <a:latin typeface="Consolas"/>
+                <a:ea typeface="Consolas"/>
+                <a:cs typeface="Consolas"/>
+              </a:defRPr>
+            </a:pPr>
+            <a:r>
+              <a:rPr sz="1800">
+                <a:solidFill>
+                  <a:srgbClr val="FFFFFF"/>
+                </a:solidFill>
+                <a:latin typeface="Consolas"/>
+                <a:ea typeface="Consolas"/>
+                <a:cs typeface="Consolas"/>
+              </a:rPr>
+              <a:t>jne failure</a:t>
             </a:r>
           </a:p>
           <a:p xmlns:a="http://schemas.openxmlformats.org/drawingml/2006/main">
@@ -8312,91 +8281,25 @@
                 <a:spcPts val="0"/>
               </a:spcAft>
               <a:buNone/>
-              <a:defRPr sz="1500">
-                <a:solidFill>
-                  <a:srgbClr val="FFFFFF"/>
-                </a:solidFill>
-                <a:latin typeface="Consolas"/>
-                <a:ea typeface="Consolas"/>
-                <a:cs typeface="Consolas"/>
-              </a:defRPr>
-            </a:pPr>
-            <a:r>
-              <a:rPr sz="1500">
-                <a:solidFill>
-                  <a:srgbClr val="FFFFFF"/>
-                </a:solidFill>
-                <a:latin typeface="Consolas"/>
-                <a:ea typeface="Consolas"/>
-                <a:cs typeface="Consolas"/>
-              </a:rPr>
-              <a:t># GDB checks</a:t>
-            </a:r>
-          </a:p>
-          <a:p xmlns:a="http://schemas.openxmlformats.org/drawingml/2006/main">
-            <a:pPr marL="0" indent="0">
-              <a:lnSpc>
-                <a:spcPct val="112000"/>
-              </a:lnSpc>
-              <a:spcBef>
-                <a:spcPts val="0"/>
-              </a:spcBef>
-              <a:spcAft>
-                <a:spcPts val="0"/>
-              </a:spcAft>
-              <a:buNone/>
-              <a:defRPr sz="1500">
-                <a:solidFill>
-                  <a:srgbClr val="FFFFFF"/>
-                </a:solidFill>
-                <a:latin typeface="Consolas"/>
-                <a:ea typeface="Consolas"/>
-                <a:cs typeface="Consolas"/>
-              </a:defRPr>
-            </a:pPr>
-            <a:r>
-              <a:rPr sz="1500">
-                <a:solidFill>
-                  <a:srgbClr val="FFFFFF"/>
-                </a:solidFill>
-                <a:latin typeface="Consolas"/>
-                <a:ea typeface="Consolas"/>
-                <a:cs typeface="Consolas"/>
-              </a:rPr>
-              <a:t>p/x $rbx</a:t>
-            </a:r>
-          </a:p>
-          <a:p xmlns:a="http://schemas.openxmlformats.org/drawingml/2006/main">
-            <a:pPr marL="0" indent="0">
-              <a:lnSpc>
-                <a:spcPct val="112000"/>
-              </a:lnSpc>
-              <a:spcBef>
-                <a:spcPts val="0"/>
-              </a:spcBef>
-              <a:spcAft>
-                <a:spcPts val="0"/>
-              </a:spcAft>
-              <a:buNone/>
-              <a:defRPr sz="1500">
-                <a:solidFill>
-                  <a:srgbClr val="FFFFFF"/>
-                </a:solidFill>
-                <a:latin typeface="Consolas"/>
-                <a:ea typeface="Consolas"/>
-                <a:cs typeface="Consolas"/>
-              </a:defRPr>
-            </a:pPr>
-            <a:r>
-              <a:rPr sz="1500">
-                <a:solidFill>
-                  <a:srgbClr val="FFFFFF"/>
-                </a:solidFill>
-                <a:latin typeface="Consolas"/>
-                <a:ea typeface="Consolas"/>
-                <a:cs typeface="Consolas"/>
-              </a:rPr>
-              <a:t>x/gd $rbx</a:t>
+              <a:defRPr sz="1800">
+                <a:solidFill>
+                  <a:srgbClr val="FFFFFF"/>
+                </a:solidFill>
+                <a:latin typeface="Consolas"/>
+                <a:ea typeface="Consolas"/>
+                <a:cs typeface="Consolas"/>
+              </a:defRPr>
+            </a:pPr>
+            <a:r>
+              <a:rPr sz="1800">
+                <a:solidFill>
+                  <a:srgbClr val="FFFFFF"/>
+                </a:solidFill>
+                <a:latin typeface="Consolas"/>
+                <a:ea typeface="Consolas"/>
+                <a:cs typeface="Consolas"/>
+              </a:rPr>
+              <a:t>To avoid this branch, eax must be 9.</a:t>
             </a:r>
           </a:p>
         </p:txBody>
@@ -8406,7 +8309,7 @@
           <p:cNvPr id="534" name="Takeaway">
             <a:extLst xmlns:a="http://schemas.openxmlformats.org/drawingml/2006/main">
               <a:ext uri="{FF2B5EF4-FFF2-40B4-BE49-F238E27FC236}">
-                <a16:creationId xmlns:a16="http://schemas.microsoft.com/office/drawing/2014/main" id="{D8AED4A9-1C73-4454-828C-B2BC6FA8B061}"/>
+                <a16:creationId xmlns:a16="http://schemas.microsoft.com/office/drawing/2014/main" id="{2756607D-0044-483E-8705-E897E3D4FFA2}"/>
               </a:ext>
             </a:extLst>
           </p:cNvPr>
@@ -8474,7 +8377,7 @@
                 <a:ea typeface="Arial"/>
                 <a:cs typeface="Arial"/>
               </a:rPr>
-              <a:t>Toy values for this example. Addresses and contents in your bomb will differ.</a:t>
+              <a:t>A parsed-field count and a parsed value answer different questions.</a:t>
             </a:r>
           </a:p>
         </p:txBody>
@@ -8715,7 +8618,7 @@
                 <a:ea typeface="Arial"/>
                 <a:cs typeface="Arial"/>
               </a:rPr>
-              <a:t>Input formats and comparisons</a:t>
+              <a:t>Reading a loop</a:t>
             </a:r>
           </a:p>
         </p:txBody>
@@ -8951,7 +8854,7 @@
                 <a:ea typeface="Arial"/>
                 <a:cs typeface="Arial"/>
               </a:rPr>
-              <a:t>Identify what the program parses before solving the checks.</a:t>
+              <a:t>Track the pointer, the loop counter, and the values being compared.</a:t>
             </a:r>
           </a:p>
           <a:p xmlns:a="http://schemas.openxmlformats.org/drawingml/2006/main">
@@ -9001,7 +8904,7 @@
                 <a:ea typeface="Arial"/>
                 <a:cs typeface="Arial"/>
               </a:rPr>
-              <a:t>A parsing helper may check how many fields it read. A later comparison checks their values.</a:t>
+              <a:t>Here, each integer takes 4 bytes. Which element does 4(%rbx) access?</a:t>
             </a:r>
           </a:p>
           <a:p xmlns:a="http://schemas.openxmlformats.org/drawingml/2006/main">
@@ -9051,7 +8954,7 @@
                 <a:ea typeface="Arial"/>
                 <a:cs typeface="Arial"/>
               </a:rPr>
-              <a:t>Read the comparison and the branch together.</a:t>
+              <a:t>What must be true to avoid failure? What changes before the next iteration?</a:t>
             </a:r>
           </a:p>
         </p:txBody>
@@ -9085,7 +8988,7 @@
           </a:bodyPr>
           <a:lstStyle xmlns:a="http://schemas.openxmlformats.org/drawingml/2006/main">
             <a:defPPr>
-              <a:defRPr sz="1800">
+              <a:defRPr sz="1500">
                 <a:solidFill>
                   <a:srgbClr val="FFFFFF"/>
                 </a:solidFill>
@@ -9269,224 +9172,421 @@
                 <a:spcPts val="0"/>
               </a:spcAft>
               <a:buNone/>
-              <a:defRPr sz="1800">
-                <a:solidFill>
-                  <a:srgbClr val="FFFFFF"/>
-                </a:solidFill>
-                <a:latin typeface="Consolas"/>
-                <a:ea typeface="Consolas"/>
-                <a:cs typeface="Consolas"/>
-              </a:defRPr>
-            </a:pPr>
-            <a:r>
-              <a:rPr sz="1800">
-                <a:solidFill>
-                  <a:srgbClr val="FFFFFF"/>
-                </a:solidFill>
-                <a:latin typeface="Consolas"/>
-                <a:ea typeface="Consolas"/>
-                <a:cs typeface="Consolas"/>
-              </a:rPr>
-              <a:t># Toy input format</a:t>
-            </a:r>
-          </a:p>
-          <a:p xmlns:a="http://schemas.openxmlformats.org/drawingml/2006/main">
-            <a:pPr marL="0" indent="0">
-              <a:lnSpc>
-                <a:spcPct val="112000"/>
-              </a:lnSpc>
-              <a:spcBef>
-                <a:spcPts val="0"/>
-              </a:spcBef>
-              <a:spcAft>
-                <a:spcPts val="0"/>
-              </a:spcAft>
-              <a:buNone/>
-              <a:defRPr sz="1800">
-                <a:solidFill>
-                  <a:srgbClr val="FFFFFF"/>
-                </a:solidFill>
-                <a:latin typeface="Consolas"/>
-                <a:ea typeface="Consolas"/>
-                <a:cs typeface="Consolas"/>
-              </a:defRPr>
-            </a:pPr>
-            <a:r>
-              <a:rPr sz="1800">
-                <a:solidFill>
-                  <a:srgbClr val="FFFFFF"/>
-                </a:solidFill>
-                <a:latin typeface="Consolas"/>
-                <a:ea typeface="Consolas"/>
-                <a:cs typeface="Consolas"/>
-              </a:rPr>
-              <a:t>"%d %c"     # integer, then character</a:t>
-            </a:r>
-          </a:p>
-          <a:p xmlns:a="http://schemas.openxmlformats.org/drawingml/2006/main">
-            <a:pPr marL="0" indent="0">
-              <a:lnSpc>
-                <a:spcPct val="112000"/>
-              </a:lnSpc>
-              <a:spcBef>
-                <a:spcPts val="0"/>
-              </a:spcBef>
-              <a:spcAft>
-                <a:spcPts val="0"/>
-              </a:spcAft>
-              <a:buNone/>
-            </a:pPr>
-            <a:r>
-              <a:t/>
-            </a:r>
-          </a:p>
-          <a:p xmlns:a="http://schemas.openxmlformats.org/drawingml/2006/main">
-            <a:pPr marL="0" indent="0">
-              <a:lnSpc>
-                <a:spcPct val="112000"/>
-              </a:lnSpc>
-              <a:spcBef>
-                <a:spcPts val="0"/>
-              </a:spcBef>
-              <a:spcAft>
-                <a:spcPts val="0"/>
-              </a:spcAft>
-              <a:buNone/>
-              <a:defRPr sz="1800">
-                <a:solidFill>
-                  <a:srgbClr val="FFFFFF"/>
-                </a:solidFill>
-                <a:latin typeface="Consolas"/>
-                <a:ea typeface="Consolas"/>
-                <a:cs typeface="Consolas"/>
-              </a:defRPr>
-            </a:pPr>
-            <a:r>
-              <a:rPr sz="1800">
-                <a:solidFill>
-                  <a:srgbClr val="FFFFFF"/>
-                </a:solidFill>
-                <a:latin typeface="Consolas"/>
-                <a:ea typeface="Consolas"/>
-                <a:cs typeface="Consolas"/>
-              </a:rPr>
-              <a:t># Toy value check</a:t>
-            </a:r>
-          </a:p>
-          <a:p xmlns:a="http://schemas.openxmlformats.org/drawingml/2006/main">
-            <a:pPr marL="0" indent="0">
-              <a:lnSpc>
-                <a:spcPct val="112000"/>
-              </a:lnSpc>
-              <a:spcBef>
-                <a:spcPts val="0"/>
-              </a:spcBef>
-              <a:spcAft>
-                <a:spcPts val="0"/>
-              </a:spcAft>
-              <a:buNone/>
-              <a:defRPr sz="1800">
-                <a:solidFill>
-                  <a:srgbClr val="FFFFFF"/>
-                </a:solidFill>
-                <a:latin typeface="Consolas"/>
-                <a:ea typeface="Consolas"/>
-                <a:cs typeface="Consolas"/>
-              </a:defRPr>
-            </a:pPr>
-            <a:r>
-              <a:rPr sz="1800">
-                <a:solidFill>
-                  <a:srgbClr val="FFFFFF"/>
-                </a:solidFill>
-                <a:latin typeface="Consolas"/>
-                <a:ea typeface="Consolas"/>
-                <a:cs typeface="Consolas"/>
-              </a:rPr>
-              <a:t>cmp $9, %eax</a:t>
-            </a:r>
-          </a:p>
-          <a:p xmlns:a="http://schemas.openxmlformats.org/drawingml/2006/main">
-            <a:pPr marL="0" indent="0">
-              <a:lnSpc>
-                <a:spcPct val="112000"/>
-              </a:lnSpc>
-              <a:spcBef>
-                <a:spcPts val="0"/>
-              </a:spcBef>
-              <a:spcAft>
-                <a:spcPts val="0"/>
-              </a:spcAft>
-              <a:buNone/>
-              <a:defRPr sz="1800">
-                <a:solidFill>
-                  <a:srgbClr val="FFFFFF"/>
-                </a:solidFill>
-                <a:latin typeface="Consolas"/>
-                <a:ea typeface="Consolas"/>
-                <a:cs typeface="Consolas"/>
-              </a:defRPr>
-            </a:pPr>
-            <a:r>
-              <a:rPr sz="1800">
-                <a:solidFill>
-                  <a:srgbClr val="FFFFFF"/>
-                </a:solidFill>
-                <a:latin typeface="Consolas"/>
-                <a:ea typeface="Consolas"/>
-                <a:cs typeface="Consolas"/>
-              </a:rPr>
-              <a:t>jne failure</a:t>
-            </a:r>
-          </a:p>
-          <a:p xmlns:a="http://schemas.openxmlformats.org/drawingml/2006/main">
-            <a:pPr marL="0" indent="0">
-              <a:lnSpc>
-                <a:spcPct val="112000"/>
-              </a:lnSpc>
-              <a:spcBef>
-                <a:spcPts val="0"/>
-              </a:spcBef>
-              <a:spcAft>
-                <a:spcPts val="0"/>
-              </a:spcAft>
-              <a:buNone/>
-            </a:pPr>
-            <a:r>
-              <a:t/>
-            </a:r>
-          </a:p>
-          <a:p xmlns:a="http://schemas.openxmlformats.org/drawingml/2006/main">
-            <a:pPr marL="0" indent="0">
-              <a:lnSpc>
-                <a:spcPct val="112000"/>
-              </a:lnSpc>
-              <a:spcBef>
-                <a:spcPts val="0"/>
-              </a:spcBef>
-              <a:spcAft>
-                <a:spcPts val="0"/>
-              </a:spcAft>
-              <a:buNone/>
-              <a:defRPr sz="1800">
-                <a:solidFill>
-                  <a:srgbClr val="FFFFFF"/>
-                </a:solidFill>
-                <a:latin typeface="Consolas"/>
-                <a:ea typeface="Consolas"/>
-                <a:cs typeface="Consolas"/>
-              </a:defRPr>
-            </a:pPr>
-            <a:r>
-              <a:rPr sz="1800">
-                <a:solidFill>
-                  <a:srgbClr val="FFFFFF"/>
-                </a:solidFill>
-                <a:latin typeface="Consolas"/>
-                <a:ea typeface="Consolas"/>
-                <a:cs typeface="Consolas"/>
-              </a:rPr>
-              <a:t>To avoid this branch, eax must be 9.</a:t>
+              <a:defRPr sz="1500">
+                <a:solidFill>
+                  <a:srgbClr val="FFFFFF"/>
+                </a:solidFill>
+                <a:latin typeface="Consolas"/>
+                <a:ea typeface="Consolas"/>
+                <a:cs typeface="Consolas"/>
+              </a:defRPr>
+            </a:pPr>
+            <a:r>
+              <a:rPr sz="1500">
+                <a:solidFill>
+                  <a:srgbClr val="FFFFFF"/>
+                </a:solidFill>
+                <a:latin typeface="Consolas"/>
+                <a:ea typeface="Consolas"/>
+                <a:cs typeface="Consolas"/>
+              </a:rPr>
+              <a:t># rdi points to four 32-bit integers</a:t>
+            </a:r>
+          </a:p>
+          <a:p xmlns:a="http://schemas.openxmlformats.org/drawingml/2006/main">
+            <a:pPr marL="0" indent="0">
+              <a:lnSpc>
+                <a:spcPct val="112000"/>
+              </a:lnSpc>
+              <a:spcBef>
+                <a:spcPts val="0"/>
+              </a:spcBef>
+              <a:spcAft>
+                <a:spcPts val="0"/>
+              </a:spcAft>
+              <a:buNone/>
+              <a:defRPr sz="1500">
+                <a:solidFill>
+                  <a:srgbClr val="FFFFFF"/>
+                </a:solidFill>
+                <a:latin typeface="Consolas"/>
+                <a:ea typeface="Consolas"/>
+                <a:cs typeface="Consolas"/>
+              </a:defRPr>
+            </a:pPr>
+            <a:r>
+              <a:rPr sz="1500">
+                <a:solidFill>
+                  <a:srgbClr val="FFFFFF"/>
+                </a:solidFill>
+                <a:latin typeface="Consolas"/>
+                <a:ea typeface="Consolas"/>
+                <a:cs typeface="Consolas"/>
+              </a:rPr>
+              <a:t>movq %rdi, %rbx</a:t>
+            </a:r>
+          </a:p>
+          <a:p xmlns:a="http://schemas.openxmlformats.org/drawingml/2006/main">
+            <a:pPr marL="0" indent="0">
+              <a:lnSpc>
+                <a:spcPct val="112000"/>
+              </a:lnSpc>
+              <a:spcBef>
+                <a:spcPts val="0"/>
+              </a:spcBef>
+              <a:spcAft>
+                <a:spcPts val="0"/>
+              </a:spcAft>
+              <a:buNone/>
+              <a:defRPr sz="1500">
+                <a:solidFill>
+                  <a:srgbClr val="FFFFFF"/>
+                </a:solidFill>
+                <a:latin typeface="Consolas"/>
+                <a:ea typeface="Consolas"/>
+                <a:cs typeface="Consolas"/>
+              </a:defRPr>
+            </a:pPr>
+            <a:r>
+              <a:rPr sz="1500">
+                <a:solidFill>
+                  <a:srgbClr val="FFFFFF"/>
+                </a:solidFill>
+                <a:latin typeface="Consolas"/>
+                <a:ea typeface="Consolas"/>
+                <a:cs typeface="Consolas"/>
+              </a:rPr>
+              <a:t>movl $1, %ecx</a:t>
+            </a:r>
+          </a:p>
+          <a:p xmlns:a="http://schemas.openxmlformats.org/drawingml/2006/main">
+            <a:pPr marL="0" indent="0">
+              <a:lnSpc>
+                <a:spcPct val="112000"/>
+              </a:lnSpc>
+              <a:spcBef>
+                <a:spcPts val="0"/>
+              </a:spcBef>
+              <a:spcAft>
+                <a:spcPts val="0"/>
+              </a:spcAft>
+              <a:buNone/>
+              <a:defRPr sz="1500">
+                <a:solidFill>
+                  <a:srgbClr val="FFFFFF"/>
+                </a:solidFill>
+                <a:latin typeface="Consolas"/>
+                <a:ea typeface="Consolas"/>
+                <a:cs typeface="Consolas"/>
+              </a:defRPr>
+            </a:pPr>
+            <a:r>
+              <a:rPr sz="1500">
+                <a:solidFill>
+                  <a:srgbClr val="FFFFFF"/>
+                </a:solidFill>
+                <a:latin typeface="Consolas"/>
+                <a:ea typeface="Consolas"/>
+                <a:cs typeface="Consolas"/>
+              </a:rPr>
+              <a:t>loop_check:</a:t>
+            </a:r>
+          </a:p>
+          <a:p xmlns:a="http://schemas.openxmlformats.org/drawingml/2006/main">
+            <a:pPr marL="0" indent="0">
+              <a:lnSpc>
+                <a:spcPct val="112000"/>
+              </a:lnSpc>
+              <a:spcBef>
+                <a:spcPts val="0"/>
+              </a:spcBef>
+              <a:spcAft>
+                <a:spcPts val="0"/>
+              </a:spcAft>
+              <a:buNone/>
+              <a:defRPr sz="1500">
+                <a:solidFill>
+                  <a:srgbClr val="FFFFFF"/>
+                </a:solidFill>
+                <a:latin typeface="Consolas"/>
+                <a:ea typeface="Consolas"/>
+                <a:cs typeface="Consolas"/>
+              </a:defRPr>
+            </a:pPr>
+            <a:r>
+              <a:rPr sz="1500">
+                <a:solidFill>
+                  <a:srgbClr val="FFFFFF"/>
+                </a:solidFill>
+                <a:latin typeface="Consolas"/>
+                <a:ea typeface="Consolas"/>
+                <a:cs typeface="Consolas"/>
+              </a:rPr>
+              <a:t>  movl (%rbx), %eax</a:t>
+            </a:r>
+          </a:p>
+          <a:p xmlns:a="http://schemas.openxmlformats.org/drawingml/2006/main">
+            <a:pPr marL="0" indent="0">
+              <a:lnSpc>
+                <a:spcPct val="112000"/>
+              </a:lnSpc>
+              <a:spcBef>
+                <a:spcPts val="0"/>
+              </a:spcBef>
+              <a:spcAft>
+                <a:spcPts val="0"/>
+              </a:spcAft>
+              <a:buNone/>
+              <a:defRPr sz="1500">
+                <a:solidFill>
+                  <a:srgbClr val="FFFFFF"/>
+                </a:solidFill>
+                <a:latin typeface="Consolas"/>
+                <a:ea typeface="Consolas"/>
+                <a:cs typeface="Consolas"/>
+              </a:defRPr>
+            </a:pPr>
+            <a:r>
+              <a:rPr sz="1500">
+                <a:solidFill>
+                  <a:srgbClr val="FFFFFF"/>
+                </a:solidFill>
+                <a:latin typeface="Consolas"/>
+                <a:ea typeface="Consolas"/>
+                <a:cs typeface="Consolas"/>
+              </a:rPr>
+              <a:t>  addl $3, %eax</a:t>
+            </a:r>
+          </a:p>
+          <a:p xmlns:a="http://schemas.openxmlformats.org/drawingml/2006/main">
+            <a:pPr marL="0" indent="0">
+              <a:lnSpc>
+                <a:spcPct val="112000"/>
+              </a:lnSpc>
+              <a:spcBef>
+                <a:spcPts val="0"/>
+              </a:spcBef>
+              <a:spcAft>
+                <a:spcPts val="0"/>
+              </a:spcAft>
+              <a:buNone/>
+              <a:defRPr sz="1500">
+                <a:solidFill>
+                  <a:srgbClr val="FFFFFF"/>
+                </a:solidFill>
+                <a:latin typeface="Consolas"/>
+                <a:ea typeface="Consolas"/>
+                <a:cs typeface="Consolas"/>
+              </a:defRPr>
+            </a:pPr>
+            <a:r>
+              <a:rPr sz="1500">
+                <a:solidFill>
+                  <a:srgbClr val="FFFFFF"/>
+                </a:solidFill>
+                <a:latin typeface="Consolas"/>
+                <a:ea typeface="Consolas"/>
+                <a:cs typeface="Consolas"/>
+              </a:rPr>
+              <a:t>  cmpl %eax, 4(%rbx)</a:t>
+            </a:r>
+          </a:p>
+          <a:p xmlns:a="http://schemas.openxmlformats.org/drawingml/2006/main">
+            <a:pPr marL="0" indent="0">
+              <a:lnSpc>
+                <a:spcPct val="112000"/>
+              </a:lnSpc>
+              <a:spcBef>
+                <a:spcPts val="0"/>
+              </a:spcBef>
+              <a:spcAft>
+                <a:spcPts val="0"/>
+              </a:spcAft>
+              <a:buNone/>
+              <a:defRPr sz="1500">
+                <a:solidFill>
+                  <a:srgbClr val="FFFFFF"/>
+                </a:solidFill>
+                <a:latin typeface="Consolas"/>
+                <a:ea typeface="Consolas"/>
+                <a:cs typeface="Consolas"/>
+              </a:defRPr>
+            </a:pPr>
+            <a:r>
+              <a:rPr sz="1500">
+                <a:solidFill>
+                  <a:srgbClr val="FFFFFF"/>
+                </a:solidFill>
+                <a:latin typeface="Consolas"/>
+                <a:ea typeface="Consolas"/>
+                <a:cs typeface="Consolas"/>
+              </a:rPr>
+              <a:t>  jne failure</a:t>
+            </a:r>
+          </a:p>
+          <a:p xmlns:a="http://schemas.openxmlformats.org/drawingml/2006/main">
+            <a:pPr marL="0" indent="0">
+              <a:lnSpc>
+                <a:spcPct val="112000"/>
+              </a:lnSpc>
+              <a:spcBef>
+                <a:spcPts val="0"/>
+              </a:spcBef>
+              <a:spcAft>
+                <a:spcPts val="0"/>
+              </a:spcAft>
+              <a:buNone/>
+              <a:defRPr sz="1500">
+                <a:solidFill>
+                  <a:srgbClr val="FFFFFF"/>
+                </a:solidFill>
+                <a:latin typeface="Consolas"/>
+                <a:ea typeface="Consolas"/>
+                <a:cs typeface="Consolas"/>
+              </a:defRPr>
+            </a:pPr>
+            <a:r>
+              <a:rPr sz="1500">
+                <a:solidFill>
+                  <a:srgbClr val="FFFFFF"/>
+                </a:solidFill>
+                <a:latin typeface="Consolas"/>
+                <a:ea typeface="Consolas"/>
+                <a:cs typeface="Consolas"/>
+              </a:rPr>
+              <a:t>  addq $4, %rbx</a:t>
+            </a:r>
+          </a:p>
+          <a:p xmlns:a="http://schemas.openxmlformats.org/drawingml/2006/main">
+            <a:pPr marL="0" indent="0">
+              <a:lnSpc>
+                <a:spcPct val="112000"/>
+              </a:lnSpc>
+              <a:spcBef>
+                <a:spcPts val="0"/>
+              </a:spcBef>
+              <a:spcAft>
+                <a:spcPts val="0"/>
+              </a:spcAft>
+              <a:buNone/>
+              <a:defRPr sz="1500">
+                <a:solidFill>
+                  <a:srgbClr val="FFFFFF"/>
+                </a:solidFill>
+                <a:latin typeface="Consolas"/>
+                <a:ea typeface="Consolas"/>
+                <a:cs typeface="Consolas"/>
+              </a:defRPr>
+            </a:pPr>
+            <a:r>
+              <a:rPr sz="1500">
+                <a:solidFill>
+                  <a:srgbClr val="FFFFFF"/>
+                </a:solidFill>
+                <a:latin typeface="Consolas"/>
+                <a:ea typeface="Consolas"/>
+                <a:cs typeface="Consolas"/>
+              </a:rPr>
+              <a:t>  addl $1, %ecx</a:t>
+            </a:r>
+          </a:p>
+          <a:p xmlns:a="http://schemas.openxmlformats.org/drawingml/2006/main">
+            <a:pPr marL="0" indent="0">
+              <a:lnSpc>
+                <a:spcPct val="112000"/>
+              </a:lnSpc>
+              <a:spcBef>
+                <a:spcPts val="0"/>
+              </a:spcBef>
+              <a:spcAft>
+                <a:spcPts val="0"/>
+              </a:spcAft>
+              <a:buNone/>
+              <a:defRPr sz="1500">
+                <a:solidFill>
+                  <a:srgbClr val="FFFFFF"/>
+                </a:solidFill>
+                <a:latin typeface="Consolas"/>
+                <a:ea typeface="Consolas"/>
+                <a:cs typeface="Consolas"/>
+              </a:defRPr>
+            </a:pPr>
+            <a:r>
+              <a:rPr sz="1500">
+                <a:solidFill>
+                  <a:srgbClr val="FFFFFF"/>
+                </a:solidFill>
+                <a:latin typeface="Consolas"/>
+                <a:ea typeface="Consolas"/>
+                <a:cs typeface="Consolas"/>
+              </a:rPr>
+              <a:t>  cmpl $4, %ecx</a:t>
+            </a:r>
+          </a:p>
+          <a:p xmlns:a="http://schemas.openxmlformats.org/drawingml/2006/main">
+            <a:pPr marL="0" indent="0">
+              <a:lnSpc>
+                <a:spcPct val="112000"/>
+              </a:lnSpc>
+              <a:spcBef>
+                <a:spcPts val="0"/>
+              </a:spcBef>
+              <a:spcAft>
+                <a:spcPts val="0"/>
+              </a:spcAft>
+              <a:buNone/>
+              <a:defRPr sz="1500">
+                <a:solidFill>
+                  <a:srgbClr val="FFFFFF"/>
+                </a:solidFill>
+                <a:latin typeface="Consolas"/>
+                <a:ea typeface="Consolas"/>
+                <a:cs typeface="Consolas"/>
+              </a:defRPr>
+            </a:pPr>
+            <a:r>
+              <a:rPr sz="1500">
+                <a:solidFill>
+                  <a:srgbClr val="FFFFFF"/>
+                </a:solidFill>
+                <a:latin typeface="Consolas"/>
+                <a:ea typeface="Consolas"/>
+                <a:cs typeface="Consolas"/>
+              </a:rPr>
+              <a:t>  jne loop_check</a:t>
+            </a:r>
+          </a:p>
+          <a:p xmlns:a="http://schemas.openxmlformats.org/drawingml/2006/main">
+            <a:pPr marL="0" indent="0">
+              <a:lnSpc>
+                <a:spcPct val="112000"/>
+              </a:lnSpc>
+              <a:spcBef>
+                <a:spcPts val="0"/>
+              </a:spcBef>
+              <a:spcAft>
+                <a:spcPts val="0"/>
+              </a:spcAft>
+              <a:buNone/>
+              <a:defRPr sz="1500">
+                <a:solidFill>
+                  <a:srgbClr val="FFFFFF"/>
+                </a:solidFill>
+                <a:latin typeface="Consolas"/>
+                <a:ea typeface="Consolas"/>
+                <a:cs typeface="Consolas"/>
+              </a:defRPr>
+            </a:pPr>
+            <a:r>
+              <a:rPr sz="1500">
+                <a:solidFill>
+                  <a:srgbClr val="FFFFFF"/>
+                </a:solidFill>
+                <a:latin typeface="Consolas"/>
+                <a:ea typeface="Consolas"/>
+                <a:cs typeface="Consolas"/>
+              </a:rPr>
+              <a:t># All comparisons passed</a:t>
             </a:r>
           </a:p>
         </p:txBody>
@@ -9496,7 +9596,7 @@
           <p:cNvPr id="534" name="Takeaway">
             <a:extLst xmlns:a="http://schemas.openxmlformats.org/drawingml/2006/main">
               <a:ext uri="{FF2B5EF4-FFF2-40B4-BE49-F238E27FC236}">
-                <a16:creationId xmlns:a16="http://schemas.microsoft.com/office/drawing/2014/main" id="{2D7CA752-A039-47A5-82F4-57EAA013361B}"/>
+                <a16:creationId xmlns:a16="http://schemas.microsoft.com/office/drawing/2014/main" id="{A267754F-AF0F-44C3-8F87-8E9111DFBD20}"/>
               </a:ext>
             </a:extLst>
           </p:cNvPr>
@@ -9564,7 +9664,7 @@
                 <a:ea typeface="Arial"/>
                 <a:cs typeface="Arial"/>
               </a:rPr>
-              <a:t>A parsed-field count and a parsed value answer different questions.</a:t>
+              <a:t>Simplified teaching example with altered checks. Derive your own bomb's rule from its instructions.</a:t>
             </a:r>
           </a:p>
         </p:txBody>
@@ -9805,7 +9905,7 @@
                 <a:ea typeface="Arial"/>
                 <a:cs typeface="Arial"/>
               </a:rPr>
-              <a:t>Loops and lookup tables</a:t>
+              <a:t>Calls and pointer structures</a:t>
             </a:r>
           </a:p>
         </p:txBody>
@@ -10041,7 +10141,7 @@
                 <a:ea typeface="Arial"/>
                 <a:cs typeface="Arial"/>
               </a:rPr>
-              <a:t>For a loop, track the index and which earlier elements the code reads.</a:t>
+              <a:t>call enters a helper; ret returns to the instruction after the call.</a:t>
             </a:r>
           </a:p>
           <a:p xmlns:a="http://schemas.openxmlformats.org/drawingml/2006/main">
@@ -10091,7 +10191,7 @@
                 <a:ea typeface="Arial"/>
                 <a:cs typeface="Arial"/>
               </a:rPr>
-              <a:t>For a table, find the base address, entry size, and index bounds.</a:t>
+              <a:t>In this example, %rdi holds a node address. The 4-byte data field is at offset 0; the next pointer is at offset 8.</a:t>
             </a:r>
           </a:p>
           <a:p xmlns:a="http://schemas.openxmlformats.org/drawingml/2006/main">
@@ -10141,7 +10241,7 @@
                 <a:ea typeface="Arial"/>
                 <a:cs typeface="Arial"/>
               </a:rPr>
-              <a:t>A mask can reduce an input before the program uses it as an index.</a:t>
+              <a:t>Which instruction reads data? Which follows a pointer?</a:t>
             </a:r>
           </a:p>
         </p:txBody>
@@ -10175,7 +10275,7 @@
           </a:bodyPr>
           <a:lstStyle xmlns:a="http://schemas.openxmlformats.org/drawingml/2006/main">
             <a:defPPr>
-              <a:defRPr sz="1800">
+              <a:defRPr sz="1500">
                 <a:solidFill>
                   <a:srgbClr val="FFFFFF"/>
                 </a:solidFill>
@@ -10359,58 +10459,58 @@
                 <a:spcPts val="0"/>
               </a:spcAft>
               <a:buNone/>
-              <a:defRPr sz="1800">
-                <a:solidFill>
-                  <a:srgbClr val="FFFFFF"/>
-                </a:solidFill>
-                <a:latin typeface="Consolas"/>
-                <a:ea typeface="Consolas"/>
-                <a:cs typeface="Consolas"/>
-              </a:defRPr>
-            </a:pPr>
-            <a:r>
-              <a:rPr sz="1800">
-                <a:solidFill>
-                  <a:srgbClr val="FFFFFF"/>
-                </a:solidFill>
-                <a:latin typeface="Consolas"/>
-                <a:ea typeface="Consolas"/>
-                <a:cs typeface="Consolas"/>
-              </a:rPr>
-              <a:t>Loop notes</a:t>
-            </a:r>
-          </a:p>
-          <a:p xmlns:a="http://schemas.openxmlformats.org/drawingml/2006/main">
-            <a:pPr marL="0" indent="0">
-              <a:lnSpc>
-                <a:spcPct val="112000"/>
-              </a:lnSpc>
-              <a:spcBef>
-                <a:spcPts val="0"/>
-              </a:spcBef>
-              <a:spcAft>
-                <a:spcPts val="0"/>
-              </a:spcAft>
-              <a:buNone/>
-              <a:defRPr sz="1800">
-                <a:solidFill>
-                  <a:srgbClr val="FFFFFF"/>
-                </a:solidFill>
-                <a:latin typeface="Consolas"/>
-                <a:ea typeface="Consolas"/>
-                <a:cs typeface="Consolas"/>
-              </a:defRPr>
-            </a:pPr>
-            <a:r>
-              <a:rPr sz="1800">
-                <a:solidFill>
-                  <a:srgbClr val="FFFFFF"/>
-                </a:solidFill>
-                <a:latin typeface="Consolas"/>
-                <a:ea typeface="Consolas"/>
-                <a:cs typeface="Consolas"/>
-              </a:rPr>
-              <a:t>index    values read    value written</a:t>
+              <a:defRPr sz="1500">
+                <a:solidFill>
+                  <a:srgbClr val="FFFFFF"/>
+                </a:solidFill>
+                <a:latin typeface="Consolas"/>
+                <a:ea typeface="Consolas"/>
+                <a:cs typeface="Consolas"/>
+              </a:defRPr>
+            </a:pPr>
+            <a:r>
+              <a:rPr sz="1500">
+                <a:solidFill>
+                  <a:srgbClr val="FFFFFF"/>
+                </a:solidFill>
+                <a:latin typeface="Consolas"/>
+                <a:ea typeface="Consolas"/>
+                <a:cs typeface="Consolas"/>
+              </a:rPr>
+              <a:t># Caller: rdi holds the head pointer</a:t>
+            </a:r>
+          </a:p>
+          <a:p xmlns:a="http://schemas.openxmlformats.org/drawingml/2006/main">
+            <a:pPr marL="0" indent="0">
+              <a:lnSpc>
+                <a:spcPct val="112000"/>
+              </a:lnSpc>
+              <a:spcBef>
+                <a:spcPts val="0"/>
+              </a:spcBef>
+              <a:spcAft>
+                <a:spcPts val="0"/>
+              </a:spcAft>
+              <a:buNone/>
+              <a:defRPr sz="1500">
+                <a:solidFill>
+                  <a:srgbClr val="FFFFFF"/>
+                </a:solidFill>
+                <a:latin typeface="Consolas"/>
+                <a:ea typeface="Consolas"/>
+                <a:cs typeface="Consolas"/>
+              </a:defRPr>
+            </a:pPr>
+            <a:r>
+              <a:rPr sz="1500">
+                <a:solidFill>
+                  <a:srgbClr val="FFFFFF"/>
+                </a:solidFill>
+                <a:latin typeface="Consolas"/>
+                <a:ea typeface="Consolas"/>
+                <a:cs typeface="Consolas"/>
+              </a:rPr>
+              <a:t>call sum_nodes     # result in eax</a:t>
             </a:r>
           </a:p>
           <a:p xmlns:a="http://schemas.openxmlformats.org/drawingml/2006/main">
@@ -10442,141 +10542,355 @@
                 <a:spcPts val="0"/>
               </a:spcAft>
               <a:buNone/>
-              <a:defRPr sz="1800">
-                <a:solidFill>
-                  <a:srgbClr val="FFFFFF"/>
-                </a:solidFill>
-                <a:latin typeface="Consolas"/>
-                <a:ea typeface="Consolas"/>
-                <a:cs typeface="Consolas"/>
-              </a:defRPr>
-            </a:pPr>
-            <a:r>
-              <a:rPr sz="1800">
-                <a:solidFill>
-                  <a:srgbClr val="FFFFFF"/>
-                </a:solidFill>
-                <a:latin typeface="Consolas"/>
-                <a:ea typeface="Consolas"/>
-                <a:cs typeface="Consolas"/>
-              </a:rPr>
-              <a:t>Address calculation</a:t>
-            </a:r>
-          </a:p>
-          <a:p xmlns:a="http://schemas.openxmlformats.org/drawingml/2006/main">
-            <a:pPr marL="0" indent="0">
-              <a:lnSpc>
-                <a:spcPct val="112000"/>
-              </a:lnSpc>
-              <a:spcBef>
-                <a:spcPts val="0"/>
-              </a:spcBef>
-              <a:spcAft>
-                <a:spcPts val="0"/>
-              </a:spcAft>
-              <a:buNone/>
-              <a:defRPr sz="1800">
-                <a:solidFill>
-                  <a:srgbClr val="FFFFFF"/>
-                </a:solidFill>
-                <a:latin typeface="Consolas"/>
-                <a:ea typeface="Consolas"/>
-                <a:cs typeface="Consolas"/>
-              </a:defRPr>
-            </a:pPr>
-            <a:r>
-              <a:rPr sz="1800">
-                <a:solidFill>
-                  <a:srgbClr val="FFFFFF"/>
-                </a:solidFill>
-                <a:latin typeface="Consolas"/>
-                <a:ea typeface="Consolas"/>
-                <a:cs typeface="Consolas"/>
-              </a:rPr>
-              <a:t>base + index * element_size</a:t>
-            </a:r>
-          </a:p>
-          <a:p xmlns:a="http://schemas.openxmlformats.org/drawingml/2006/main">
-            <a:pPr marL="0" indent="0">
-              <a:lnSpc>
-                <a:spcPct val="112000"/>
-              </a:lnSpc>
-              <a:spcBef>
-                <a:spcPts val="0"/>
-              </a:spcBef>
-              <a:spcAft>
-                <a:spcPts val="0"/>
-              </a:spcAft>
-              <a:buNone/>
-            </a:pPr>
-            <a:r>
-              <a:t/>
-            </a:r>
-          </a:p>
-          <a:p xmlns:a="http://schemas.openxmlformats.org/drawingml/2006/main">
-            <a:pPr marL="0" indent="0">
-              <a:lnSpc>
-                <a:spcPct val="112000"/>
-              </a:lnSpc>
-              <a:spcBef>
-                <a:spcPts val="0"/>
-              </a:spcBef>
-              <a:spcAft>
-                <a:spcPts val="0"/>
-              </a:spcAft>
-              <a:buNone/>
-              <a:defRPr sz="1800">
-                <a:solidFill>
-                  <a:srgbClr val="FFFFFF"/>
-                </a:solidFill>
-                <a:latin typeface="Consolas"/>
-                <a:ea typeface="Consolas"/>
-                <a:cs typeface="Consolas"/>
-              </a:defRPr>
-            </a:pPr>
-            <a:r>
-              <a:rPr sz="1800">
-                <a:solidFill>
-                  <a:srgbClr val="FFFFFF"/>
-                </a:solidFill>
-                <a:latin typeface="Consolas"/>
-                <a:ea typeface="Consolas"/>
-                <a:cs typeface="Consolas"/>
-              </a:rPr>
-              <a:t>After a mask</a:t>
-            </a:r>
-          </a:p>
-          <a:p xmlns:a="http://schemas.openxmlformats.org/drawingml/2006/main">
-            <a:pPr marL="0" indent="0">
-              <a:lnSpc>
-                <a:spcPct val="112000"/>
-              </a:lnSpc>
-              <a:spcBef>
-                <a:spcPts val="0"/>
-              </a:spcBef>
-              <a:spcAft>
-                <a:spcPts val="0"/>
-              </a:spcAft>
-              <a:buNone/>
-              <a:defRPr sz="1800">
-                <a:solidFill>
-                  <a:srgbClr val="FFFFFF"/>
-                </a:solidFill>
-                <a:latin typeface="Consolas"/>
-                <a:ea typeface="Consolas"/>
-                <a:cs typeface="Consolas"/>
-              </a:defRPr>
-            </a:pPr>
-            <a:r>
-              <a:rPr sz="1800">
-                <a:solidFill>
-                  <a:srgbClr val="FFFFFF"/>
-                </a:solidFill>
-                <a:latin typeface="Consolas"/>
-                <a:ea typeface="Consolas"/>
-                <a:cs typeface="Consolas"/>
-              </a:rPr>
-              <a:t>track the masked index</a:t>
+              <a:defRPr sz="1500">
+                <a:solidFill>
+                  <a:srgbClr val="FFFFFF"/>
+                </a:solidFill>
+                <a:latin typeface="Consolas"/>
+                <a:ea typeface="Consolas"/>
+                <a:cs typeface="Consolas"/>
+              </a:defRPr>
+            </a:pPr>
+            <a:r>
+              <a:rPr sz="1500">
+                <a:solidFill>
+                  <a:srgbClr val="FFFFFF"/>
+                </a:solidFill>
+                <a:latin typeface="Consolas"/>
+                <a:ea typeface="Consolas"/>
+                <a:cs typeface="Consolas"/>
+              </a:rPr>
+              <a:t># Helper function</a:t>
+            </a:r>
+          </a:p>
+          <a:p xmlns:a="http://schemas.openxmlformats.org/drawingml/2006/main">
+            <a:pPr marL="0" indent="0">
+              <a:lnSpc>
+                <a:spcPct val="112000"/>
+              </a:lnSpc>
+              <a:spcBef>
+                <a:spcPts val="0"/>
+              </a:spcBef>
+              <a:spcAft>
+                <a:spcPts val="0"/>
+              </a:spcAft>
+              <a:buNone/>
+              <a:defRPr sz="1500">
+                <a:solidFill>
+                  <a:srgbClr val="FFFFFF"/>
+                </a:solidFill>
+                <a:latin typeface="Consolas"/>
+                <a:ea typeface="Consolas"/>
+                <a:cs typeface="Consolas"/>
+              </a:defRPr>
+            </a:pPr>
+            <a:r>
+              <a:rPr sz="1500">
+                <a:solidFill>
+                  <a:srgbClr val="FFFFFF"/>
+                </a:solidFill>
+                <a:latin typeface="Consolas"/>
+                <a:ea typeface="Consolas"/>
+                <a:cs typeface="Consolas"/>
+              </a:rPr>
+              <a:t>sum_nodes:</a:t>
+            </a:r>
+          </a:p>
+          <a:p xmlns:a="http://schemas.openxmlformats.org/drawingml/2006/main">
+            <a:pPr marL="0" indent="0">
+              <a:lnSpc>
+                <a:spcPct val="112000"/>
+              </a:lnSpc>
+              <a:spcBef>
+                <a:spcPts val="0"/>
+              </a:spcBef>
+              <a:spcAft>
+                <a:spcPts val="0"/>
+              </a:spcAft>
+              <a:buNone/>
+              <a:defRPr sz="1500">
+                <a:solidFill>
+                  <a:srgbClr val="FFFFFF"/>
+                </a:solidFill>
+                <a:latin typeface="Consolas"/>
+                <a:ea typeface="Consolas"/>
+                <a:cs typeface="Consolas"/>
+              </a:defRPr>
+            </a:pPr>
+            <a:r>
+              <a:rPr sz="1500">
+                <a:solidFill>
+                  <a:srgbClr val="FFFFFF"/>
+                </a:solidFill>
+                <a:latin typeface="Consolas"/>
+                <a:ea typeface="Consolas"/>
+                <a:cs typeface="Consolas"/>
+              </a:rPr>
+              <a:t>  xorl %eax, %eax</a:t>
+            </a:r>
+          </a:p>
+          <a:p xmlns:a="http://schemas.openxmlformats.org/drawingml/2006/main">
+            <a:pPr marL="0" indent="0">
+              <a:lnSpc>
+                <a:spcPct val="112000"/>
+              </a:lnSpc>
+              <a:spcBef>
+                <a:spcPts val="0"/>
+              </a:spcBef>
+              <a:spcAft>
+                <a:spcPts val="0"/>
+              </a:spcAft>
+              <a:buNone/>
+              <a:defRPr sz="1500">
+                <a:solidFill>
+                  <a:srgbClr val="FFFFFF"/>
+                </a:solidFill>
+                <a:latin typeface="Consolas"/>
+                <a:ea typeface="Consolas"/>
+                <a:cs typeface="Consolas"/>
+              </a:defRPr>
+            </a:pPr>
+            <a:r>
+              <a:rPr sz="1500">
+                <a:solidFill>
+                  <a:srgbClr val="FFFFFF"/>
+                </a:solidFill>
+                <a:latin typeface="Consolas"/>
+                <a:ea typeface="Consolas"/>
+                <a:cs typeface="Consolas"/>
+              </a:rPr>
+              <a:t>visit:</a:t>
+            </a:r>
+          </a:p>
+          <a:p xmlns:a="http://schemas.openxmlformats.org/drawingml/2006/main">
+            <a:pPr marL="0" indent="0">
+              <a:lnSpc>
+                <a:spcPct val="112000"/>
+              </a:lnSpc>
+              <a:spcBef>
+                <a:spcPts val="0"/>
+              </a:spcBef>
+              <a:spcAft>
+                <a:spcPts val="0"/>
+              </a:spcAft>
+              <a:buNone/>
+              <a:defRPr sz="1500">
+                <a:solidFill>
+                  <a:srgbClr val="FFFFFF"/>
+                </a:solidFill>
+                <a:latin typeface="Consolas"/>
+                <a:ea typeface="Consolas"/>
+                <a:cs typeface="Consolas"/>
+              </a:defRPr>
+            </a:pPr>
+            <a:r>
+              <a:rPr sz="1500">
+                <a:solidFill>
+                  <a:srgbClr val="FFFFFF"/>
+                </a:solidFill>
+                <a:latin typeface="Consolas"/>
+                <a:ea typeface="Consolas"/>
+                <a:cs typeface="Consolas"/>
+              </a:rPr>
+              <a:t>  testq %rdi, %rdi</a:t>
+            </a:r>
+          </a:p>
+          <a:p xmlns:a="http://schemas.openxmlformats.org/drawingml/2006/main">
+            <a:pPr marL="0" indent="0">
+              <a:lnSpc>
+                <a:spcPct val="112000"/>
+              </a:lnSpc>
+              <a:spcBef>
+                <a:spcPts val="0"/>
+              </a:spcBef>
+              <a:spcAft>
+                <a:spcPts val="0"/>
+              </a:spcAft>
+              <a:buNone/>
+              <a:defRPr sz="1500">
+                <a:solidFill>
+                  <a:srgbClr val="FFFFFF"/>
+                </a:solidFill>
+                <a:latin typeface="Consolas"/>
+                <a:ea typeface="Consolas"/>
+                <a:cs typeface="Consolas"/>
+              </a:defRPr>
+            </a:pPr>
+            <a:r>
+              <a:rPr sz="1500">
+                <a:solidFill>
+                  <a:srgbClr val="FFFFFF"/>
+                </a:solidFill>
+                <a:latin typeface="Consolas"/>
+                <a:ea typeface="Consolas"/>
+                <a:cs typeface="Consolas"/>
+              </a:rPr>
+              <a:t>  je done</a:t>
+            </a:r>
+          </a:p>
+          <a:p xmlns:a="http://schemas.openxmlformats.org/drawingml/2006/main">
+            <a:pPr marL="0" indent="0">
+              <a:lnSpc>
+                <a:spcPct val="112000"/>
+              </a:lnSpc>
+              <a:spcBef>
+                <a:spcPts val="0"/>
+              </a:spcBef>
+              <a:spcAft>
+                <a:spcPts val="0"/>
+              </a:spcAft>
+              <a:buNone/>
+              <a:defRPr sz="1500">
+                <a:solidFill>
+                  <a:srgbClr val="FFFFFF"/>
+                </a:solidFill>
+                <a:latin typeface="Consolas"/>
+                <a:ea typeface="Consolas"/>
+                <a:cs typeface="Consolas"/>
+              </a:defRPr>
+            </a:pPr>
+            <a:r>
+              <a:rPr sz="1500">
+                <a:solidFill>
+                  <a:srgbClr val="FFFFFF"/>
+                </a:solidFill>
+                <a:latin typeface="Consolas"/>
+                <a:ea typeface="Consolas"/>
+                <a:cs typeface="Consolas"/>
+              </a:rPr>
+              <a:t>  addl (%rdi), %eax</a:t>
+            </a:r>
+          </a:p>
+          <a:p xmlns:a="http://schemas.openxmlformats.org/drawingml/2006/main">
+            <a:pPr marL="0" indent="0">
+              <a:lnSpc>
+                <a:spcPct val="112000"/>
+              </a:lnSpc>
+              <a:spcBef>
+                <a:spcPts val="0"/>
+              </a:spcBef>
+              <a:spcAft>
+                <a:spcPts val="0"/>
+              </a:spcAft>
+              <a:buNone/>
+              <a:defRPr sz="1500">
+                <a:solidFill>
+                  <a:srgbClr val="FFFFFF"/>
+                </a:solidFill>
+                <a:latin typeface="Consolas"/>
+                <a:ea typeface="Consolas"/>
+                <a:cs typeface="Consolas"/>
+              </a:defRPr>
+            </a:pPr>
+            <a:r>
+              <a:rPr sz="1500">
+                <a:solidFill>
+                  <a:srgbClr val="FFFFFF"/>
+                </a:solidFill>
+                <a:latin typeface="Consolas"/>
+                <a:ea typeface="Consolas"/>
+                <a:cs typeface="Consolas"/>
+              </a:rPr>
+              <a:t>  movq 8(%rdi), %rdi</a:t>
+            </a:r>
+          </a:p>
+          <a:p xmlns:a="http://schemas.openxmlformats.org/drawingml/2006/main">
+            <a:pPr marL="0" indent="0">
+              <a:lnSpc>
+                <a:spcPct val="112000"/>
+              </a:lnSpc>
+              <a:spcBef>
+                <a:spcPts val="0"/>
+              </a:spcBef>
+              <a:spcAft>
+                <a:spcPts val="0"/>
+              </a:spcAft>
+              <a:buNone/>
+              <a:defRPr sz="1500">
+                <a:solidFill>
+                  <a:srgbClr val="FFFFFF"/>
+                </a:solidFill>
+                <a:latin typeface="Consolas"/>
+                <a:ea typeface="Consolas"/>
+                <a:cs typeface="Consolas"/>
+              </a:defRPr>
+            </a:pPr>
+            <a:r>
+              <a:rPr sz="1500">
+                <a:solidFill>
+                  <a:srgbClr val="FFFFFF"/>
+                </a:solidFill>
+                <a:latin typeface="Consolas"/>
+                <a:ea typeface="Consolas"/>
+                <a:cs typeface="Consolas"/>
+              </a:rPr>
+              <a:t>  jmp visit</a:t>
+            </a:r>
+          </a:p>
+          <a:p xmlns:a="http://schemas.openxmlformats.org/drawingml/2006/main">
+            <a:pPr marL="0" indent="0">
+              <a:lnSpc>
+                <a:spcPct val="112000"/>
+              </a:lnSpc>
+              <a:spcBef>
+                <a:spcPts val="0"/>
+              </a:spcBef>
+              <a:spcAft>
+                <a:spcPts val="0"/>
+              </a:spcAft>
+              <a:buNone/>
+              <a:defRPr sz="1500">
+                <a:solidFill>
+                  <a:srgbClr val="FFFFFF"/>
+                </a:solidFill>
+                <a:latin typeface="Consolas"/>
+                <a:ea typeface="Consolas"/>
+                <a:cs typeface="Consolas"/>
+              </a:defRPr>
+            </a:pPr>
+            <a:r>
+              <a:rPr sz="1500">
+                <a:solidFill>
+                  <a:srgbClr val="FFFFFF"/>
+                </a:solidFill>
+                <a:latin typeface="Consolas"/>
+                <a:ea typeface="Consolas"/>
+                <a:cs typeface="Consolas"/>
+              </a:rPr>
+              <a:t>done:</a:t>
+            </a:r>
+          </a:p>
+          <a:p xmlns:a="http://schemas.openxmlformats.org/drawingml/2006/main">
+            <a:pPr marL="0" indent="0">
+              <a:lnSpc>
+                <a:spcPct val="112000"/>
+              </a:lnSpc>
+              <a:spcBef>
+                <a:spcPts val="0"/>
+              </a:spcBef>
+              <a:spcAft>
+                <a:spcPts val="0"/>
+              </a:spcAft>
+              <a:buNone/>
+              <a:defRPr sz="1500">
+                <a:solidFill>
+                  <a:srgbClr val="FFFFFF"/>
+                </a:solidFill>
+                <a:latin typeface="Consolas"/>
+                <a:ea typeface="Consolas"/>
+                <a:cs typeface="Consolas"/>
+              </a:defRPr>
+            </a:pPr>
+            <a:r>
+              <a:rPr sz="1500">
+                <a:solidFill>
+                  <a:srgbClr val="FFFFFF"/>
+                </a:solidFill>
+                <a:latin typeface="Consolas"/>
+                <a:ea typeface="Consolas"/>
+                <a:cs typeface="Consolas"/>
+              </a:rPr>
+              <a:t>  ret</a:t>
             </a:r>
           </a:p>
         </p:txBody>
@@ -10586,7 +10900,7 @@
           <p:cNvPr id="534" name="Takeaway">
             <a:extLst xmlns:a="http://schemas.openxmlformats.org/drawingml/2006/main">
               <a:ext uri="{FF2B5EF4-FFF2-40B4-BE49-F238E27FC236}">
-                <a16:creationId xmlns:a16="http://schemas.microsoft.com/office/drawing/2014/main" id="{A8C40A3E-506F-46F1-B1BF-ABB874D3FA56}"/>
+                <a16:creationId xmlns:a16="http://schemas.microsoft.com/office/drawing/2014/main" id="{14EE4096-1CAE-4409-833E-D346C04A438A}"/>
               </a:ext>
             </a:extLst>
           </p:cNvPr>
@@ -10654,7 +10968,7 @@
                 <a:ea typeface="Arial"/>
                 <a:cs typeface="Arial"/>
               </a:rPr>
-              <a:t>Derive the relationship from the instructions. Familiar-looking sequences can use different rules.</a:t>
+              <a:t>Toy linked-list traversal. Field offsets and checks in your bomb may differ.</a:t>
             </a:r>
           </a:p>
         </p:txBody>
@@ -10895,7 +11209,7 @@
                 <a:ea typeface="Arial"/>
                 <a:cs typeface="Arial"/>
               </a:rPr>
-              <a:t>Calls and pointer structures</a:t>
+              <a:t>Saving confirmed inputs</a:t>
             </a:r>
           </a:p>
         </p:txBody>
@@ -11131,7 +11445,7 @@
                 <a:ea typeface="Arial"/>
                 <a:cs typeface="Arial"/>
               </a:rPr>
-              <a:t>For recursive code, identify the stopping condition and how each call changes its arguments.</a:t>
+              <a:t>Keep a separate text file with one confirmed phase input per line, in order.</a:t>
             </a:r>
           </a:p>
           <a:p xmlns:a="http://schemas.openxmlformats.org/drawingml/2006/main">
@@ -11181,7 +11495,7 @@
                 <a:ea typeface="Arial"/>
                 <a:cs typeface="Arial"/>
               </a:rPr>
-              <a:t>For pointer structures, distinguish a node's value from its next pointer.</a:t>
+              <a:t>Read bomb.c to check whether your version accepts that file as a command-line argument.</a:t>
             </a:r>
           </a:p>
           <a:p xmlns:a="http://schemas.openxmlformats.org/drawingml/2006/main">
@@ -11231,7 +11545,7 @@
                 <a:ea typeface="Arial"/>
                 <a:cs typeface="Arial"/>
               </a:rPr>
-              <a:t>Write down each address you visit before following the next link.</a:t>
+              <a:t>Keep your own notes on why each line passes.</a:t>
             </a:r>
           </a:p>
         </p:txBody>
@@ -11467,7 +11781,7 @@
                 <a:ea typeface="Consolas"/>
                 <a:cs typeface="Consolas"/>
               </a:rPr>
-              <a:t>Recursive trace</a:t>
+              <a:t># If bomb.c supports a filename</a:t>
             </a:r>
           </a:p>
           <a:p xmlns:a="http://schemas.openxmlformats.org/drawingml/2006/main">
@@ -11500,7 +11814,7 @@
                 <a:ea typeface="Consolas"/>
                 <a:cs typeface="Consolas"/>
               </a:rPr>
-              <a:t>arguments    base case    return value</a:t>
+              <a:t>(gdb) run answers.txt</a:t>
             </a:r>
           </a:p>
           <a:p xmlns:a="http://schemas.openxmlformats.org/drawingml/2006/main">
@@ -11550,7 +11864,7 @@
                 <a:ea typeface="Consolas"/>
                 <a:cs typeface="Consolas"/>
               </a:rPr>
-              <a:t>Pointer trace</a:t>
+              <a:t># Otherwise, stdin redirection</a:t>
             </a:r>
           </a:p>
           <a:p xmlns:a="http://schemas.openxmlformats.org/drawingml/2006/main">
@@ -11583,7 +11897,7 @@
                 <a:ea typeface="Consolas"/>
                 <a:cs typeface="Consolas"/>
               </a:rPr>
-              <a:t>node address    data    next address</a:t>
+              <a:t>(gdb) run &lt; answers.txt</a:t>
             </a:r>
           </a:p>
           <a:p xmlns:a="http://schemas.openxmlformats.org/drawingml/2006/main">
@@ -11633,7 +11947,7 @@
                 <a:ea typeface="Consolas"/>
                 <a:cs typeface="Consolas"/>
               </a:rPr>
-              <a:t>Array index and node value</a:t>
+              <a:t># Breakpoints remain in this session</a:t>
             </a:r>
           </a:p>
           <a:p xmlns:a="http://schemas.openxmlformats.org/drawingml/2006/main">
@@ -11666,7 +11980,7 @@
                 <a:ea typeface="Consolas"/>
                 <a:cs typeface="Consolas"/>
               </a:rPr>
-              <a:t>may represent different things.</a:t>
+              <a:t>(gdb) info breakpoints</a:t>
             </a:r>
           </a:p>
         </p:txBody>
@@ -11676,7 +11990,7 @@
           <p:cNvPr id="534" name="Takeaway">
             <a:extLst xmlns:a="http://schemas.openxmlformats.org/drawingml/2006/main">
               <a:ext uri="{FF2B5EF4-FFF2-40B4-BE49-F238E27FC236}">
-                <a16:creationId xmlns:a16="http://schemas.microsoft.com/office/drawing/2014/main" id="{DCC8A476-25A2-4001-852E-5E0C297EDBC2}"/>
+                <a16:creationId xmlns:a16="http://schemas.microsoft.com/office/drawing/2014/main" id="{C89C64EC-AD69-43F5-81DF-701E50AFF121}"/>
               </a:ext>
             </a:extLst>
           </p:cNvPr>
@@ -11744,7 +12058,7 @@
                 <a:ea typeface="Arial"/>
                 <a:cs typeface="Arial"/>
               </a:rPr>
-              <a:t>Assembly offsets reveal which field the program reads and how it uses that field.</a:t>
+              <a:t>An argument file and stdin redirection handle end-of-file differently. Check your version before relying on either.</a:t>
             </a:r>
           </a:p>
         </p:txBody>
@@ -11985,7 +12299,7 @@
                 <a:ea typeface="Arial"/>
                 <a:cs typeface="Arial"/>
               </a:rPr>
-              <a:t>Saving confirmed inputs</a:t>
+              <a:t>A phase investigation</a:t>
             </a:r>
           </a:p>
         </p:txBody>
@@ -12221,7 +12535,7 @@
                 <a:ea typeface="Arial"/>
                 <a:cs typeface="Arial"/>
               </a:rPr>
-              <a:t>Keep a separate text file with one confirmed phase input per line, in order.</a:t>
+              <a:t>Pause at the phase entry.</a:t>
             </a:r>
           </a:p>
           <a:p xmlns:a="http://schemas.openxmlformats.org/drawingml/2006/main">
@@ -12271,7 +12585,7 @@
                 <a:ea typeface="Arial"/>
                 <a:cs typeface="Arial"/>
               </a:rPr>
-              <a:t>Read bomb.c to check whether your version accepts that file as a command-line argument.</a:t>
+              <a:t>Identify the input format and failure branches.</a:t>
             </a:r>
           </a:p>
           <a:p xmlns:a="http://schemas.openxmlformats.org/drawingml/2006/main">
@@ -12321,7 +12635,57 @@
                 <a:ea typeface="Arial"/>
                 <a:cs typeface="Arial"/>
               </a:rPr>
-              <a:t>Keep your own notes on why each line passes.</a:t>
+              <a:t>Track the registers or memory that each check uses.</a:t>
+            </a:r>
+          </a:p>
+          <a:p xmlns:a="http://schemas.openxmlformats.org/drawingml/2006/main">
+            <a:pPr marL="0" indent="0">
+              <a:lnSpc>
+                <a:spcPct val="112000"/>
+              </a:lnSpc>
+              <a:spcBef>
+                <a:spcPts val="0"/>
+              </a:spcBef>
+              <a:spcAft>
+                <a:spcPts val="0"/>
+              </a:spcAft>
+              <a:buNone/>
+            </a:pPr>
+            <a:r>
+              <a:t/>
+            </a:r>
+          </a:p>
+          <a:p xmlns:a="http://schemas.openxmlformats.org/drawingml/2006/main">
+            <a:pPr marL="0" indent="0">
+              <a:lnSpc>
+                <a:spcPct val="112000"/>
+              </a:lnSpc>
+              <a:spcBef>
+                <a:spcPts val="0"/>
+              </a:spcBef>
+              <a:spcAft>
+                <a:spcPts val="0"/>
+              </a:spcAft>
+              <a:buNone/>
+              <a:defRPr sz="1875">
+                <a:solidFill>
+                  <a:srgbClr val="FFFFFF"/>
+                </a:solidFill>
+                <a:latin typeface="Arial"/>
+                <a:ea typeface="Arial"/>
+                <a:cs typeface="Arial"/>
+              </a:defRPr>
+            </a:pPr>
+            <a:r>
+              <a:rPr sz="1875">
+                <a:solidFill>
+                  <a:srgbClr val="FFFFFF"/>
+                </a:solidFill>
+                <a:latin typeface="Arial"/>
+                <a:ea typeface="Arial"/>
+                <a:cs typeface="Arial"/>
+              </a:rPr>
+              <a:t>Test a candidate only after you can explain it.</a:t>
             </a:r>
           </a:p>
         </p:txBody>
@@ -12557,7 +12921,24 @@
                 <a:ea typeface="Consolas"/>
                 <a:cs typeface="Consolas"/>
               </a:rPr>
-              <a:t># If bomb.c supports a filename</a:t>
+              <a:t>Useful notes to keep</a:t>
+            </a:r>
+          </a:p>
+          <a:p xmlns:a="http://schemas.openxmlformats.org/drawingml/2006/main">
+            <a:pPr marL="0" indent="0">
+              <a:lnSpc>
+                <a:spcPct val="112000"/>
+              </a:lnSpc>
+              <a:spcBef>
+                <a:spcPts val="0"/>
+              </a:spcBef>
+              <a:spcAft>
+                <a:spcPts val="0"/>
+              </a:spcAft>
+              <a:buNone/>
+            </a:pPr>
+            <a:r>
+              <a:t/>
             </a:r>
           </a:p>
           <a:p xmlns:a="http://schemas.openxmlformats.org/drawingml/2006/main">
@@ -12590,24 +12971,7 @@
                 <a:ea typeface="Consolas"/>
                 <a:cs typeface="Consolas"/>
               </a:rPr>
-              <a:t>(gdb) run answers.txt</a:t>
-            </a:r>
-          </a:p>
-          <a:p xmlns:a="http://schemas.openxmlformats.org/drawingml/2006/main">
-            <a:pPr marL="0" indent="0">
-              <a:lnSpc>
-                <a:spcPct val="112000"/>
-              </a:lnSpc>
-              <a:spcBef>
-                <a:spcPts val="0"/>
-              </a:spcBef>
-              <a:spcAft>
-                <a:spcPts val="0"/>
-              </a:spcAft>
-              <a:buNone/>
-            </a:pPr>
-            <a:r>
-              <a:t/>
+              <a:t>Function and instruction address</a:t>
             </a:r>
           </a:p>
           <a:p xmlns:a="http://schemas.openxmlformats.org/drawingml/2006/main">
@@ -12640,7 +13004,7 @@
                 <a:ea typeface="Consolas"/>
                 <a:cs typeface="Consolas"/>
               </a:rPr>
-              <a:t># Otherwise, stdin redirection</a:t>
+              <a:t>Input fields</a:t>
             </a:r>
           </a:p>
           <a:p xmlns:a="http://schemas.openxmlformats.org/drawingml/2006/main">
@@ -12673,24 +13037,7 @@
                 <a:ea typeface="Consolas"/>
                 <a:cs typeface="Consolas"/>
               </a:rPr>
-              <a:t>(gdb) run &lt; answers.txt</a:t>
-            </a:r>
-          </a:p>
-          <a:p xmlns:a="http://schemas.openxmlformats.org/drawingml/2006/main">
-            <a:pPr marL="0" indent="0">
-              <a:lnSpc>
-                <a:spcPct val="112000"/>
-              </a:lnSpc>
-              <a:spcBef>
-                <a:spcPts val="0"/>
-              </a:spcBef>
-              <a:spcAft>
-                <a:spcPts val="0"/>
-              </a:spcAft>
-              <a:buNone/>
-            </a:pPr>
-            <a:r>
-              <a:t/>
+              <a:t>Condition required to pass</a:t>
             </a:r>
           </a:p>
           <a:p xmlns:a="http://schemas.openxmlformats.org/drawingml/2006/main">
@@ -12723,7 +13070,7 @@
                 <a:ea typeface="Consolas"/>
                 <a:cs typeface="Consolas"/>
               </a:rPr>
-              <a:t># Breakpoints remain in this session</a:t>
+              <a:t>Observed register or memory values</a:t>
             </a:r>
           </a:p>
           <a:p xmlns:a="http://schemas.openxmlformats.org/drawingml/2006/main">
@@ -12756,7 +13103,7 @@
                 <a:ea typeface="Consolas"/>
                 <a:cs typeface="Consolas"/>
               </a:rPr>
-              <a:t>(gdb) info breakpoints</a:t>
+              <a:t>Reason for the candidate input</a:t>
             </a:r>
           </a:p>
         </p:txBody>
@@ -12766,1130 +13113,7 @@
           <p:cNvPr id="534" name="Takeaway">
             <a:extLst xmlns:a="http://schemas.openxmlformats.org/drawingml/2006/main">
               <a:ext uri="{FF2B5EF4-FFF2-40B4-BE49-F238E27FC236}">
-                <a16:creationId xmlns:a16="http://schemas.microsoft.com/office/drawing/2014/main" id="{DC11381B-8210-4AE0-A0D3-4FD7F554D230}"/>
-              </a:ext>
-            </a:extLst>
-          </p:cNvPr>
-          <p:cNvSpPr>
-            <a:spLocks xmlns:a="http://schemas.openxmlformats.org/drawingml/2006/main" noGrp="1"/>
-          </p:cNvSpPr>
-          <p:nvPr/>
-        </p:nvSpPr>
-        <p:spPr>
-          <a:xfrm xmlns:a="http://schemas.openxmlformats.org/drawingml/2006/main">
-            <a:off x="393668" y="5715000"/>
-            <a:ext cx="11404283" cy="466725"/>
-          </a:xfrm>
-          <a:prstGeom xmlns:a="http://schemas.openxmlformats.org/drawingml/2006/main" prst="rect">
-            <a:avLst/>
-          </a:prstGeom>
-          <a:noFill xmlns:a="http://schemas.openxmlformats.org/drawingml/2006/main"/>
-          <a:ln xmlns:a="http://schemas.openxmlformats.org/drawingml/2006/main" w="0">
-            <a:noFill/>
-          </a:ln>
-        </p:spPr>
-        <p:txBody>
-          <a:bodyPr xmlns:a="http://schemas.openxmlformats.org/drawingml/2006/main" lIns="0" tIns="0" rIns="0" bIns="0" anchor="t">
-            <a:noAutofit/>
-          </a:bodyPr>
-          <a:lstStyle xmlns:a="http://schemas.openxmlformats.org/drawingml/2006/main">
-            <a:defPPr>
-              <a:defRPr sz="1350">
-                <a:solidFill>
-                  <a:srgbClr val="CCCCCC"/>
-                </a:solidFill>
-                <a:latin typeface="Arial"/>
-                <a:ea typeface="Arial"/>
-                <a:cs typeface="Arial"/>
-              </a:defRPr>
-            </a:defPPr>
-          </a:lstStyle>
-          <a:p xmlns:a="http://schemas.openxmlformats.org/drawingml/2006/main">
-            <a:pPr marL="0" indent="0">
-              <a:lnSpc>
-                <a:spcPct val="112000"/>
-              </a:lnSpc>
-              <a:spcBef>
-                <a:spcPts val="0"/>
-              </a:spcBef>
-              <a:spcAft>
-                <a:spcPts val="0"/>
-              </a:spcAft>
-              <a:buNone/>
-              <a:defRPr sz="1350">
-                <a:solidFill>
-                  <a:srgbClr val="CCCCCC"/>
-                </a:solidFill>
-                <a:latin typeface="Arial"/>
-                <a:ea typeface="Arial"/>
-                <a:cs typeface="Arial"/>
-              </a:defRPr>
-            </a:pPr>
-            <a:r>
-              <a:rPr sz="1350">
-                <a:solidFill>
-                  <a:srgbClr val="CCCCCC"/>
-                </a:solidFill>
-                <a:latin typeface="Arial"/>
-                <a:ea typeface="Arial"/>
-                <a:cs typeface="Arial"/>
-              </a:rPr>
-              <a:t>An argument file and stdin redirection handle end-of-file differently. Check your version before relying on either.</a:t>
-            </a:r>
-          </a:p>
-        </p:txBody>
-      </p:sp>
-    </p:spTree>
-    <p:extLst>
-      <p:ext uri="{BB962C8B-B14F-4D97-AF65-F5344CB8AC3E}">
-        <p14:creationId xmlns:p14="http://schemas.microsoft.com/office/powerpoint/2010/main" val="3667182145"/>
-      </p:ext>
-    </p:extLst>
-  </p:cSld>
-</p:sld>
-</file>
-
-<file path=ppt/slides/slide17.xml><?xml version="1.0" encoding="utf-8"?>
-<p:sld xmlns:p="http://schemas.openxmlformats.org/presentationml/2006/main">
-  <p:cSld>
-    <p:spTree>
-      <p:nvGrpSpPr>
-        <p:cNvPr id="1" name=""/>
-        <p:cNvGrpSpPr/>
-        <p:nvPr/>
-      </p:nvGrpSpPr>
-      <p:grpSpPr>
-        <a:xfrm xmlns:a="http://schemas.openxmlformats.org/drawingml/2006/main"/>
-      </p:grpSpPr>
-      <p:sp>
-        <p:nvSpPr>
-          <p:cNvPr id="3" name="Footer Placeholder 2">
-            <a:extLst xmlns:a="http://schemas.openxmlformats.org/drawingml/2006/main">
-              <a:ext uri="{FF2B5EF4-FFF2-40B4-BE49-F238E27FC236}">
-                <a16:creationId xmlns:a16="http://schemas.microsoft.com/office/drawing/2014/main" id="{39EA4C82-C623-0196-4A95-876ADF5DEE92}"/>
-              </a:ext>
-            </a:extLst>
-          </p:cNvPr>
-          <p:cNvSpPr>
-            <a:spLocks xmlns:a="http://schemas.openxmlformats.org/drawingml/2006/main" noGrp="1"/>
-          </p:cNvSpPr>
-          <p:nvPr>
-            <p:ph type="ftr" idx="3"/>
-          </p:nvPr>
-        </p:nvSpPr>
-        <p:spPr>
-          <a:xfrm xmlns:a="http://schemas.openxmlformats.org/drawingml/2006/main">
-            <a:off x="393700" y="6279952"/>
-            <a:ext cx="3568700" cy="241240"/>
-          </a:xfrm>
-        </p:spPr>
-        <p:txBody>
-          <a:bodyPr xmlns:a="http://schemas.openxmlformats.org/drawingml/2006/main" lIns="0" tIns="0" rIns="0" bIns="0" anchor="t">
-            <a:noAutofit/>
-          </a:bodyPr>
-          <a:lstStyle xmlns:a="http://schemas.openxmlformats.org/drawingml/2006/main">
-            <a:defPPr>
-              <a:defRPr sz="1125">
-                <a:solidFill>
-                  <a:srgbClr val="FFFFFF"/>
-                </a:solidFill>
-                <a:latin typeface="Arial"/>
-                <a:ea typeface="Arial"/>
-                <a:cs typeface="Arial"/>
-              </a:defRPr>
-            </a:defPPr>
-          </a:lstStyle>
-          <a:p xmlns:a="http://schemas.openxmlformats.org/drawingml/2006/main">
-            <a:pPr marL="0" indent="0">
-              <a:lnSpc>
-                <a:spcPct val="112000"/>
-              </a:lnSpc>
-              <a:spcBef>
-                <a:spcPts val="0"/>
-              </a:spcBef>
-              <a:spcAft>
-                <a:spcPts val="0"/>
-              </a:spcAft>
-              <a:buNone/>
-              <a:defRPr sz="1125">
-                <a:solidFill>
-                  <a:srgbClr val="FFFFFF"/>
-                </a:solidFill>
-                <a:latin typeface="Arial"/>
-                <a:ea typeface="Arial"/>
-                <a:cs typeface="Arial"/>
-              </a:defRPr>
-            </a:pPr>
-            <a:r>
-              <a:rPr sz="1125">
-                <a:solidFill>
-                  <a:srgbClr val="FFFFFF"/>
-                </a:solidFill>
-                <a:latin typeface="Arial"/>
-                <a:ea typeface="Arial"/>
-                <a:cs typeface="Arial"/>
-              </a:rPr>
-              <a:t>CS 211 · Recitation 05</a:t>
-            </a:r>
-          </a:p>
-        </p:txBody>
-      </p:sp>
-      <p:sp>
-        <p:nvSpPr>
-          <p:cNvPr id="532" name="Google Shape;532;p58">
-            <a:extLst xmlns:a="http://schemas.openxmlformats.org/drawingml/2006/main">
-              <a:ext uri="{FF2B5EF4-FFF2-40B4-BE49-F238E27FC236}">
-                <a16:creationId xmlns:a16="http://schemas.microsoft.com/office/drawing/2014/main" id="{1BCBE750-7048-686D-1472-52C53362D6CD}"/>
-              </a:ext>
-            </a:extLst>
-          </p:cNvPr>
-          <p:cNvSpPr>
-            <a:spLocks xmlns:a="http://schemas.openxmlformats.org/drawingml/2006/main" noGrp="1"/>
-          </p:cNvSpPr>
-          <p:nvPr>
-            <p:ph type="sldNum" idx="4"/>
-          </p:nvPr>
-        </p:nvSpPr>
-        <p:spPr>
-          <a:xfrm xmlns:a="http://schemas.openxmlformats.org/drawingml/2006/main">
-            <a:off x="11279332" y="6279294"/>
-            <a:ext cx="518968" cy="241240"/>
-          </a:xfrm>
-        </p:spPr>
-        <p:txBody>
-          <a:bodyPr xmlns:a="http://schemas.openxmlformats.org/drawingml/2006/main" spcFirstLastPara="1" vert="horz" wrap="square" lIns="0" tIns="0" rIns="0" bIns="0" anchor="t">
-            <a:noAutofit/>
-          </a:bodyPr>
-          <a:lstStyle xmlns:a="http://schemas.openxmlformats.org/drawingml/2006/main">
-            <a:defPPr>
-              <a:defRPr sz="1125">
-                <a:solidFill>
-                  <a:srgbClr val="FFFFFF"/>
-                </a:solidFill>
-                <a:latin typeface="Arial"/>
-                <a:ea typeface="Arial"/>
-                <a:cs typeface="Arial"/>
-              </a:defRPr>
-            </a:defPPr>
-          </a:lstStyle>
-          <a:p xmlns:a="http://schemas.openxmlformats.org/drawingml/2006/main">
-            <a:pPr marL="0" indent="0">
-              <a:lnSpc>
-                <a:spcPct val="112000"/>
-              </a:lnSpc>
-              <a:spcBef>
-                <a:spcPts val="0"/>
-              </a:spcBef>
-              <a:spcAft>
-                <a:spcPts val="0"/>
-              </a:spcAft>
-              <a:buNone/>
-              <a:defRPr sz="1125">
-                <a:solidFill>
-                  <a:srgbClr val="FFFFFF"/>
-                </a:solidFill>
-                <a:latin typeface="Arial"/>
-                <a:ea typeface="Arial"/>
-                <a:cs typeface="Arial"/>
-              </a:defRPr>
-            </a:pPr>
-            <a:r>
-              <a:rPr sz="1125">
-                <a:solidFill>
-                  <a:srgbClr val="FFFFFF"/>
-                </a:solidFill>
-                <a:latin typeface="Arial"/>
-                <a:ea typeface="Arial"/>
-                <a:cs typeface="Arial"/>
-              </a:rPr>
-              <a:t>17</a:t>
-            </a:r>
-          </a:p>
-        </p:txBody>
-      </p:sp>
-      <p:sp>
-        <p:nvSpPr>
-          <p:cNvPr id="533" name="Google Shape;533;p58">
-            <a:extLst xmlns:a="http://schemas.openxmlformats.org/drawingml/2006/main">
-              <a:ext uri="{FF2B5EF4-FFF2-40B4-BE49-F238E27FC236}">
-                <a16:creationId xmlns:a16="http://schemas.microsoft.com/office/drawing/2014/main" id="{1B5D55CD-1C17-7CD8-F26A-2DD65B067687}"/>
-              </a:ext>
-            </a:extLst>
-          </p:cNvPr>
-          <p:cNvSpPr>
-            <a:spLocks xmlns:a="http://schemas.openxmlformats.org/drawingml/2006/main" noGrp="1"/>
-          </p:cNvSpPr>
-          <p:nvPr>
-            <p:ph type="title" idx="0"/>
-          </p:nvPr>
-        </p:nvSpPr>
-        <p:spPr>
-          <a:xfrm xmlns:a="http://schemas.openxmlformats.org/drawingml/2006/main">
-            <a:off x="393700" y="344008"/>
-            <a:ext cx="11404600" cy="1047491"/>
-          </a:xfrm>
-        </p:spPr>
-        <p:txBody>
-          <a:bodyPr xmlns:a="http://schemas.openxmlformats.org/drawingml/2006/main" spcFirstLastPara="1" vert="horz" wrap="square" lIns="0" tIns="0" rIns="0" bIns="0" anchor="t">
-            <a:noAutofit/>
-          </a:bodyPr>
-          <a:lstStyle xmlns:a="http://schemas.openxmlformats.org/drawingml/2006/main">
-            <a:defPPr>
-              <a:defRPr sz="3150">
-                <a:solidFill>
-                  <a:srgbClr val="FFFFFF"/>
-                </a:solidFill>
-                <a:latin typeface="Arial"/>
-                <a:ea typeface="Arial"/>
-                <a:cs typeface="Arial"/>
-              </a:defRPr>
-            </a:defPPr>
-          </a:lstStyle>
-          <a:p xmlns:a="http://schemas.openxmlformats.org/drawingml/2006/main">
-            <a:pPr marL="0" indent="0">
-              <a:lnSpc>
-                <a:spcPct val="112000"/>
-              </a:lnSpc>
-              <a:spcBef>
-                <a:spcPts val="0"/>
-              </a:spcBef>
-              <a:spcAft>
-                <a:spcPts val="0"/>
-              </a:spcAft>
-              <a:buNone/>
-              <a:defRPr sz="3150">
-                <a:solidFill>
-                  <a:srgbClr val="FFFFFF"/>
-                </a:solidFill>
-                <a:latin typeface="Arial"/>
-                <a:ea typeface="Arial"/>
-                <a:cs typeface="Arial"/>
-              </a:defRPr>
-            </a:pPr>
-            <a:r>
-              <a:rPr sz="3150">
-                <a:solidFill>
-                  <a:srgbClr val="FFFFFF"/>
-                </a:solidFill>
-                <a:latin typeface="Arial"/>
-                <a:ea typeface="Arial"/>
-                <a:cs typeface="Arial"/>
-              </a:rPr>
-              <a:t>A phase investigation</a:t>
-            </a:r>
-          </a:p>
-        </p:txBody>
-      </p:sp>
-      <p:sp>
-        <p:nvSpPr>
-          <p:cNvPr id="7" name="Google Shape;534;p58">
-            <a:extLst xmlns:a="http://schemas.openxmlformats.org/drawingml/2006/main">
-              <a:ext uri="{FF2B5EF4-FFF2-40B4-BE49-F238E27FC236}">
-                <a16:creationId xmlns:a16="http://schemas.microsoft.com/office/drawing/2014/main" id="{3A923FEE-B8D2-CD3A-ABBD-21770B40AA24}"/>
-              </a:ext>
-            </a:extLst>
-          </p:cNvPr>
-          <p:cNvSpPr>
-            <a:spLocks xmlns:a="http://schemas.openxmlformats.org/drawingml/2006/main" noGrp="1"/>
-          </p:cNvSpPr>
-          <p:nvPr/>
-        </p:nvSpPr>
-        <p:spPr>
-          <a:xfrm xmlns:a="http://schemas.openxmlformats.org/drawingml/2006/main">
-            <a:off x="393700" y="2031999"/>
-            <a:ext cx="5537200" cy="3534787"/>
-          </a:xfrm>
-          <a:prstGeom xmlns:a="http://schemas.openxmlformats.org/drawingml/2006/main" prst="rect">
-            <a:avLst/>
-          </a:prstGeom>
-        </p:spPr>
-        <p:txBody>
-          <a:bodyPr xmlns:a="http://schemas.openxmlformats.org/drawingml/2006/main" spcFirstLastPara="1" vert="horz" wrap="square" lIns="0" tIns="0" rIns="0" bIns="0" anchor="t">
-            <a:noAutofit/>
-          </a:bodyPr>
-          <a:lstStyle xmlns:a="http://schemas.openxmlformats.org/drawingml/2006/main">
-            <a:defPPr>
-              <a:defRPr sz="1875">
-                <a:solidFill>
-                  <a:srgbClr val="FFFFFF"/>
-                </a:solidFill>
-                <a:latin typeface="Arial"/>
-                <a:ea typeface="Arial"/>
-                <a:cs typeface="Arial"/>
-              </a:defRPr>
-            </a:defPPr>
-            <a:lvl1pPr marL="228600" indent="-228600" algn="l" defTabSz="914400">
-              <a:lnSpc>
-                <a:spcPct val="90000"/>
-              </a:lnSpc>
-              <a:spcBef>
-                <a:spcPts val="1000"/>
-              </a:spcBef>
-              <a:buFont typeface="Arial"/>
-              <a:buChar char="•"/>
-              <a:defRPr sz="2400" kern="1200">
-                <a:solidFill>
-                  <a:schemeClr val="tx1"/>
-                </a:solidFill>
-                <a:latin typeface="+mn-lt"/>
-                <a:ea typeface="+mn-lt"/>
-                <a:cs typeface="+mn-lt"/>
-              </a:defRPr>
-            </a:lvl1pPr>
-            <a:lvl2pPr marL="685800" indent="-228600" algn="l" defTabSz="914400">
-              <a:lnSpc>
-                <a:spcPct val="90000"/>
-              </a:lnSpc>
-              <a:spcBef>
-                <a:spcPts val="500"/>
-              </a:spcBef>
-              <a:buFont typeface="Arial"/>
-              <a:buChar char="•"/>
-              <a:defRPr sz="2000" kern="1200">
-                <a:solidFill>
-                  <a:schemeClr val="tx1"/>
-                </a:solidFill>
-                <a:latin typeface="+mn-lt"/>
-                <a:ea typeface="+mn-lt"/>
-                <a:cs typeface="+mn-lt"/>
-              </a:defRPr>
-            </a:lvl2pPr>
-            <a:lvl3pPr marL="1143000" indent="-228600" algn="l" defTabSz="914400">
-              <a:lnSpc>
-                <a:spcPct val="90000"/>
-              </a:lnSpc>
-              <a:spcBef>
-                <a:spcPts val="500"/>
-              </a:spcBef>
-              <a:buFont typeface="Arial"/>
-              <a:buChar char="•"/>
-              <a:defRPr sz="1800" kern="1200">
-                <a:solidFill>
-                  <a:schemeClr val="tx1"/>
-                </a:solidFill>
-                <a:latin typeface="+mn-lt"/>
-                <a:ea typeface="+mn-lt"/>
-                <a:cs typeface="+mn-lt"/>
-              </a:defRPr>
-            </a:lvl3pPr>
-            <a:lvl4pPr marL="1600200" indent="-228600" algn="l" defTabSz="914400">
-              <a:lnSpc>
-                <a:spcPct val="90000"/>
-              </a:lnSpc>
-              <a:spcBef>
-                <a:spcPts val="500"/>
-              </a:spcBef>
-              <a:buFont typeface="Arial"/>
-              <a:buChar char="•"/>
-              <a:defRPr sz="1800" kern="1200">
-                <a:solidFill>
-                  <a:schemeClr val="tx1"/>
-                </a:solidFill>
-                <a:latin typeface="+mn-lt"/>
-                <a:ea typeface="+mn-lt"/>
-                <a:cs typeface="+mn-lt"/>
-              </a:defRPr>
-            </a:lvl4pPr>
-            <a:lvl5pPr marL="2057400" indent="-228600" algn="l" defTabSz="914400">
-              <a:lnSpc>
-                <a:spcPct val="90000"/>
-              </a:lnSpc>
-              <a:spcBef>
-                <a:spcPts val="500"/>
-              </a:spcBef>
-              <a:buFont typeface="Arial"/>
-              <a:buChar char="•"/>
-              <a:defRPr sz="1800" kern="1200">
-                <a:solidFill>
-                  <a:schemeClr val="tx1"/>
-                </a:solidFill>
-                <a:latin typeface="+mn-lt"/>
-                <a:ea typeface="+mn-lt"/>
-                <a:cs typeface="+mn-lt"/>
-              </a:defRPr>
-            </a:lvl5pPr>
-            <a:lvl6pPr marL="2514600" indent="-228600" algn="l" defTabSz="914400">
-              <a:lnSpc>
-                <a:spcPct val="90000"/>
-              </a:lnSpc>
-              <a:spcBef>
-                <a:spcPts val="500"/>
-              </a:spcBef>
-              <a:buFont typeface="Arial"/>
-              <a:buChar char="•"/>
-              <a:defRPr sz="1800" kern="1200">
-                <a:solidFill>
-                  <a:schemeClr val="tx1"/>
-                </a:solidFill>
-                <a:latin typeface="+mn-lt"/>
-                <a:ea typeface="+mn-lt"/>
-                <a:cs typeface="+mn-lt"/>
-              </a:defRPr>
-            </a:lvl6pPr>
-            <a:lvl7pPr marL="2971800" indent="-228600" algn="l" defTabSz="914400">
-              <a:lnSpc>
-                <a:spcPct val="90000"/>
-              </a:lnSpc>
-              <a:spcBef>
-                <a:spcPts val="500"/>
-              </a:spcBef>
-              <a:buFont typeface="Arial"/>
-              <a:buChar char="•"/>
-              <a:defRPr sz="1800" kern="1200">
-                <a:solidFill>
-                  <a:schemeClr val="tx1"/>
-                </a:solidFill>
-                <a:latin typeface="+mn-lt"/>
-                <a:ea typeface="+mn-lt"/>
-                <a:cs typeface="+mn-lt"/>
-              </a:defRPr>
-            </a:lvl7pPr>
-            <a:lvl8pPr marL="3429000" indent="-228600" algn="l" defTabSz="914400">
-              <a:lnSpc>
-                <a:spcPct val="90000"/>
-              </a:lnSpc>
-              <a:spcBef>
-                <a:spcPts val="500"/>
-              </a:spcBef>
-              <a:buFont typeface="Arial"/>
-              <a:buChar char="•"/>
-              <a:defRPr sz="1800" kern="1200">
-                <a:solidFill>
-                  <a:schemeClr val="tx1"/>
-                </a:solidFill>
-                <a:latin typeface="+mn-lt"/>
-                <a:ea typeface="+mn-lt"/>
-                <a:cs typeface="+mn-lt"/>
-              </a:defRPr>
-            </a:lvl8pPr>
-            <a:lvl9pPr marL="3886200" indent="-228600" algn="l" defTabSz="914400">
-              <a:lnSpc>
-                <a:spcPct val="90000"/>
-              </a:lnSpc>
-              <a:spcBef>
-                <a:spcPts val="500"/>
-              </a:spcBef>
-              <a:buFont typeface="Arial"/>
-              <a:buChar char="•"/>
-              <a:defRPr sz="1800" kern="1200">
-                <a:solidFill>
-                  <a:schemeClr val="tx1"/>
-                </a:solidFill>
-                <a:latin typeface="+mn-lt"/>
-                <a:ea typeface="+mn-lt"/>
-                <a:cs typeface="+mn-lt"/>
-              </a:defRPr>
-            </a:lvl9pPr>
-          </a:lstStyle>
-          <a:p xmlns:a="http://schemas.openxmlformats.org/drawingml/2006/main">
-            <a:pPr marL="0" indent="0">
-              <a:lnSpc>
-                <a:spcPct val="112000"/>
-              </a:lnSpc>
-              <a:spcBef>
-                <a:spcPts val="0"/>
-              </a:spcBef>
-              <a:spcAft>
-                <a:spcPts val="0"/>
-              </a:spcAft>
-              <a:buNone/>
-              <a:defRPr sz="1875">
-                <a:solidFill>
-                  <a:srgbClr val="FFFFFF"/>
-                </a:solidFill>
-                <a:latin typeface="Arial"/>
-                <a:ea typeface="Arial"/>
-                <a:cs typeface="Arial"/>
-              </a:defRPr>
-            </a:pPr>
-            <a:r>
-              <a:rPr sz="1875">
-                <a:solidFill>
-                  <a:srgbClr val="FFFFFF"/>
-                </a:solidFill>
-                <a:latin typeface="Arial"/>
-                <a:ea typeface="Arial"/>
-                <a:cs typeface="Arial"/>
-              </a:rPr>
-              <a:t>Pause at the phase entry.</a:t>
-            </a:r>
-          </a:p>
-          <a:p xmlns:a="http://schemas.openxmlformats.org/drawingml/2006/main">
-            <a:pPr marL="0" indent="0">
-              <a:lnSpc>
-                <a:spcPct val="112000"/>
-              </a:lnSpc>
-              <a:spcBef>
-                <a:spcPts val="0"/>
-              </a:spcBef>
-              <a:spcAft>
-                <a:spcPts val="0"/>
-              </a:spcAft>
-              <a:buNone/>
-            </a:pPr>
-            <a:r>
-              <a:t/>
-            </a:r>
-          </a:p>
-          <a:p xmlns:a="http://schemas.openxmlformats.org/drawingml/2006/main">
-            <a:pPr marL="0" indent="0">
-              <a:lnSpc>
-                <a:spcPct val="112000"/>
-              </a:lnSpc>
-              <a:spcBef>
-                <a:spcPts val="0"/>
-              </a:spcBef>
-              <a:spcAft>
-                <a:spcPts val="0"/>
-              </a:spcAft>
-              <a:buNone/>
-              <a:defRPr sz="1875">
-                <a:solidFill>
-                  <a:srgbClr val="FFFFFF"/>
-                </a:solidFill>
-                <a:latin typeface="Arial"/>
-                <a:ea typeface="Arial"/>
-                <a:cs typeface="Arial"/>
-              </a:defRPr>
-            </a:pPr>
-            <a:r>
-              <a:rPr sz="1875">
-                <a:solidFill>
-                  <a:srgbClr val="FFFFFF"/>
-                </a:solidFill>
-                <a:latin typeface="Arial"/>
-                <a:ea typeface="Arial"/>
-                <a:cs typeface="Arial"/>
-              </a:rPr>
-              <a:t>Identify the input format and failure branches.</a:t>
-            </a:r>
-          </a:p>
-          <a:p xmlns:a="http://schemas.openxmlformats.org/drawingml/2006/main">
-            <a:pPr marL="0" indent="0">
-              <a:lnSpc>
-                <a:spcPct val="112000"/>
-              </a:lnSpc>
-              <a:spcBef>
-                <a:spcPts val="0"/>
-              </a:spcBef>
-              <a:spcAft>
-                <a:spcPts val="0"/>
-              </a:spcAft>
-              <a:buNone/>
-            </a:pPr>
-            <a:r>
-              <a:t/>
-            </a:r>
-          </a:p>
-          <a:p xmlns:a="http://schemas.openxmlformats.org/drawingml/2006/main">
-            <a:pPr marL="0" indent="0">
-              <a:lnSpc>
-                <a:spcPct val="112000"/>
-              </a:lnSpc>
-              <a:spcBef>
-                <a:spcPts val="0"/>
-              </a:spcBef>
-              <a:spcAft>
-                <a:spcPts val="0"/>
-              </a:spcAft>
-              <a:buNone/>
-              <a:defRPr sz="1875">
-                <a:solidFill>
-                  <a:srgbClr val="FFFFFF"/>
-                </a:solidFill>
-                <a:latin typeface="Arial"/>
-                <a:ea typeface="Arial"/>
-                <a:cs typeface="Arial"/>
-              </a:defRPr>
-            </a:pPr>
-            <a:r>
-              <a:rPr sz="1875">
-                <a:solidFill>
-                  <a:srgbClr val="FFFFFF"/>
-                </a:solidFill>
-                <a:latin typeface="Arial"/>
-                <a:ea typeface="Arial"/>
-                <a:cs typeface="Arial"/>
-              </a:rPr>
-              <a:t>Track the registers or memory that each check uses.</a:t>
-            </a:r>
-          </a:p>
-          <a:p xmlns:a="http://schemas.openxmlformats.org/drawingml/2006/main">
-            <a:pPr marL="0" indent="0">
-              <a:lnSpc>
-                <a:spcPct val="112000"/>
-              </a:lnSpc>
-              <a:spcBef>
-                <a:spcPts val="0"/>
-              </a:spcBef>
-              <a:spcAft>
-                <a:spcPts val="0"/>
-              </a:spcAft>
-              <a:buNone/>
-            </a:pPr>
-            <a:r>
-              <a:t/>
-            </a:r>
-          </a:p>
-          <a:p xmlns:a="http://schemas.openxmlformats.org/drawingml/2006/main">
-            <a:pPr marL="0" indent="0">
-              <a:lnSpc>
-                <a:spcPct val="112000"/>
-              </a:lnSpc>
-              <a:spcBef>
-                <a:spcPts val="0"/>
-              </a:spcBef>
-              <a:spcAft>
-                <a:spcPts val="0"/>
-              </a:spcAft>
-              <a:buNone/>
-              <a:defRPr sz="1875">
-                <a:solidFill>
-                  <a:srgbClr val="FFFFFF"/>
-                </a:solidFill>
-                <a:latin typeface="Arial"/>
-                <a:ea typeface="Arial"/>
-                <a:cs typeface="Arial"/>
-              </a:defRPr>
-            </a:pPr>
-            <a:r>
-              <a:rPr sz="1875">
-                <a:solidFill>
-                  <a:srgbClr val="FFFFFF"/>
-                </a:solidFill>
-                <a:latin typeface="Arial"/>
-                <a:ea typeface="Arial"/>
-                <a:cs typeface="Arial"/>
-              </a:rPr>
-              <a:t>Test a candidate only after you can explain it.</a:t>
-            </a:r>
-          </a:p>
-        </p:txBody>
-      </p:sp>
-      <p:sp>
-        <p:nvSpPr>
-          <p:cNvPr id="8" name="Content Placeholder 3">
-            <a:extLst xmlns:a="http://schemas.openxmlformats.org/drawingml/2006/main">
-              <a:ext uri="{FF2B5EF4-FFF2-40B4-BE49-F238E27FC236}">
-                <a16:creationId xmlns:a16="http://schemas.microsoft.com/office/drawing/2014/main" id="{2EE8F343-A95F-2AAA-FE9E-A6C31E298DF7}"/>
-              </a:ext>
-            </a:extLst>
-          </p:cNvPr>
-          <p:cNvSpPr>
-            <a:spLocks xmlns:a="http://schemas.openxmlformats.org/drawingml/2006/main" noGrp="1"/>
-          </p:cNvSpPr>
-          <p:nvPr/>
-        </p:nvSpPr>
-        <p:spPr>
-          <a:xfrm xmlns:a="http://schemas.openxmlformats.org/drawingml/2006/main">
-            <a:off x="6256618" y="2031999"/>
-            <a:ext cx="5537200" cy="3534787"/>
-          </a:xfrm>
-          <a:prstGeom xmlns:a="http://schemas.openxmlformats.org/drawingml/2006/main" prst="rect">
-            <a:avLst/>
-          </a:prstGeom>
-        </p:spPr>
-        <p:txBody>
-          <a:bodyPr xmlns:a="http://schemas.openxmlformats.org/drawingml/2006/main" lIns="0" tIns="0" rIns="0" bIns="0" anchor="t">
-            <a:noAutofit/>
-          </a:bodyPr>
-          <a:lstStyle xmlns:a="http://schemas.openxmlformats.org/drawingml/2006/main">
-            <a:defPPr>
-              <a:defRPr sz="1800">
-                <a:solidFill>
-                  <a:srgbClr val="FFFFFF"/>
-                </a:solidFill>
-                <a:latin typeface="Consolas"/>
-                <a:ea typeface="Consolas"/>
-                <a:cs typeface="Consolas"/>
-              </a:defRPr>
-            </a:defPPr>
-            <a:lvl1pPr marL="228600" indent="-228600" algn="l" defTabSz="914400">
-              <a:lnSpc>
-                <a:spcPct val="90000"/>
-              </a:lnSpc>
-              <a:spcBef>
-                <a:spcPts val="1000"/>
-              </a:spcBef>
-              <a:buFont typeface="Arial"/>
-              <a:buChar char="•"/>
-              <a:defRPr sz="2400" kern="1200">
-                <a:solidFill>
-                  <a:schemeClr val="tx1"/>
-                </a:solidFill>
-                <a:latin typeface="+mn-lt"/>
-                <a:ea typeface="+mn-lt"/>
-                <a:cs typeface="+mn-lt"/>
-              </a:defRPr>
-            </a:lvl1pPr>
-            <a:lvl2pPr marL="685800" indent="-228600" algn="l" defTabSz="914400">
-              <a:lnSpc>
-                <a:spcPct val="90000"/>
-              </a:lnSpc>
-              <a:spcBef>
-                <a:spcPts val="500"/>
-              </a:spcBef>
-              <a:buFont typeface="Arial"/>
-              <a:buChar char="•"/>
-              <a:defRPr sz="2000" kern="1200">
-                <a:solidFill>
-                  <a:schemeClr val="tx1"/>
-                </a:solidFill>
-                <a:latin typeface="+mn-lt"/>
-                <a:ea typeface="+mn-lt"/>
-                <a:cs typeface="+mn-lt"/>
-              </a:defRPr>
-            </a:lvl2pPr>
-            <a:lvl3pPr marL="1143000" indent="-228600" algn="l" defTabSz="914400">
-              <a:lnSpc>
-                <a:spcPct val="90000"/>
-              </a:lnSpc>
-              <a:spcBef>
-                <a:spcPts val="500"/>
-              </a:spcBef>
-              <a:buFont typeface="Arial"/>
-              <a:buChar char="•"/>
-              <a:defRPr sz="1800" kern="1200">
-                <a:solidFill>
-                  <a:schemeClr val="tx1"/>
-                </a:solidFill>
-                <a:latin typeface="+mn-lt"/>
-                <a:ea typeface="+mn-lt"/>
-                <a:cs typeface="+mn-lt"/>
-              </a:defRPr>
-            </a:lvl3pPr>
-            <a:lvl4pPr marL="1600200" indent="-228600" algn="l" defTabSz="914400">
-              <a:lnSpc>
-                <a:spcPct val="90000"/>
-              </a:lnSpc>
-              <a:spcBef>
-                <a:spcPts val="500"/>
-              </a:spcBef>
-              <a:buFont typeface="Arial"/>
-              <a:buChar char="•"/>
-              <a:defRPr sz="1800" kern="1200">
-                <a:solidFill>
-                  <a:schemeClr val="tx1"/>
-                </a:solidFill>
-                <a:latin typeface="+mn-lt"/>
-                <a:ea typeface="+mn-lt"/>
-                <a:cs typeface="+mn-lt"/>
-              </a:defRPr>
-            </a:lvl4pPr>
-            <a:lvl5pPr marL="2057400" indent="-228600" algn="l" defTabSz="914400">
-              <a:lnSpc>
-                <a:spcPct val="90000"/>
-              </a:lnSpc>
-              <a:spcBef>
-                <a:spcPts val="500"/>
-              </a:spcBef>
-              <a:buFont typeface="Arial"/>
-              <a:buChar char="•"/>
-              <a:defRPr sz="1800" kern="1200">
-                <a:solidFill>
-                  <a:schemeClr val="tx1"/>
-                </a:solidFill>
-                <a:latin typeface="+mn-lt"/>
-                <a:ea typeface="+mn-lt"/>
-                <a:cs typeface="+mn-lt"/>
-              </a:defRPr>
-            </a:lvl5pPr>
-            <a:lvl6pPr marL="2514600" indent="-228600" algn="l" defTabSz="914400">
-              <a:lnSpc>
-                <a:spcPct val="90000"/>
-              </a:lnSpc>
-              <a:spcBef>
-                <a:spcPts val="500"/>
-              </a:spcBef>
-              <a:buFont typeface="Arial"/>
-              <a:buChar char="•"/>
-              <a:defRPr sz="1800" kern="1200">
-                <a:solidFill>
-                  <a:schemeClr val="tx1"/>
-                </a:solidFill>
-                <a:latin typeface="+mn-lt"/>
-                <a:ea typeface="+mn-lt"/>
-                <a:cs typeface="+mn-lt"/>
-              </a:defRPr>
-            </a:lvl6pPr>
-            <a:lvl7pPr marL="2971800" indent="-228600" algn="l" defTabSz="914400">
-              <a:lnSpc>
-                <a:spcPct val="90000"/>
-              </a:lnSpc>
-              <a:spcBef>
-                <a:spcPts val="500"/>
-              </a:spcBef>
-              <a:buFont typeface="Arial"/>
-              <a:buChar char="•"/>
-              <a:defRPr sz="1800" kern="1200">
-                <a:solidFill>
-                  <a:schemeClr val="tx1"/>
-                </a:solidFill>
-                <a:latin typeface="+mn-lt"/>
-                <a:ea typeface="+mn-lt"/>
-                <a:cs typeface="+mn-lt"/>
-              </a:defRPr>
-            </a:lvl7pPr>
-            <a:lvl8pPr marL="3429000" indent="-228600" algn="l" defTabSz="914400">
-              <a:lnSpc>
-                <a:spcPct val="90000"/>
-              </a:lnSpc>
-              <a:spcBef>
-                <a:spcPts val="500"/>
-              </a:spcBef>
-              <a:buFont typeface="Arial"/>
-              <a:buChar char="•"/>
-              <a:defRPr sz="1800" kern="1200">
-                <a:solidFill>
-                  <a:schemeClr val="tx1"/>
-                </a:solidFill>
-                <a:latin typeface="+mn-lt"/>
-                <a:ea typeface="+mn-lt"/>
-                <a:cs typeface="+mn-lt"/>
-              </a:defRPr>
-            </a:lvl8pPr>
-            <a:lvl9pPr marL="3886200" indent="-228600" algn="l" defTabSz="914400">
-              <a:lnSpc>
-                <a:spcPct val="90000"/>
-              </a:lnSpc>
-              <a:spcBef>
-                <a:spcPts val="500"/>
-              </a:spcBef>
-              <a:buFont typeface="Arial"/>
-              <a:buChar char="•"/>
-              <a:defRPr sz="1800" kern="1200">
-                <a:solidFill>
-                  <a:schemeClr val="tx1"/>
-                </a:solidFill>
-                <a:latin typeface="+mn-lt"/>
-                <a:ea typeface="+mn-lt"/>
-                <a:cs typeface="+mn-lt"/>
-              </a:defRPr>
-            </a:lvl9pPr>
-          </a:lstStyle>
-          <a:p xmlns:a="http://schemas.openxmlformats.org/drawingml/2006/main">
-            <a:pPr marL="0" indent="0">
-              <a:lnSpc>
-                <a:spcPct val="112000"/>
-              </a:lnSpc>
-              <a:spcBef>
-                <a:spcPts val="0"/>
-              </a:spcBef>
-              <a:spcAft>
-                <a:spcPts val="0"/>
-              </a:spcAft>
-              <a:buNone/>
-              <a:defRPr sz="1800">
-                <a:solidFill>
-                  <a:srgbClr val="FFFFFF"/>
-                </a:solidFill>
-                <a:latin typeface="Consolas"/>
-                <a:ea typeface="Consolas"/>
-                <a:cs typeface="Consolas"/>
-              </a:defRPr>
-            </a:pPr>
-            <a:r>
-              <a:rPr sz="1800">
-                <a:solidFill>
-                  <a:srgbClr val="FFFFFF"/>
-                </a:solidFill>
-                <a:latin typeface="Consolas"/>
-                <a:ea typeface="Consolas"/>
-                <a:cs typeface="Consolas"/>
-              </a:rPr>
-              <a:t>Useful notes to keep</a:t>
-            </a:r>
-          </a:p>
-          <a:p xmlns:a="http://schemas.openxmlformats.org/drawingml/2006/main">
-            <a:pPr marL="0" indent="0">
-              <a:lnSpc>
-                <a:spcPct val="112000"/>
-              </a:lnSpc>
-              <a:spcBef>
-                <a:spcPts val="0"/>
-              </a:spcBef>
-              <a:spcAft>
-                <a:spcPts val="0"/>
-              </a:spcAft>
-              <a:buNone/>
-            </a:pPr>
-            <a:r>
-              <a:t/>
-            </a:r>
-          </a:p>
-          <a:p xmlns:a="http://schemas.openxmlformats.org/drawingml/2006/main">
-            <a:pPr marL="0" indent="0">
-              <a:lnSpc>
-                <a:spcPct val="112000"/>
-              </a:lnSpc>
-              <a:spcBef>
-                <a:spcPts val="0"/>
-              </a:spcBef>
-              <a:spcAft>
-                <a:spcPts val="0"/>
-              </a:spcAft>
-              <a:buNone/>
-              <a:defRPr sz="1800">
-                <a:solidFill>
-                  <a:srgbClr val="FFFFFF"/>
-                </a:solidFill>
-                <a:latin typeface="Consolas"/>
-                <a:ea typeface="Consolas"/>
-                <a:cs typeface="Consolas"/>
-              </a:defRPr>
-            </a:pPr>
-            <a:r>
-              <a:rPr sz="1800">
-                <a:solidFill>
-                  <a:srgbClr val="FFFFFF"/>
-                </a:solidFill>
-                <a:latin typeface="Consolas"/>
-                <a:ea typeface="Consolas"/>
-                <a:cs typeface="Consolas"/>
-              </a:rPr>
-              <a:t>Function and instruction address</a:t>
-            </a:r>
-          </a:p>
-          <a:p xmlns:a="http://schemas.openxmlformats.org/drawingml/2006/main">
-            <a:pPr marL="0" indent="0">
-              <a:lnSpc>
-                <a:spcPct val="112000"/>
-              </a:lnSpc>
-              <a:spcBef>
-                <a:spcPts val="0"/>
-              </a:spcBef>
-              <a:spcAft>
-                <a:spcPts val="0"/>
-              </a:spcAft>
-              <a:buNone/>
-              <a:defRPr sz="1800">
-                <a:solidFill>
-                  <a:srgbClr val="FFFFFF"/>
-                </a:solidFill>
-                <a:latin typeface="Consolas"/>
-                <a:ea typeface="Consolas"/>
-                <a:cs typeface="Consolas"/>
-              </a:defRPr>
-            </a:pPr>
-            <a:r>
-              <a:rPr sz="1800">
-                <a:solidFill>
-                  <a:srgbClr val="FFFFFF"/>
-                </a:solidFill>
-                <a:latin typeface="Consolas"/>
-                <a:ea typeface="Consolas"/>
-                <a:cs typeface="Consolas"/>
-              </a:rPr>
-              <a:t>Input fields</a:t>
-            </a:r>
-          </a:p>
-          <a:p xmlns:a="http://schemas.openxmlformats.org/drawingml/2006/main">
-            <a:pPr marL="0" indent="0">
-              <a:lnSpc>
-                <a:spcPct val="112000"/>
-              </a:lnSpc>
-              <a:spcBef>
-                <a:spcPts val="0"/>
-              </a:spcBef>
-              <a:spcAft>
-                <a:spcPts val="0"/>
-              </a:spcAft>
-              <a:buNone/>
-              <a:defRPr sz="1800">
-                <a:solidFill>
-                  <a:srgbClr val="FFFFFF"/>
-                </a:solidFill>
-                <a:latin typeface="Consolas"/>
-                <a:ea typeface="Consolas"/>
-                <a:cs typeface="Consolas"/>
-              </a:defRPr>
-            </a:pPr>
-            <a:r>
-              <a:rPr sz="1800">
-                <a:solidFill>
-                  <a:srgbClr val="FFFFFF"/>
-                </a:solidFill>
-                <a:latin typeface="Consolas"/>
-                <a:ea typeface="Consolas"/>
-                <a:cs typeface="Consolas"/>
-              </a:rPr>
-              <a:t>Condition required to pass</a:t>
-            </a:r>
-          </a:p>
-          <a:p xmlns:a="http://schemas.openxmlformats.org/drawingml/2006/main">
-            <a:pPr marL="0" indent="0">
-              <a:lnSpc>
-                <a:spcPct val="112000"/>
-              </a:lnSpc>
-              <a:spcBef>
-                <a:spcPts val="0"/>
-              </a:spcBef>
-              <a:spcAft>
-                <a:spcPts val="0"/>
-              </a:spcAft>
-              <a:buNone/>
-              <a:defRPr sz="1800">
-                <a:solidFill>
-                  <a:srgbClr val="FFFFFF"/>
-                </a:solidFill>
-                <a:latin typeface="Consolas"/>
-                <a:ea typeface="Consolas"/>
-                <a:cs typeface="Consolas"/>
-              </a:defRPr>
-            </a:pPr>
-            <a:r>
-              <a:rPr sz="1800">
-                <a:solidFill>
-                  <a:srgbClr val="FFFFFF"/>
-                </a:solidFill>
-                <a:latin typeface="Consolas"/>
-                <a:ea typeface="Consolas"/>
-                <a:cs typeface="Consolas"/>
-              </a:rPr>
-              <a:t>Observed register or memory values</a:t>
-            </a:r>
-          </a:p>
-          <a:p xmlns:a="http://schemas.openxmlformats.org/drawingml/2006/main">
-            <a:pPr marL="0" indent="0">
-              <a:lnSpc>
-                <a:spcPct val="112000"/>
-              </a:lnSpc>
-              <a:spcBef>
-                <a:spcPts val="0"/>
-              </a:spcBef>
-              <a:spcAft>
-                <a:spcPts val="0"/>
-              </a:spcAft>
-              <a:buNone/>
-              <a:defRPr sz="1800">
-                <a:solidFill>
-                  <a:srgbClr val="FFFFFF"/>
-                </a:solidFill>
-                <a:latin typeface="Consolas"/>
-                <a:ea typeface="Consolas"/>
-                <a:cs typeface="Consolas"/>
-              </a:defRPr>
-            </a:pPr>
-            <a:r>
-              <a:rPr sz="1800">
-                <a:solidFill>
-                  <a:srgbClr val="FFFFFF"/>
-                </a:solidFill>
-                <a:latin typeface="Consolas"/>
-                <a:ea typeface="Consolas"/>
-                <a:cs typeface="Consolas"/>
-              </a:rPr>
-              <a:t>Reason for the candidate input</a:t>
-            </a:r>
-          </a:p>
-        </p:txBody>
-      </p:sp>
-      <p:sp>
-        <p:nvSpPr>
-          <p:cNvPr id="534" name="Takeaway">
-            <a:extLst xmlns:a="http://schemas.openxmlformats.org/drawingml/2006/main">
-              <a:ext uri="{FF2B5EF4-FFF2-40B4-BE49-F238E27FC236}">
-                <a16:creationId xmlns:a16="http://schemas.microsoft.com/office/drawing/2014/main" id="{192D27CF-D224-4A85-AFC9-2795210040DB}"/>
+                <a16:creationId xmlns:a16="http://schemas.microsoft.com/office/drawing/2014/main" id="{24DD7052-53C7-40FB-B29A-3846DA3DDE5D}"/>
               </a:ext>
             </a:extLst>
           </p:cNvPr>
@@ -14912,7 +14136,7 @@
           <p:cNvPr id="534" name="Takeaway">
             <a:extLst xmlns:a="http://schemas.openxmlformats.org/drawingml/2006/main">
               <a:ext uri="{FF2B5EF4-FFF2-40B4-BE49-F238E27FC236}">
-                <a16:creationId xmlns:a16="http://schemas.microsoft.com/office/drawing/2014/main" id="{46A1926D-C2E0-4039-8050-B497FA53711C}"/>
+                <a16:creationId xmlns:a16="http://schemas.microsoft.com/office/drawing/2014/main" id="{E606CD78-C7EA-4FED-81DA-08B135144CE4}"/>
               </a:ext>
             </a:extLst>
           </p:cNvPr>
@@ -16997,7 +16221,7 @@
           <p:cNvPr id="534" name="Takeaway">
             <a:extLst xmlns:a="http://schemas.openxmlformats.org/drawingml/2006/main">
               <a:ext uri="{FF2B5EF4-FFF2-40B4-BE49-F238E27FC236}">
-                <a16:creationId xmlns:a16="http://schemas.microsoft.com/office/drawing/2014/main" id="{B8A9EEAC-A864-48AC-B26F-1BFBBFA9C5EF}"/>
+                <a16:creationId xmlns:a16="http://schemas.microsoft.com/office/drawing/2014/main" id="{1E43121B-F9CE-4326-99DF-700604760066}"/>
               </a:ext>
             </a:extLst>
           </p:cNvPr>
@@ -18053,7 +17277,7 @@
           <p:cNvPr id="534" name="Takeaway">
             <a:extLst xmlns:a="http://schemas.openxmlformats.org/drawingml/2006/main">
               <a:ext uri="{FF2B5EF4-FFF2-40B4-BE49-F238E27FC236}">
-                <a16:creationId xmlns:a16="http://schemas.microsoft.com/office/drawing/2014/main" id="{B1A677F5-A19B-4146-B274-87442261AA12}"/>
+                <a16:creationId xmlns:a16="http://schemas.microsoft.com/office/drawing/2014/main" id="{1034C1A7-35E9-4FCF-8491-B145F19D58A6}"/>
               </a:ext>
             </a:extLst>
           </p:cNvPr>
@@ -18362,7 +17586,7 @@
                 <a:ea typeface="Arial"/>
                 <a:cs typeface="Arial"/>
               </a:rPr>
-              <a:t>C code and assembly</a:t>
+              <a:t>Assembly from the executable</a:t>
             </a:r>
           </a:p>
         </p:txBody>
@@ -18598,7 +17822,7 @@
                 <a:ea typeface="Arial"/>
                 <a:cs typeface="Arial"/>
               </a:rPr>
-              <a:t>For C source you own, gcc -S produces an assembly file.</a:t>
+              <a:t>objdump displays machine instructions without running the bomb.</a:t>
             </a:r>
           </a:p>
           <a:p xmlns:a="http://schemas.openxmlformats.org/drawingml/2006/main">
@@ -18648,7 +17872,7 @@
                 <a:ea typeface="Arial"/>
                 <a:cs typeface="Arial"/>
               </a:rPr>
-              <a:t>-g adds debugger information. -O0 keeps optimization off for this exercise.</a:t>
+              <a:t>In GDB, disassemble displays one function.</a:t>
             </a:r>
           </a:p>
           <a:p xmlns:a="http://schemas.openxmlformats.org/drawingml/2006/main">
@@ -18698,7 +17922,7 @@
                 <a:ea typeface="Arial"/>
                 <a:cs typeface="Arial"/>
               </a:rPr>
-              <a:t>The bomb already contains machine code. Inspect that executable directly.</a:t>
+              <a:t>Use AT&amp;T syntax consistently with the earlier recitations.</a:t>
             </a:r>
           </a:p>
         </p:txBody>
@@ -18934,7 +18158,7 @@
                 <a:ea typeface="Consolas"/>
                 <a:cs typeface="Consolas"/>
               </a:rPr>
-              <a:t># With the supplied example.c</a:t>
+              <a:t># Shell</a:t>
             </a:r>
           </a:p>
           <a:p xmlns:a="http://schemas.openxmlformats.org/drawingml/2006/main">
@@ -18967,7 +18191,7 @@
                 <a:ea typeface="Consolas"/>
                 <a:cs typeface="Consolas"/>
               </a:rPr>
-              <a:t>gcc -O0 -S example.c -o example.s</a:t>
+              <a:t>objdump -d bomb &gt; bomb-disassembly.txt</a:t>
             </a:r>
           </a:p>
           <a:p xmlns:a="http://schemas.openxmlformats.org/drawingml/2006/main">
@@ -19000,7 +18224,7 @@
                 <a:ea typeface="Consolas"/>
                 <a:cs typeface="Consolas"/>
               </a:rPr>
-              <a:t>less example.s</a:t>
+              <a:t>less bomb-disassembly.txt</a:t>
             </a:r>
           </a:p>
           <a:p xmlns:a="http://schemas.openxmlformats.org/drawingml/2006/main">
@@ -19050,7 +18274,7 @@
                 <a:ea typeface="Consolas"/>
                 <a:cs typeface="Consolas"/>
               </a:rPr>
-              <a:t># A separate executable for GDB</a:t>
+              <a:t># Inside GDB</a:t>
             </a:r>
           </a:p>
           <a:p xmlns:a="http://schemas.openxmlformats.org/drawingml/2006/main">
@@ -19083,7 +18307,7 @@
                 <a:ea typeface="Consolas"/>
                 <a:cs typeface="Consolas"/>
               </a:rPr>
-              <a:t>gcc -g -O0 example.c -o example</a:t>
+              <a:t>set disassembly-flavor att</a:t>
             </a:r>
           </a:p>
           <a:p xmlns:a="http://schemas.openxmlformats.org/drawingml/2006/main">
@@ -19116,7 +18340,40 @@
                 <a:ea typeface="Consolas"/>
                 <a:cs typeface="Consolas"/>
               </a:rPr>
-              <a:t>gdb ./example</a:t>
+              <a:t>info functions phase_</a:t>
+            </a:r>
+          </a:p>
+          <a:p xmlns:a="http://schemas.openxmlformats.org/drawingml/2006/main">
+            <a:pPr marL="0" indent="0">
+              <a:lnSpc>
+                <a:spcPct val="112000"/>
+              </a:lnSpc>
+              <a:spcBef>
+                <a:spcPts val="0"/>
+              </a:spcBef>
+              <a:spcAft>
+                <a:spcPts val="0"/>
+              </a:spcAft>
+              <a:buNone/>
+              <a:defRPr sz="1800">
+                <a:solidFill>
+                  <a:srgbClr val="FFFFFF"/>
+                </a:solidFill>
+                <a:latin typeface="Consolas"/>
+                <a:ea typeface="Consolas"/>
+                <a:cs typeface="Consolas"/>
+              </a:defRPr>
+            </a:pPr>
+            <a:r>
+              <a:rPr sz="1800">
+                <a:solidFill>
+                  <a:srgbClr val="FFFFFF"/>
+                </a:solidFill>
+                <a:latin typeface="Consolas"/>
+                <a:ea typeface="Consolas"/>
+                <a:cs typeface="Consolas"/>
+              </a:rPr>
+              <a:t>disassemble phase_1</a:t>
             </a:r>
           </a:p>
         </p:txBody>
@@ -19126,7 +18383,7 @@
           <p:cNvPr id="534" name="Takeaway">
             <a:extLst xmlns:a="http://schemas.openxmlformats.org/drawingml/2006/main">
               <a:ext uri="{FF2B5EF4-FFF2-40B4-BE49-F238E27FC236}">
-                <a16:creationId xmlns:a16="http://schemas.microsoft.com/office/drawing/2014/main" id="{047BE8B3-2108-45A9-9F0A-09E92BF7729C}"/>
+                <a16:creationId xmlns:a16="http://schemas.microsoft.com/office/drawing/2014/main" id="{BC0684E2-01C5-48F9-A073-0507A0B1226D}"/>
               </a:ext>
             </a:extLst>
           </p:cNvPr>
@@ -19194,7 +18451,7 @@
                 <a:ea typeface="Arial"/>
                 <a:cs typeface="Arial"/>
               </a:rPr>
-              <a:t>Compiling bomb.c alone may fail because the phase code is missing.</a:t>
+              <a:t>Function names depend on your executable. Use the symbols it actually provides.</a:t>
             </a:r>
           </a:p>
         </p:txBody>
@@ -19435,7 +18692,7 @@
                 <a:ea typeface="Arial"/>
                 <a:cs typeface="Arial"/>
               </a:rPr>
-              <a:t>Assembly from the executable</a:t>
+              <a:t>The first GDB session</a:t>
             </a:r>
           </a:p>
         </p:txBody>
@@ -19671,7 +18928,7 @@
                 <a:ea typeface="Arial"/>
                 <a:cs typeface="Arial"/>
               </a:rPr>
-              <a:t>objdump displays machine instructions without running the bomb.</a:t>
+              <a:t>Set breakpoints before running. Stop at the phase entry and inspect its instructions.</a:t>
             </a:r>
           </a:p>
           <a:p xmlns:a="http://schemas.openxmlformats.org/drawingml/2006/main">
@@ -19721,7 +18978,7 @@
                 <a:ea typeface="Arial"/>
                 <a:cs typeface="Arial"/>
               </a:rPr>
-              <a:t>In GDB, disassemble displays one function.</a:t>
+              <a:t>A breakpoint on explode_bomb gives an extra stopping point if execution reaches it.</a:t>
             </a:r>
           </a:p>
           <a:p xmlns:a="http://schemas.openxmlformats.org/drawingml/2006/main">
@@ -19771,7 +19028,7 @@
                 <a:ea typeface="Arial"/>
                 <a:cs typeface="Arial"/>
               </a:rPr>
-              <a:t>Use AT&amp;T syntax consistently with the earlier recitations.</a:t>
+              <a:t>At that breakpoint, inspect and stop the run.</a:t>
             </a:r>
           </a:p>
         </p:txBody>
@@ -20007,7 +19264,7 @@
                 <a:ea typeface="Consolas"/>
                 <a:cs typeface="Consolas"/>
               </a:rPr>
-              <a:t># Shell</a:t>
+              <a:t>(gdb) break phase_1</a:t>
             </a:r>
           </a:p>
           <a:p xmlns:a="http://schemas.openxmlformats.org/drawingml/2006/main">
@@ -20040,7 +19297,7 @@
                 <a:ea typeface="Consolas"/>
                 <a:cs typeface="Consolas"/>
               </a:rPr>
-              <a:t>objdump -d bomb &gt; bomb-disassembly.txt</a:t>
+              <a:t>(gdb) break explode_bomb</a:t>
             </a:r>
           </a:p>
           <a:p xmlns:a="http://schemas.openxmlformats.org/drawingml/2006/main">
@@ -20073,7 +19330,40 @@
                 <a:ea typeface="Consolas"/>
                 <a:cs typeface="Consolas"/>
               </a:rPr>
-              <a:t>less bomb-disassembly.txt</a:t>
+              <a:t>(gdb) info breakpoints</a:t>
+            </a:r>
+          </a:p>
+          <a:p xmlns:a="http://schemas.openxmlformats.org/drawingml/2006/main">
+            <a:pPr marL="0" indent="0">
+              <a:lnSpc>
+                <a:spcPct val="112000"/>
+              </a:lnSpc>
+              <a:spcBef>
+                <a:spcPts val="0"/>
+              </a:spcBef>
+              <a:spcAft>
+                <a:spcPts val="0"/>
+              </a:spcAft>
+              <a:buNone/>
+              <a:defRPr sz="1800">
+                <a:solidFill>
+                  <a:srgbClr val="FFFFFF"/>
+                </a:solidFill>
+                <a:latin typeface="Consolas"/>
+                <a:ea typeface="Consolas"/>
+                <a:cs typeface="Consolas"/>
+              </a:defRPr>
+            </a:pPr>
+            <a:r>
+              <a:rPr sz="1800">
+                <a:solidFill>
+                  <a:srgbClr val="FFFFFF"/>
+                </a:solidFill>
+                <a:latin typeface="Consolas"/>
+                <a:ea typeface="Consolas"/>
+                <a:cs typeface="Consolas"/>
+              </a:rPr>
+              <a:t>(gdb) run</a:t>
             </a:r>
           </a:p>
           <a:p xmlns:a="http://schemas.openxmlformats.org/drawingml/2006/main">
@@ -20123,7 +19413,7 @@
                 <a:ea typeface="Consolas"/>
                 <a:cs typeface="Consolas"/>
               </a:rPr>
-              <a:t># Inside GDB</a:t>
+              <a:t># At the phase breakpoint</a:t>
             </a:r>
           </a:p>
           <a:p xmlns:a="http://schemas.openxmlformats.org/drawingml/2006/main">
@@ -20156,7 +19446,7 @@
                 <a:ea typeface="Consolas"/>
                 <a:cs typeface="Consolas"/>
               </a:rPr>
-              <a:t>set disassembly-flavor att</a:t>
+              <a:t>(gdb) disassemble phase_1</a:t>
             </a:r>
           </a:p>
           <a:p xmlns:a="http://schemas.openxmlformats.org/drawingml/2006/main">
@@ -20189,40 +19479,7 @@
                 <a:ea typeface="Consolas"/>
                 <a:cs typeface="Consolas"/>
               </a:rPr>
-              <a:t>info functions phase_</a:t>
-            </a:r>
-          </a:p>
-          <a:p xmlns:a="http://schemas.openxmlformats.org/drawingml/2006/main">
-            <a:pPr marL="0" indent="0">
-              <a:lnSpc>
-                <a:spcPct val="112000"/>
-              </a:lnSpc>
-              <a:spcBef>
-                <a:spcPts val="0"/>
-              </a:spcBef>
-              <a:spcAft>
-                <a:spcPts val="0"/>
-              </a:spcAft>
-              <a:buNone/>
-              <a:defRPr sz="1800">
-                <a:solidFill>
-                  <a:srgbClr val="FFFFFF"/>
-                </a:solidFill>
-                <a:latin typeface="Consolas"/>
-                <a:ea typeface="Consolas"/>
-                <a:cs typeface="Consolas"/>
-              </a:defRPr>
-            </a:pPr>
-            <a:r>
-              <a:rPr sz="1800">
-                <a:solidFill>
-                  <a:srgbClr val="FFFFFF"/>
-                </a:solidFill>
-                <a:latin typeface="Consolas"/>
-                <a:ea typeface="Consolas"/>
-                <a:cs typeface="Consolas"/>
-              </a:rPr>
-              <a:t>disassemble phase_1</a:t>
+              <a:t>(gdb) x/i $pc</a:t>
             </a:r>
           </a:p>
         </p:txBody>
@@ -20232,7 +19489,7 @@
           <p:cNvPr id="534" name="Takeaway">
             <a:extLst xmlns:a="http://schemas.openxmlformats.org/drawingml/2006/main">
               <a:ext uri="{FF2B5EF4-FFF2-40B4-BE49-F238E27FC236}">
-                <a16:creationId xmlns:a16="http://schemas.microsoft.com/office/drawing/2014/main" id="{39B3855E-5DC1-4EAC-A7C8-E2D3EB8FD466}"/>
+                <a16:creationId xmlns:a16="http://schemas.microsoft.com/office/drawing/2014/main" id="{C97AA755-DCD6-444C-80B3-E9028E6DDB41}"/>
               </a:ext>
             </a:extLst>
           </p:cNvPr>
@@ -20300,7 +19557,7 @@
                 <a:ea typeface="Arial"/>
                 <a:cs typeface="Arial"/>
               </a:rPr>
-              <a:t>Function names depend on your executable. Use the symbols it actually provides.</a:t>
+              <a:t>A breakpoint pauses execution. Continuing from explode_bomb can execute the failure routine.</a:t>
             </a:r>
           </a:p>
         </p:txBody>
@@ -20541,7 +19798,7 @@
                 <a:ea typeface="Arial"/>
                 <a:cs typeface="Arial"/>
               </a:rPr>
-              <a:t>The first GDB session</a:t>
+              <a:t>Managing breakpoints</a:t>
             </a:r>
           </a:p>
         </p:txBody>
@@ -20777,7 +20034,7 @@
                 <a:ea typeface="Arial"/>
                 <a:cs typeface="Arial"/>
               </a:rPr>
-              <a:t>Set breakpoints before running. Stop at the phase entry and inspect its instructions.</a:t>
+              <a:t>Break at a function or at a specific instruction address.</a:t>
             </a:r>
           </a:p>
           <a:p xmlns:a="http://schemas.openxmlformats.org/drawingml/2006/main">
@@ -20827,7 +20084,7 @@
                 <a:ea typeface="Arial"/>
                 <a:cs typeface="Arial"/>
               </a:rPr>
-              <a:t>A breakpoint on explode_bomb gives an extra stopping point if execution reaches it.</a:t>
+              <a:t>GDB assigns a number to each breakpoint. Use that number to disable or delete it.</a:t>
             </a:r>
           </a:p>
           <a:p xmlns:a="http://schemas.openxmlformats.org/drawingml/2006/main">
@@ -20877,7 +20134,7 @@
                 <a:ea typeface="Arial"/>
                 <a:cs typeface="Arial"/>
               </a:rPr>
-              <a:t>At that breakpoint, inspect and stop the run.</a:t>
+              <a:t>Choose addresses from your current disassembly.</a:t>
             </a:r>
           </a:p>
         </p:txBody>
@@ -21113,7 +20370,7 @@
                 <a:ea typeface="Consolas"/>
                 <a:cs typeface="Consolas"/>
               </a:rPr>
-              <a:t>(gdb) break phase_1</a:t>
+              <a:t>break phase_2</a:t>
             </a:r>
           </a:p>
           <a:p xmlns:a="http://schemas.openxmlformats.org/drawingml/2006/main">
@@ -21146,7 +20403,7 @@
                 <a:ea typeface="Consolas"/>
                 <a:cs typeface="Consolas"/>
               </a:rPr>
-              <a:t>(gdb) break explode_bomb</a:t>
+              <a:t>break *ADDRESS</a:t>
             </a:r>
           </a:p>
           <a:p xmlns:a="http://schemas.openxmlformats.org/drawingml/2006/main">
@@ -21179,7 +20436,24 @@
                 <a:ea typeface="Consolas"/>
                 <a:cs typeface="Consolas"/>
               </a:rPr>
-              <a:t>(gdb) info breakpoints</a:t>
+              <a:t>info breakpoints</a:t>
+            </a:r>
+          </a:p>
+          <a:p xmlns:a="http://schemas.openxmlformats.org/drawingml/2006/main">
+            <a:pPr marL="0" indent="0">
+              <a:lnSpc>
+                <a:spcPct val="112000"/>
+              </a:lnSpc>
+              <a:spcBef>
+                <a:spcPts val="0"/>
+              </a:spcBef>
+              <a:spcAft>
+                <a:spcPts val="0"/>
+              </a:spcAft>
+              <a:buNone/>
+            </a:pPr>
+            <a:r>
+              <a:t/>
             </a:r>
           </a:p>
           <a:p xmlns:a="http://schemas.openxmlformats.org/drawingml/2006/main">
@@ -21212,7 +20486,73 @@
                 <a:ea typeface="Consolas"/>
                 <a:cs typeface="Consolas"/>
               </a:rPr>
-              <a:t>(gdb) run</a:t>
+              <a:t>disable 2</a:t>
+            </a:r>
+          </a:p>
+          <a:p xmlns:a="http://schemas.openxmlformats.org/drawingml/2006/main">
+            <a:pPr marL="0" indent="0">
+              <a:lnSpc>
+                <a:spcPct val="112000"/>
+              </a:lnSpc>
+              <a:spcBef>
+                <a:spcPts val="0"/>
+              </a:spcBef>
+              <a:spcAft>
+                <a:spcPts val="0"/>
+              </a:spcAft>
+              <a:buNone/>
+              <a:defRPr sz="1800">
+                <a:solidFill>
+                  <a:srgbClr val="FFFFFF"/>
+                </a:solidFill>
+                <a:latin typeface="Consolas"/>
+                <a:ea typeface="Consolas"/>
+                <a:cs typeface="Consolas"/>
+              </a:defRPr>
+            </a:pPr>
+            <a:r>
+              <a:rPr sz="1800">
+                <a:solidFill>
+                  <a:srgbClr val="FFFFFF"/>
+                </a:solidFill>
+                <a:latin typeface="Consolas"/>
+                <a:ea typeface="Consolas"/>
+                <a:cs typeface="Consolas"/>
+              </a:rPr>
+              <a:t>enable 2</a:t>
+            </a:r>
+          </a:p>
+          <a:p xmlns:a="http://schemas.openxmlformats.org/drawingml/2006/main">
+            <a:pPr marL="0" indent="0">
+              <a:lnSpc>
+                <a:spcPct val="112000"/>
+              </a:lnSpc>
+              <a:spcBef>
+                <a:spcPts val="0"/>
+              </a:spcBef>
+              <a:spcAft>
+                <a:spcPts val="0"/>
+              </a:spcAft>
+              <a:buNone/>
+              <a:defRPr sz="1800">
+                <a:solidFill>
+                  <a:srgbClr val="FFFFFF"/>
+                </a:solidFill>
+                <a:latin typeface="Consolas"/>
+                <a:ea typeface="Consolas"/>
+                <a:cs typeface="Consolas"/>
+              </a:defRPr>
+            </a:pPr>
+            <a:r>
+              <a:rPr sz="1800">
+                <a:solidFill>
+                  <a:srgbClr val="FFFFFF"/>
+                </a:solidFill>
+                <a:latin typeface="Consolas"/>
+                <a:ea typeface="Consolas"/>
+                <a:cs typeface="Consolas"/>
+              </a:rPr>
+              <a:t>delete 2</a:t>
             </a:r>
           </a:p>
           <a:p xmlns:a="http://schemas.openxmlformats.org/drawingml/2006/main">
@@ -21262,73 +20602,7 @@
                 <a:ea typeface="Consolas"/>
                 <a:cs typeface="Consolas"/>
               </a:rPr>
-              <a:t># At the phase breakpoint</a:t>
-            </a:r>
-          </a:p>
-          <a:p xmlns:a="http://schemas.openxmlformats.org/drawingml/2006/main">
-            <a:pPr marL="0" indent="0">
-              <a:lnSpc>
-                <a:spcPct val="112000"/>
-              </a:lnSpc>
-              <a:spcBef>
-                <a:spcPts val="0"/>
-              </a:spcBef>
-              <a:spcAft>
-                <a:spcPts val="0"/>
-              </a:spcAft>
-              <a:buNone/>
-              <a:defRPr sz="1800">
-                <a:solidFill>
-                  <a:srgbClr val="FFFFFF"/>
-                </a:solidFill>
-                <a:latin typeface="Consolas"/>
-                <a:ea typeface="Consolas"/>
-                <a:cs typeface="Consolas"/>
-              </a:defRPr>
-            </a:pPr>
-            <a:r>
-              <a:rPr sz="1800">
-                <a:solidFill>
-                  <a:srgbClr val="FFFFFF"/>
-                </a:solidFill>
-                <a:latin typeface="Consolas"/>
-                <a:ea typeface="Consolas"/>
-                <a:cs typeface="Consolas"/>
-              </a:rPr>
-              <a:t>(gdb) disassemble phase_1</a:t>
-            </a:r>
-          </a:p>
-          <a:p xmlns:a="http://schemas.openxmlformats.org/drawingml/2006/main">
-            <a:pPr marL="0" indent="0">
-              <a:lnSpc>
-                <a:spcPct val="112000"/>
-              </a:lnSpc>
-              <a:spcBef>
-                <a:spcPts val="0"/>
-              </a:spcBef>
-              <a:spcAft>
-                <a:spcPts val="0"/>
-              </a:spcAft>
-              <a:buNone/>
-              <a:defRPr sz="1800">
-                <a:solidFill>
-                  <a:srgbClr val="FFFFFF"/>
-                </a:solidFill>
-                <a:latin typeface="Consolas"/>
-                <a:ea typeface="Consolas"/>
-                <a:cs typeface="Consolas"/>
-              </a:defRPr>
-            </a:pPr>
-            <a:r>
-              <a:rPr sz="1800">
-                <a:solidFill>
-                  <a:srgbClr val="FFFFFF"/>
-                </a:solidFill>
-                <a:latin typeface="Consolas"/>
-                <a:ea typeface="Consolas"/>
-                <a:cs typeface="Consolas"/>
-              </a:rPr>
-              <a:t>(gdb) x/i $pc</a:t>
+              <a:t>help break</a:t>
             </a:r>
           </a:p>
         </p:txBody>
@@ -21338,7 +20612,7 @@
           <p:cNvPr id="534" name="Takeaway">
             <a:extLst xmlns:a="http://schemas.openxmlformats.org/drawingml/2006/main">
               <a:ext uri="{FF2B5EF4-FFF2-40B4-BE49-F238E27FC236}">
-                <a16:creationId xmlns:a16="http://schemas.microsoft.com/office/drawing/2014/main" id="{C5AA301E-04CA-402D-A0F1-443E4C549CCF}"/>
+                <a16:creationId xmlns:a16="http://schemas.microsoft.com/office/drawing/2014/main" id="{7D633C5C-FA76-4807-8E3C-906AF2363ECA}"/>
               </a:ext>
             </a:extLst>
           </p:cNvPr>
@@ -21406,7 +20680,7 @@
                 <a:ea typeface="Arial"/>
                 <a:cs typeface="Arial"/>
               </a:rPr>
-              <a:t>A breakpoint pauses execution. Continuing from explode_bomb can execute the failure routine.</a:t>
+              <a:t>Replace ADDRESS with a real address. Breakpoint numbers may differ in your session.</a:t>
             </a:r>
           </a:p>
         </p:txBody>
@@ -21647,7 +20921,7 @@
                 <a:ea typeface="Arial"/>
                 <a:cs typeface="Arial"/>
               </a:rPr>
-              <a:t>Managing breakpoints</a:t>
+              <a:t>Stepping through instructions</a:t>
             </a:r>
           </a:p>
         </p:txBody>
@@ -21883,7 +21157,7 @@
                 <a:ea typeface="Arial"/>
                 <a:cs typeface="Arial"/>
               </a:rPr>
-              <a:t>Break at a function or at a specific instruction address.</a:t>
+              <a:t>si executes one machine instruction and enters calls. ni executes one instruction and steps over calls.</a:t>
             </a:r>
           </a:p>
           <a:p xmlns:a="http://schemas.openxmlformats.org/drawingml/2006/main">
@@ -21933,7 +21207,7 @@
                 <a:ea typeface="Arial"/>
                 <a:cs typeface="Arial"/>
               </a:rPr>
-              <a:t>GDB assigns a number to each breakpoint. Use that number to disable or delete it.</a:t>
+              <a:t>Stepping over a call still runs the function.</a:t>
             </a:r>
           </a:p>
           <a:p xmlns:a="http://schemas.openxmlformats.org/drawingml/2006/main">
@@ -21983,7 +21257,7 @@
                 <a:ea typeface="Arial"/>
                 <a:cs typeface="Arial"/>
               </a:rPr>
-              <a:t>Choose addresses from your current disassembly.</a:t>
+              <a:t>Source commands step and next operate on source lines when debug information exists.</a:t>
             </a:r>
           </a:p>
         </p:txBody>
@@ -22219,7 +21493,7 @@
                 <a:ea typeface="Consolas"/>
                 <a:cs typeface="Consolas"/>
               </a:rPr>
-              <a:t>break phase_2</a:t>
+              <a:t>si         # stepi</a:t>
             </a:r>
           </a:p>
           <a:p xmlns:a="http://schemas.openxmlformats.org/drawingml/2006/main">
@@ -22252,7 +21526,7 @@
                 <a:ea typeface="Consolas"/>
                 <a:cs typeface="Consolas"/>
               </a:rPr>
-              <a:t>break *ADDRESS</a:t>
+              <a:t>ni         # nexti</a:t>
             </a:r>
           </a:p>
           <a:p xmlns:a="http://schemas.openxmlformats.org/drawingml/2006/main">
@@ -22285,7 +21559,7 @@
                 <a:ea typeface="Consolas"/>
                 <a:cs typeface="Consolas"/>
               </a:rPr>
-              <a:t>info breakpoints</a:t>
+              <a:t>x/i $pc    # current instruction</a:t>
             </a:r>
           </a:p>
           <a:p xmlns:a="http://schemas.openxmlformats.org/drawingml/2006/main">
@@ -22335,7 +21609,7 @@
                 <a:ea typeface="Consolas"/>
                 <a:cs typeface="Consolas"/>
               </a:rPr>
-              <a:t>disable 2</a:t>
+              <a:t>continue   # run until next stop</a:t>
             </a:r>
           </a:p>
           <a:p xmlns:a="http://schemas.openxmlformats.org/drawingml/2006/main">
@@ -22368,7 +21642,7 @@
                 <a:ea typeface="Consolas"/>
                 <a:cs typeface="Consolas"/>
               </a:rPr>
-              <a:t>enable 2</a:t>
+              <a:t>run        # restart from the beginning</a:t>
             </a:r>
           </a:p>
           <a:p xmlns:a="http://schemas.openxmlformats.org/drawingml/2006/main">
@@ -22401,24 +21675,7 @@
                 <a:ea typeface="Consolas"/>
                 <a:cs typeface="Consolas"/>
               </a:rPr>
-              <a:t>delete 2</a:t>
-            </a:r>
-          </a:p>
-          <a:p xmlns:a="http://schemas.openxmlformats.org/drawingml/2006/main">
-            <a:pPr marL="0" indent="0">
-              <a:lnSpc>
-                <a:spcPct val="112000"/>
-              </a:lnSpc>
-              <a:spcBef>
-                <a:spcPts val="0"/>
-              </a:spcBef>
-              <a:spcAft>
-                <a:spcPts val="0"/>
-              </a:spcAft>
-              <a:buNone/>
-            </a:pPr>
-            <a:r>
-              <a:t/>
+              <a:t>kill       # stop the running program</a:t>
             </a:r>
           </a:p>
           <a:p xmlns:a="http://schemas.openxmlformats.org/drawingml/2006/main">
@@ -22451,7 +21708,7 @@
                 <a:ea typeface="Consolas"/>
                 <a:cs typeface="Consolas"/>
               </a:rPr>
-              <a:t>help break</a:t>
+              <a:t>quit       # leave GDB</a:t>
             </a:r>
           </a:p>
         </p:txBody>
@@ -22461,7 +21718,7 @@
           <p:cNvPr id="534" name="Takeaway">
             <a:extLst xmlns:a="http://schemas.openxmlformats.org/drawingml/2006/main">
               <a:ext uri="{FF2B5EF4-FFF2-40B4-BE49-F238E27FC236}">
-                <a16:creationId xmlns:a16="http://schemas.microsoft.com/office/drawing/2014/main" id="{3B6BDD52-036F-4D2B-9C10-B6DA69746DD8}"/>
+                <a16:creationId xmlns:a16="http://schemas.microsoft.com/office/drawing/2014/main" id="{E9706C0F-5791-48D4-8762-44A281EBB17D}"/>
               </a:ext>
             </a:extLst>
           </p:cNvPr>
@@ -22529,7 +21786,7 @@
                 <a:ea typeface="Arial"/>
                 <a:cs typeface="Arial"/>
               </a:rPr>
-              <a:t>Replace ADDRESS with a real address. Breakpoint numbers may differ in your session.</a:t>
+              <a:t>Inspect the destination of a call before using ni or continue.</a:t>
             </a:r>
           </a:p>
         </p:txBody>

</xml_diff>

<commit_message>
Keep pointer walkthrough within slide viewport
</commit_message>
<xml_diff>
--- a/public/presentations/CS211_Recitation_5.pptx
+++ b/public/presentations/CS211_Recitation_5.pptx
@@ -2,38 +2,38 @@
 <file path=ppt/presentation.xml><?xml version="1.0" encoding="utf-8"?>
 <p:presentation xmlns:p="http://schemas.openxmlformats.org/presentationml/2006/main" embedTrueTypeFonts="1" saveSubsetFonts="0">
   <p:sldMasterIdLst>
-    <p:sldMasterId xmlns:r="http://schemas.openxmlformats.org/officeDocument/2006/relationships" id="2147483648" r:id="R380236326d454a17"/>
+    <p:sldMasterId xmlns:r="http://schemas.openxmlformats.org/officeDocument/2006/relationships" id="2147483648" r:id="R8e3f39b086d648c7"/>
   </p:sldMasterIdLst>
   <p:notesMasterIdLst>
-    <p:notesMasterId xmlns:r="http://schemas.openxmlformats.org/officeDocument/2006/relationships" r:id="R04eaa965632d46c6"/>
+    <p:notesMasterId xmlns:r="http://schemas.openxmlformats.org/officeDocument/2006/relationships" r:id="R928d06a398554702"/>
   </p:notesMasterIdLst>
   <p:sldIdLst>
-    <p:sldId xmlns:r="http://schemas.openxmlformats.org/officeDocument/2006/relationships" id="256" r:id="R44f9d355782546cb"/>
-    <p:sldId xmlns:r="http://schemas.openxmlformats.org/officeDocument/2006/relationships" id="257" r:id="R44fc2cecd4be4b26"/>
-    <p:sldId xmlns:r="http://schemas.openxmlformats.org/officeDocument/2006/relationships" id="258" r:id="R37f01edf4740497d"/>
-    <p:sldId xmlns:r="http://schemas.openxmlformats.org/officeDocument/2006/relationships" id="259" r:id="R22581dbdaa2a4fc2"/>
-    <p:sldId xmlns:r="http://schemas.openxmlformats.org/officeDocument/2006/relationships" id="260" r:id="R3badfffe070f4ec9"/>
-    <p:sldId xmlns:r="http://schemas.openxmlformats.org/officeDocument/2006/relationships" id="261" r:id="R6cadd6088005434f"/>
-    <p:sldId xmlns:r="http://schemas.openxmlformats.org/officeDocument/2006/relationships" id="262" r:id="R9f35b00384f34c50"/>
-    <p:sldId xmlns:r="http://schemas.openxmlformats.org/officeDocument/2006/relationships" id="263" r:id="R43aeb3865a394ab0"/>
-    <p:sldId xmlns:r="http://schemas.openxmlformats.org/officeDocument/2006/relationships" id="264" r:id="R4364cd0b49ef4554"/>
-    <p:sldId xmlns:r="http://schemas.openxmlformats.org/officeDocument/2006/relationships" id="265" r:id="R38ace93525be4ca8"/>
-    <p:sldId xmlns:r="http://schemas.openxmlformats.org/officeDocument/2006/relationships" id="266" r:id="Rc41d29da64be4ccd"/>
-    <p:sldId xmlns:r="http://schemas.openxmlformats.org/officeDocument/2006/relationships" id="267" r:id="Raa3ba324c9644168"/>
-    <p:sldId xmlns:r="http://schemas.openxmlformats.org/officeDocument/2006/relationships" id="268" r:id="Rc5e5c1165cf44e7e"/>
-    <p:sldId xmlns:r="http://schemas.openxmlformats.org/officeDocument/2006/relationships" id="269" r:id="R9096813e7fb340b6"/>
-    <p:sldId xmlns:r="http://schemas.openxmlformats.org/officeDocument/2006/relationships" id="270" r:id="Rf74ea3026fcf49b9"/>
-    <p:sldId xmlns:r="http://schemas.openxmlformats.org/officeDocument/2006/relationships" id="271" r:id="Rc2a4fde253024657"/>
+    <p:sldId xmlns:r="http://schemas.openxmlformats.org/officeDocument/2006/relationships" id="256" r:id="R752a964708f040c0"/>
+    <p:sldId xmlns:r="http://schemas.openxmlformats.org/officeDocument/2006/relationships" id="257" r:id="Rc47a71649d47408d"/>
+    <p:sldId xmlns:r="http://schemas.openxmlformats.org/officeDocument/2006/relationships" id="258" r:id="Rd30692c4de224bb8"/>
+    <p:sldId xmlns:r="http://schemas.openxmlformats.org/officeDocument/2006/relationships" id="259" r:id="Rde3641d5b29448db"/>
+    <p:sldId xmlns:r="http://schemas.openxmlformats.org/officeDocument/2006/relationships" id="260" r:id="Rf423d39747bd4c34"/>
+    <p:sldId xmlns:r="http://schemas.openxmlformats.org/officeDocument/2006/relationships" id="261" r:id="Ra69b6be50fa34cf2"/>
+    <p:sldId xmlns:r="http://schemas.openxmlformats.org/officeDocument/2006/relationships" id="262" r:id="Rbfbce66a99bc42bc"/>
+    <p:sldId xmlns:r="http://schemas.openxmlformats.org/officeDocument/2006/relationships" id="263" r:id="Rfed6722b920a4b97"/>
+    <p:sldId xmlns:r="http://schemas.openxmlformats.org/officeDocument/2006/relationships" id="264" r:id="R2d732c43a8e1473a"/>
+    <p:sldId xmlns:r="http://schemas.openxmlformats.org/officeDocument/2006/relationships" id="265" r:id="R945ed90827ba4d0b"/>
+    <p:sldId xmlns:r="http://schemas.openxmlformats.org/officeDocument/2006/relationships" id="266" r:id="R69892cc5993d43f3"/>
+    <p:sldId xmlns:r="http://schemas.openxmlformats.org/officeDocument/2006/relationships" id="267" r:id="R5a6fa0f55a1a4bf8"/>
+    <p:sldId xmlns:r="http://schemas.openxmlformats.org/officeDocument/2006/relationships" id="268" r:id="R813a30d373d5466f"/>
+    <p:sldId xmlns:r="http://schemas.openxmlformats.org/officeDocument/2006/relationships" id="269" r:id="R5405c5b8affc463b"/>
+    <p:sldId xmlns:r="http://schemas.openxmlformats.org/officeDocument/2006/relationships" id="270" r:id="R66714f5348bb488e"/>
+    <p:sldId xmlns:r="http://schemas.openxmlformats.org/officeDocument/2006/relationships" id="271" r:id="R9cd03b6269bb4065"/>
   </p:sldIdLst>
   <p:sldSz cx="12192000" cy="6858000"/>
   <p:notesSz cx="6858000" cy="9144000"/>
   <p:embeddedFontLst>
     <p:embeddedFont>
       <p:font typeface="OpenAI Sans"/>
-      <p:regular xmlns:r="http://schemas.openxmlformats.org/officeDocument/2006/relationships" r:id="R32d25cb964094149"/>
-      <p:bold xmlns:r="http://schemas.openxmlformats.org/officeDocument/2006/relationships" r:id="R2831515c73ae4274"/>
-      <p:italic xmlns:r="http://schemas.openxmlformats.org/officeDocument/2006/relationships" r:id="R1010ce9c6b3e4382"/>
-      <p:boldItalic xmlns:r="http://schemas.openxmlformats.org/officeDocument/2006/relationships" r:id="Rfd32b32f48f04368"/>
+      <p:regular xmlns:r="http://schemas.openxmlformats.org/officeDocument/2006/relationships" r:id="R26417ff3316d48b5"/>
+      <p:bold xmlns:r="http://schemas.openxmlformats.org/officeDocument/2006/relationships" r:id="Ra4b4ee6d1de74c4a"/>
+      <p:italic xmlns:r="http://schemas.openxmlformats.org/officeDocument/2006/relationships" r:id="R845f2e7a971d4c8d"/>
+      <p:boldItalic xmlns:r="http://schemas.openxmlformats.org/officeDocument/2006/relationships" r:id="R08c283ba42844916"/>
     </p:embeddedFont>
   </p:embeddedFontLst>
   <p:defaultTextStyle>
@@ -3609,14 +3609,14 @@
   </p:cSld>
   <p:clrMap bg1="dk1" tx1="lt1" bg2="dk2" tx2="lt2" accent1="accent1" accent2="accent2" accent3="accent3" accent4="accent4" accent5="accent5" accent6="accent6" hlink="hlink" folHlink="folHlink"/>
   <p:sldLayoutIdLst>
-    <p:sldLayoutId xmlns:r="http://schemas.openxmlformats.org/officeDocument/2006/relationships" id="2147483649" r:id="R7df592212e454582"/>
-    <p:sldLayoutId xmlns:r="http://schemas.openxmlformats.org/officeDocument/2006/relationships" id="2147483650" r:id="Rd3eaf559b9f24aab"/>
-    <p:sldLayoutId xmlns:r="http://schemas.openxmlformats.org/officeDocument/2006/relationships" id="2147483651" r:id="R48b83eb1d5db4c6c"/>
-    <p:sldLayoutId xmlns:r="http://schemas.openxmlformats.org/officeDocument/2006/relationships" id="2147483652" r:id="R90f5b6da6a254e3a"/>
-    <p:sldLayoutId xmlns:r="http://schemas.openxmlformats.org/officeDocument/2006/relationships" id="2147483653" r:id="R75cbd0f553524fe5"/>
-    <p:sldLayoutId xmlns:r="http://schemas.openxmlformats.org/officeDocument/2006/relationships" id="2147483654" r:id="R02133a9f51bb4763"/>
-    <p:sldLayoutId xmlns:r="http://schemas.openxmlformats.org/officeDocument/2006/relationships" id="2147483655" r:id="R40b4f75ec23b4b7d"/>
-    <p:sldLayoutId xmlns:r="http://schemas.openxmlformats.org/officeDocument/2006/relationships" id="2147483656" r:id="Rbbbf4a9447bb4297"/>
+    <p:sldLayoutId xmlns:r="http://schemas.openxmlformats.org/officeDocument/2006/relationships" id="2147483649" r:id="Rb3c0b77f34a542a9"/>
+    <p:sldLayoutId xmlns:r="http://schemas.openxmlformats.org/officeDocument/2006/relationships" id="2147483650" r:id="R349059cae28541b3"/>
+    <p:sldLayoutId xmlns:r="http://schemas.openxmlformats.org/officeDocument/2006/relationships" id="2147483651" r:id="R55eeb50f76f14595"/>
+    <p:sldLayoutId xmlns:r="http://schemas.openxmlformats.org/officeDocument/2006/relationships" id="2147483652" r:id="Rbc2f40fc396d422d"/>
+    <p:sldLayoutId xmlns:r="http://schemas.openxmlformats.org/officeDocument/2006/relationships" id="2147483653" r:id="R94e1d4cb005e442c"/>
+    <p:sldLayoutId xmlns:r="http://schemas.openxmlformats.org/officeDocument/2006/relationships" id="2147483654" r:id="R247153acbe8d46e9"/>
+    <p:sldLayoutId xmlns:r="http://schemas.openxmlformats.org/officeDocument/2006/relationships" id="2147483655" r:id="R291dbe2e3aeb49dc"/>
+    <p:sldLayoutId xmlns:r="http://schemas.openxmlformats.org/officeDocument/2006/relationships" id="2147483656" r:id="Rc58e91a48ac94e76"/>
   </p:sldLayoutIdLst>
   <p:hf hdr="0" dt="0"/>
   <p:txStyles>
@@ -6063,7 +6063,7 @@
           <p:cNvPr id="534" name="Takeaway">
             <a:extLst xmlns:a="http://schemas.openxmlformats.org/drawingml/2006/main">
               <a:ext uri="{FF2B5EF4-FFF2-40B4-BE49-F238E27FC236}">
-                <a16:creationId xmlns:a16="http://schemas.microsoft.com/office/drawing/2014/main" id="{C45CC3A1-990F-45B1-924F-3CEA0A1C6BBB}"/>
+                <a16:creationId xmlns:a16="http://schemas.microsoft.com/office/drawing/2014/main" id="{16D6CD83-E83A-4427-9C57-425F42129522}"/>
               </a:ext>
             </a:extLst>
           </p:cNvPr>
@@ -7219,7 +7219,7 @@
           <p:cNvPr id="534" name="Takeaway">
             <a:extLst xmlns:a="http://schemas.openxmlformats.org/drawingml/2006/main">
               <a:ext uri="{FF2B5EF4-FFF2-40B4-BE49-F238E27FC236}">
-                <a16:creationId xmlns:a16="http://schemas.microsoft.com/office/drawing/2014/main" id="{C3EC592E-CAEF-4514-9AA7-85E19D4C1A90}"/>
+                <a16:creationId xmlns:a16="http://schemas.microsoft.com/office/drawing/2014/main" id="{AB61BAC7-0783-489E-A86F-70C2CD5BD4C7}"/>
               </a:ext>
             </a:extLst>
           </p:cNvPr>
@@ -8309,7 +8309,7 @@
           <p:cNvPr id="534" name="Takeaway">
             <a:extLst xmlns:a="http://schemas.openxmlformats.org/drawingml/2006/main">
               <a:ext uri="{FF2B5EF4-FFF2-40B4-BE49-F238E27FC236}">
-                <a16:creationId xmlns:a16="http://schemas.microsoft.com/office/drawing/2014/main" id="{2756607D-0044-483E-8705-E897E3D4FFA2}"/>
+                <a16:creationId xmlns:a16="http://schemas.microsoft.com/office/drawing/2014/main" id="{CC80A59F-9179-4ECC-901C-30A170F772A3}"/>
               </a:ext>
             </a:extLst>
           </p:cNvPr>
@@ -9596,7 +9596,7 @@
           <p:cNvPr id="534" name="Takeaway">
             <a:extLst xmlns:a="http://schemas.openxmlformats.org/drawingml/2006/main">
               <a:ext uri="{FF2B5EF4-FFF2-40B4-BE49-F238E27FC236}">
-                <a16:creationId xmlns:a16="http://schemas.microsoft.com/office/drawing/2014/main" id="{A267754F-AF0F-44C3-8F87-8E9111DFBD20}"/>
+                <a16:creationId xmlns:a16="http://schemas.microsoft.com/office/drawing/2014/main" id="{696FB48D-3710-4F5A-9D17-6E3DF89546D5}"/>
               </a:ext>
             </a:extLst>
           </p:cNvPr>
@@ -10477,57 +10477,7 @@
                 <a:ea typeface="Consolas"/>
                 <a:cs typeface="Consolas"/>
               </a:rPr>
-              <a:t># Caller: rdi holds the head pointer</a:t>
-            </a:r>
-          </a:p>
-          <a:p xmlns:a="http://schemas.openxmlformats.org/drawingml/2006/main">
-            <a:pPr marL="0" indent="0">
-              <a:lnSpc>
-                <a:spcPct val="112000"/>
-              </a:lnSpc>
-              <a:spcBef>
-                <a:spcPts val="0"/>
-              </a:spcBef>
-              <a:spcAft>
-                <a:spcPts val="0"/>
-              </a:spcAft>
-              <a:buNone/>
-              <a:defRPr sz="1500">
-                <a:solidFill>
-                  <a:srgbClr val="FFFFFF"/>
-                </a:solidFill>
-                <a:latin typeface="Consolas"/>
-                <a:ea typeface="Consolas"/>
-                <a:cs typeface="Consolas"/>
-              </a:defRPr>
-            </a:pPr>
-            <a:r>
-              <a:rPr sz="1500">
-                <a:solidFill>
-                  <a:srgbClr val="FFFFFF"/>
-                </a:solidFill>
-                <a:latin typeface="Consolas"/>
-                <a:ea typeface="Consolas"/>
-                <a:cs typeface="Consolas"/>
-              </a:rPr>
               <a:t>call sum_nodes     # result in eax</a:t>
-            </a:r>
-          </a:p>
-          <a:p xmlns:a="http://schemas.openxmlformats.org/drawingml/2006/main">
-            <a:pPr marL="0" indent="0">
-              <a:lnSpc>
-                <a:spcPct val="112000"/>
-              </a:lnSpc>
-              <a:spcBef>
-                <a:spcPts val="0"/>
-              </a:spcBef>
-              <a:spcAft>
-                <a:spcPts val="0"/>
-              </a:spcAft>
-              <a:buNone/>
-            </a:pPr>
-            <a:r>
-              <a:t/>
             </a:r>
           </a:p>
           <a:p xmlns:a="http://schemas.openxmlformats.org/drawingml/2006/main">
@@ -10900,7 +10850,7 @@
           <p:cNvPr id="534" name="Takeaway">
             <a:extLst xmlns:a="http://schemas.openxmlformats.org/drawingml/2006/main">
               <a:ext uri="{FF2B5EF4-FFF2-40B4-BE49-F238E27FC236}">
-                <a16:creationId xmlns:a16="http://schemas.microsoft.com/office/drawing/2014/main" id="{14EE4096-1CAE-4409-833E-D346C04A438A}"/>
+                <a16:creationId xmlns:a16="http://schemas.microsoft.com/office/drawing/2014/main" id="{086044BC-B041-4D50-8D58-A1CC71839590}"/>
               </a:ext>
             </a:extLst>
           </p:cNvPr>
@@ -11990,7 +11940,7 @@
           <p:cNvPr id="534" name="Takeaway">
             <a:extLst xmlns:a="http://schemas.openxmlformats.org/drawingml/2006/main">
               <a:ext uri="{FF2B5EF4-FFF2-40B4-BE49-F238E27FC236}">
-                <a16:creationId xmlns:a16="http://schemas.microsoft.com/office/drawing/2014/main" id="{C89C64EC-AD69-43F5-81DF-701E50AFF121}"/>
+                <a16:creationId xmlns:a16="http://schemas.microsoft.com/office/drawing/2014/main" id="{5490A65B-76B8-4DB0-AA1D-B3FEC2A78DAB}"/>
               </a:ext>
             </a:extLst>
           </p:cNvPr>
@@ -13113,7 +13063,7 @@
           <p:cNvPr id="534" name="Takeaway">
             <a:extLst xmlns:a="http://schemas.openxmlformats.org/drawingml/2006/main">
               <a:ext uri="{FF2B5EF4-FFF2-40B4-BE49-F238E27FC236}">
-                <a16:creationId xmlns:a16="http://schemas.microsoft.com/office/drawing/2014/main" id="{24DD7052-53C7-40FB-B29A-3846DA3DDE5D}"/>
+                <a16:creationId xmlns:a16="http://schemas.microsoft.com/office/drawing/2014/main" id="{8D4EF907-B2E6-4339-A152-EB297CA73082}"/>
               </a:ext>
             </a:extLst>
           </p:cNvPr>
@@ -14136,7 +14086,7 @@
           <p:cNvPr id="534" name="Takeaway">
             <a:extLst xmlns:a="http://schemas.openxmlformats.org/drawingml/2006/main">
               <a:ext uri="{FF2B5EF4-FFF2-40B4-BE49-F238E27FC236}">
-                <a16:creationId xmlns:a16="http://schemas.microsoft.com/office/drawing/2014/main" id="{E606CD78-C7EA-4FED-81DA-08B135144CE4}"/>
+                <a16:creationId xmlns:a16="http://schemas.microsoft.com/office/drawing/2014/main" id="{78BDB389-D90F-44E6-A047-1F8E376F78F2}"/>
               </a:ext>
             </a:extLst>
           </p:cNvPr>
@@ -16221,7 +16171,7 @@
           <p:cNvPr id="534" name="Takeaway">
             <a:extLst xmlns:a="http://schemas.openxmlformats.org/drawingml/2006/main">
               <a:ext uri="{FF2B5EF4-FFF2-40B4-BE49-F238E27FC236}">
-                <a16:creationId xmlns:a16="http://schemas.microsoft.com/office/drawing/2014/main" id="{1E43121B-F9CE-4326-99DF-700604760066}"/>
+                <a16:creationId xmlns:a16="http://schemas.microsoft.com/office/drawing/2014/main" id="{3272CA29-1403-4D0D-A7F0-B59A38508441}"/>
               </a:ext>
             </a:extLst>
           </p:cNvPr>
@@ -17277,7 +17227,7 @@
           <p:cNvPr id="534" name="Takeaway">
             <a:extLst xmlns:a="http://schemas.openxmlformats.org/drawingml/2006/main">
               <a:ext uri="{FF2B5EF4-FFF2-40B4-BE49-F238E27FC236}">
-                <a16:creationId xmlns:a16="http://schemas.microsoft.com/office/drawing/2014/main" id="{1034C1A7-35E9-4FCF-8491-B145F19D58A6}"/>
+                <a16:creationId xmlns:a16="http://schemas.microsoft.com/office/drawing/2014/main" id="{87DD4254-46B5-437D-91D3-D3B77B125AA9}"/>
               </a:ext>
             </a:extLst>
           </p:cNvPr>
@@ -18383,7 +18333,7 @@
           <p:cNvPr id="534" name="Takeaway">
             <a:extLst xmlns:a="http://schemas.openxmlformats.org/drawingml/2006/main">
               <a:ext uri="{FF2B5EF4-FFF2-40B4-BE49-F238E27FC236}">
-                <a16:creationId xmlns:a16="http://schemas.microsoft.com/office/drawing/2014/main" id="{BC0684E2-01C5-48F9-A073-0507A0B1226D}"/>
+                <a16:creationId xmlns:a16="http://schemas.microsoft.com/office/drawing/2014/main" id="{6F043ED2-D16C-4D2F-8F6C-C0928AF21944}"/>
               </a:ext>
             </a:extLst>
           </p:cNvPr>
@@ -19489,7 +19439,7 @@
           <p:cNvPr id="534" name="Takeaway">
             <a:extLst xmlns:a="http://schemas.openxmlformats.org/drawingml/2006/main">
               <a:ext uri="{FF2B5EF4-FFF2-40B4-BE49-F238E27FC236}">
-                <a16:creationId xmlns:a16="http://schemas.microsoft.com/office/drawing/2014/main" id="{C97AA755-DCD6-444C-80B3-E9028E6DDB41}"/>
+                <a16:creationId xmlns:a16="http://schemas.microsoft.com/office/drawing/2014/main" id="{880E7F1E-836D-4DC1-A137-879ABC73A7D1}"/>
               </a:ext>
             </a:extLst>
           </p:cNvPr>
@@ -20612,7 +20562,7 @@
           <p:cNvPr id="534" name="Takeaway">
             <a:extLst xmlns:a="http://schemas.openxmlformats.org/drawingml/2006/main">
               <a:ext uri="{FF2B5EF4-FFF2-40B4-BE49-F238E27FC236}">
-                <a16:creationId xmlns:a16="http://schemas.microsoft.com/office/drawing/2014/main" id="{7D633C5C-FA76-4807-8E3C-906AF2363ECA}"/>
+                <a16:creationId xmlns:a16="http://schemas.microsoft.com/office/drawing/2014/main" id="{D17E0589-BB46-4792-A357-5A56FE16E302}"/>
               </a:ext>
             </a:extLst>
           </p:cNvPr>
@@ -21718,7 +21668,7 @@
           <p:cNvPr id="534" name="Takeaway">
             <a:extLst xmlns:a="http://schemas.openxmlformats.org/drawingml/2006/main">
               <a:ext uri="{FF2B5EF4-FFF2-40B4-BE49-F238E27FC236}">
-                <a16:creationId xmlns:a16="http://schemas.microsoft.com/office/drawing/2014/main" id="{E9706C0F-5791-48D4-8762-44A281EBB17D}"/>
+                <a16:creationId xmlns:a16="http://schemas.microsoft.com/office/drawing/2014/main" id="{C974FA69-7C57-4458-95EC-CE044A1B0620}"/>
               </a:ext>
             </a:extLst>
           </p:cNvPr>

</xml_diff>

<commit_message>
Remove pointer structures slide from Bomb Lab recitation
</commit_message>
<xml_diff>
--- a/public/presentations/CS211_Recitation_5.pptx
+++ b/public/presentations/CS211_Recitation_5.pptx
@@ -2,38 +2,37 @@
 <file path=ppt/presentation.xml><?xml version="1.0" encoding="utf-8"?>
 <p:presentation xmlns:p="http://schemas.openxmlformats.org/presentationml/2006/main" embedTrueTypeFonts="1" saveSubsetFonts="0">
   <p:sldMasterIdLst>
-    <p:sldMasterId xmlns:r="http://schemas.openxmlformats.org/officeDocument/2006/relationships" id="2147483648" r:id="R8e3f39b086d648c7"/>
+    <p:sldMasterId xmlns:r="http://schemas.openxmlformats.org/officeDocument/2006/relationships" id="2147483648" r:id="Rff47be523bb744da"/>
   </p:sldMasterIdLst>
   <p:notesMasterIdLst>
-    <p:notesMasterId xmlns:r="http://schemas.openxmlformats.org/officeDocument/2006/relationships" r:id="R928d06a398554702"/>
+    <p:notesMasterId xmlns:r="http://schemas.openxmlformats.org/officeDocument/2006/relationships" r:id="R09b84aa99c2e439d"/>
   </p:notesMasterIdLst>
   <p:sldIdLst>
-    <p:sldId xmlns:r="http://schemas.openxmlformats.org/officeDocument/2006/relationships" id="256" r:id="R752a964708f040c0"/>
-    <p:sldId xmlns:r="http://schemas.openxmlformats.org/officeDocument/2006/relationships" id="257" r:id="Rc47a71649d47408d"/>
-    <p:sldId xmlns:r="http://schemas.openxmlformats.org/officeDocument/2006/relationships" id="258" r:id="Rd30692c4de224bb8"/>
-    <p:sldId xmlns:r="http://schemas.openxmlformats.org/officeDocument/2006/relationships" id="259" r:id="Rde3641d5b29448db"/>
-    <p:sldId xmlns:r="http://schemas.openxmlformats.org/officeDocument/2006/relationships" id="260" r:id="Rf423d39747bd4c34"/>
-    <p:sldId xmlns:r="http://schemas.openxmlformats.org/officeDocument/2006/relationships" id="261" r:id="Ra69b6be50fa34cf2"/>
-    <p:sldId xmlns:r="http://schemas.openxmlformats.org/officeDocument/2006/relationships" id="262" r:id="Rbfbce66a99bc42bc"/>
-    <p:sldId xmlns:r="http://schemas.openxmlformats.org/officeDocument/2006/relationships" id="263" r:id="Rfed6722b920a4b97"/>
-    <p:sldId xmlns:r="http://schemas.openxmlformats.org/officeDocument/2006/relationships" id="264" r:id="R2d732c43a8e1473a"/>
-    <p:sldId xmlns:r="http://schemas.openxmlformats.org/officeDocument/2006/relationships" id="265" r:id="R945ed90827ba4d0b"/>
-    <p:sldId xmlns:r="http://schemas.openxmlformats.org/officeDocument/2006/relationships" id="266" r:id="R69892cc5993d43f3"/>
-    <p:sldId xmlns:r="http://schemas.openxmlformats.org/officeDocument/2006/relationships" id="267" r:id="R5a6fa0f55a1a4bf8"/>
-    <p:sldId xmlns:r="http://schemas.openxmlformats.org/officeDocument/2006/relationships" id="268" r:id="R813a30d373d5466f"/>
-    <p:sldId xmlns:r="http://schemas.openxmlformats.org/officeDocument/2006/relationships" id="269" r:id="R5405c5b8affc463b"/>
-    <p:sldId xmlns:r="http://schemas.openxmlformats.org/officeDocument/2006/relationships" id="270" r:id="R66714f5348bb488e"/>
-    <p:sldId xmlns:r="http://schemas.openxmlformats.org/officeDocument/2006/relationships" id="271" r:id="R9cd03b6269bb4065"/>
+    <p:sldId xmlns:r="http://schemas.openxmlformats.org/officeDocument/2006/relationships" id="256" r:id="Rf693c0989b9d4c4b"/>
+    <p:sldId xmlns:r="http://schemas.openxmlformats.org/officeDocument/2006/relationships" id="257" r:id="R9407d36d89954452"/>
+    <p:sldId xmlns:r="http://schemas.openxmlformats.org/officeDocument/2006/relationships" id="258" r:id="R90648a58e0f247e3"/>
+    <p:sldId xmlns:r="http://schemas.openxmlformats.org/officeDocument/2006/relationships" id="259" r:id="R50c022a7946c4ef4"/>
+    <p:sldId xmlns:r="http://schemas.openxmlformats.org/officeDocument/2006/relationships" id="260" r:id="R14828581482d48f9"/>
+    <p:sldId xmlns:r="http://schemas.openxmlformats.org/officeDocument/2006/relationships" id="261" r:id="R2f32681a23d14653"/>
+    <p:sldId xmlns:r="http://schemas.openxmlformats.org/officeDocument/2006/relationships" id="262" r:id="R3c5807297e4a4eaf"/>
+    <p:sldId xmlns:r="http://schemas.openxmlformats.org/officeDocument/2006/relationships" id="263" r:id="Rb7368c600bdd4904"/>
+    <p:sldId xmlns:r="http://schemas.openxmlformats.org/officeDocument/2006/relationships" id="264" r:id="Rc4f0b6cb10eb4654"/>
+    <p:sldId xmlns:r="http://schemas.openxmlformats.org/officeDocument/2006/relationships" id="265" r:id="R84e58342567f4ff4"/>
+    <p:sldId xmlns:r="http://schemas.openxmlformats.org/officeDocument/2006/relationships" id="266" r:id="Ra0d573c877c24a1b"/>
+    <p:sldId xmlns:r="http://schemas.openxmlformats.org/officeDocument/2006/relationships" id="267" r:id="R3fd9765ac0244f59"/>
+    <p:sldId xmlns:r="http://schemas.openxmlformats.org/officeDocument/2006/relationships" id="268" r:id="R53aa679031a74eec"/>
+    <p:sldId xmlns:r="http://schemas.openxmlformats.org/officeDocument/2006/relationships" id="269" r:id="R7b35844bf62442b4"/>
+    <p:sldId xmlns:r="http://schemas.openxmlformats.org/officeDocument/2006/relationships" id="270" r:id="R9063319f227442e8"/>
   </p:sldIdLst>
   <p:sldSz cx="12192000" cy="6858000"/>
   <p:notesSz cx="6858000" cy="9144000"/>
   <p:embeddedFontLst>
     <p:embeddedFont>
       <p:font typeface="OpenAI Sans"/>
-      <p:regular xmlns:r="http://schemas.openxmlformats.org/officeDocument/2006/relationships" r:id="R26417ff3316d48b5"/>
-      <p:bold xmlns:r="http://schemas.openxmlformats.org/officeDocument/2006/relationships" r:id="Ra4b4ee6d1de74c4a"/>
-      <p:italic xmlns:r="http://schemas.openxmlformats.org/officeDocument/2006/relationships" r:id="R845f2e7a971d4c8d"/>
-      <p:boldItalic xmlns:r="http://schemas.openxmlformats.org/officeDocument/2006/relationships" r:id="R08c283ba42844916"/>
+      <p:regular xmlns:r="http://schemas.openxmlformats.org/officeDocument/2006/relationships" r:id="R65317eb8120544e1"/>
+      <p:bold xmlns:r="http://schemas.openxmlformats.org/officeDocument/2006/relationships" r:id="R954bf9cab35340e3"/>
+      <p:italic xmlns:r="http://schemas.openxmlformats.org/officeDocument/2006/relationships" r:id="R906f0b0986214108"/>
+      <p:boldItalic xmlns:r="http://schemas.openxmlformats.org/officeDocument/2006/relationships" r:id="R151f38073db34b69"/>
     </p:embeddedFont>
   </p:embeddedFontLst>
   <p:defaultTextStyle>
@@ -525,7 +524,7 @@
               <a:buNone/>
             </a:pPr>
             <a:r>
-              <a:t>Use iLab for the live demonstration. Walk through the toy loop and pointer examples before inspecting a bomb.</a:t>
+              <a:t>Use iLab for the live demonstration. Walk through the toy loop example before inspecting a bomb.</a:t>
             </a:r>
             <a:endParaRPr/>
           </a:p>
@@ -925,7 +924,7 @@
               <a:buNone/>
             </a:pPr>
             <a:r>
-              <a:t>This is an invented helper, not bomb phase code. Under System V AMD64, the first pointer argument is in rdi and a 32-bit integer return value is in eax. The caller line is a separate excerpt; do not fall through into the helper. A toy node layout has a 32-bit data field at offset 0, padding at offset 4, and an 8-byte next pointer at offset 8. xor clears the sum. test checks for a null pointer before dereferencing. add reads the current node's data; mov reads the stored next address into rdi. Trace two nodes containing 5 and 9, with the second next pointer null: eax returns 14. Distinguish advancing through a stored link from adding a fixed stride to an array pointer. call saves a return address; ret uses it. No recursion, private ordering rule, or phase solution is shown.</a:t>
+              <a:t>The standard CS:APP driver often accepts a filename and switches to interactive input when that file ends, while stdin redirection may terminate at EOF. Verify the supplied bomb.c instead of promising that behavior for every version. Do not include placeholders or guessed lines in a replay file. Source for input redirection and distinct deployment modes: supplied instructor README. GDB run syntax: https://sourceware.org/gdb/current/onlinedocs/gdb.html/Arguments.html and https://sourceware.org/gdb/current/onlinedocs/gdb.html/Input_002fOutput.html .</a:t>
             </a:r>
             <a:endParaRPr/>
           </a:p>
@@ -957,86 +956,6 @@
 </file>
 
 <file path=ppt/notesSlides/notesSlide15.xml><?xml version="1.0" encoding="utf-8"?>
-<p:notes xmlns:p="http://schemas.openxmlformats.org/presentationml/2006/main">
-  <p:cSld>
-    <p:spTree>
-      <p:nvGrpSpPr>
-        <p:cNvPr id="1" name=""/>
-        <p:cNvGrpSpPr/>
-        <p:nvPr/>
-      </p:nvGrpSpPr>
-      <p:grpSpPr>
-        <a:xfrm xmlns:a="http://schemas.openxmlformats.org/drawingml/2006/main"/>
-      </p:grpSpPr>
-      <p:sp>
-        <p:nvSpPr>
-          <p:cNvPr id="2" name="Slide Image Placeholder 1"/>
-          <p:cNvSpPr>
-            <a:spLocks xmlns:a="http://schemas.openxmlformats.org/drawingml/2006/main" noGrp="1"/>
-          </p:cNvSpPr>
-          <p:nvPr>
-            <p:ph type="sldImg" idx="0"/>
-          </p:nvPr>
-        </p:nvSpPr>
-        <p:spPr/>
-      </p:sp>
-      <p:sp>
-        <p:nvSpPr>
-          <p:cNvPr id="3" name="Notes Placeholder 2"/>
-          <p:cNvSpPr>
-            <a:spLocks xmlns:a="http://schemas.openxmlformats.org/drawingml/2006/main" noGrp="1"/>
-          </p:cNvSpPr>
-          <p:nvPr>
-            <p:ph type="body" idx="1"/>
-          </p:nvPr>
-        </p:nvSpPr>
-        <p:spPr/>
-        <p:txBody>
-          <a:bodyPr xmlns:a="http://schemas.openxmlformats.org/drawingml/2006/main"/>
-          <a:lstStyle xmlns:a="http://schemas.openxmlformats.org/drawingml/2006/main"/>
-          <a:p xmlns:a="http://schemas.openxmlformats.org/drawingml/2006/main">
-            <a:pPr marL="0" lvl="0" indent="0" algn="l">
-              <a:spcBef>
-                <a:spcPts val="0"/>
-              </a:spcBef>
-              <a:spcAft>
-                <a:spcPts val="0"/>
-              </a:spcAft>
-              <a:buNone/>
-            </a:pPr>
-            <a:r>
-              <a:t>The standard CS:APP driver often accepts a filename and switches to interactive input when that file ends, while stdin redirection may terminate at EOF. Verify the supplied bomb.c instead of promising that behavior for every version. Do not include placeholders or guessed lines in a replay file. Source for input redirection and distinct deployment modes: supplied instructor README. GDB run syntax: https://sourceware.org/gdb/current/onlinedocs/gdb.html/Arguments.html and https://sourceware.org/gdb/current/onlinedocs/gdb.html/Input_002fOutput.html .</a:t>
-            </a:r>
-            <a:endParaRPr/>
-          </a:p>
-        </p:txBody>
-      </p:sp>
-      <p:sp>
-        <p:nvSpPr>
-          <p:cNvPr id="4" name="Slide Number Placeholder 3"/>
-          <p:cNvSpPr>
-            <a:spLocks xmlns:a="http://schemas.openxmlformats.org/drawingml/2006/main" noGrp="1"/>
-          </p:cNvSpPr>
-          <p:nvPr>
-            <p:ph type="sldNum" idx="5"/>
-          </p:nvPr>
-        </p:nvSpPr>
-        <p:spPr/>
-        <p:txBody>
-          <a:bodyPr xmlns:a="http://schemas.openxmlformats.org/drawingml/2006/main"/>
-          <a:lstStyle xmlns:a="http://schemas.openxmlformats.org/drawingml/2006/main"/>
-          <a:p xmlns:a="http://schemas.openxmlformats.org/drawingml/2006/main"/>
-        </p:txBody>
-      </p:sp>
-    </p:spTree>
-  </p:cSld>
-  <p:clrMapOvr>
-    <a:masterClrMapping xmlns:a="http://schemas.openxmlformats.org/drawingml/2006/main"/>
-  </p:clrMapOvr>
-</p:notes>
-</file>
-
-<file path=ppt/notesSlides/notesSlide16.xml><?xml version="1.0" encoding="utf-8"?>
 <p:notes xmlns:p="http://schemas.openxmlformats.org/presentationml/2006/main">
   <p:cSld>
     <p:spTree>
@@ -3609,14 +3528,14 @@
   </p:cSld>
   <p:clrMap bg1="dk1" tx1="lt1" bg2="dk2" tx2="lt2" accent1="accent1" accent2="accent2" accent3="accent3" accent4="accent4" accent5="accent5" accent6="accent6" hlink="hlink" folHlink="folHlink"/>
   <p:sldLayoutIdLst>
-    <p:sldLayoutId xmlns:r="http://schemas.openxmlformats.org/officeDocument/2006/relationships" id="2147483649" r:id="Rb3c0b77f34a542a9"/>
-    <p:sldLayoutId xmlns:r="http://schemas.openxmlformats.org/officeDocument/2006/relationships" id="2147483650" r:id="R349059cae28541b3"/>
-    <p:sldLayoutId xmlns:r="http://schemas.openxmlformats.org/officeDocument/2006/relationships" id="2147483651" r:id="R55eeb50f76f14595"/>
-    <p:sldLayoutId xmlns:r="http://schemas.openxmlformats.org/officeDocument/2006/relationships" id="2147483652" r:id="Rbc2f40fc396d422d"/>
-    <p:sldLayoutId xmlns:r="http://schemas.openxmlformats.org/officeDocument/2006/relationships" id="2147483653" r:id="R94e1d4cb005e442c"/>
-    <p:sldLayoutId xmlns:r="http://schemas.openxmlformats.org/officeDocument/2006/relationships" id="2147483654" r:id="R247153acbe8d46e9"/>
-    <p:sldLayoutId xmlns:r="http://schemas.openxmlformats.org/officeDocument/2006/relationships" id="2147483655" r:id="R291dbe2e3aeb49dc"/>
-    <p:sldLayoutId xmlns:r="http://schemas.openxmlformats.org/officeDocument/2006/relationships" id="2147483656" r:id="Rc58e91a48ac94e76"/>
+    <p:sldLayoutId xmlns:r="http://schemas.openxmlformats.org/officeDocument/2006/relationships" id="2147483649" r:id="Rb759d1db6ec7487a"/>
+    <p:sldLayoutId xmlns:r="http://schemas.openxmlformats.org/officeDocument/2006/relationships" id="2147483650" r:id="Raaec6b01076b4b86"/>
+    <p:sldLayoutId xmlns:r="http://schemas.openxmlformats.org/officeDocument/2006/relationships" id="2147483651" r:id="R10064a395d274500"/>
+    <p:sldLayoutId xmlns:r="http://schemas.openxmlformats.org/officeDocument/2006/relationships" id="2147483652" r:id="Rc1ea525f35bd4889"/>
+    <p:sldLayoutId xmlns:r="http://schemas.openxmlformats.org/officeDocument/2006/relationships" id="2147483653" r:id="Rf080fdb76bb6480d"/>
+    <p:sldLayoutId xmlns:r="http://schemas.openxmlformats.org/officeDocument/2006/relationships" id="2147483654" r:id="R18f4360508844078"/>
+    <p:sldLayoutId xmlns:r="http://schemas.openxmlformats.org/officeDocument/2006/relationships" id="2147483655" r:id="Rdff2dcb622244054"/>
+    <p:sldLayoutId xmlns:r="http://schemas.openxmlformats.org/officeDocument/2006/relationships" id="2147483656" r:id="R530e4b52dab54883"/>
   </p:sldLayoutIdLst>
   <p:hf hdr="0" dt="0"/>
   <p:txStyles>
@@ -6063,7 +5982,7 @@
           <p:cNvPr id="534" name="Takeaway">
             <a:extLst xmlns:a="http://schemas.openxmlformats.org/drawingml/2006/main">
               <a:ext uri="{FF2B5EF4-FFF2-40B4-BE49-F238E27FC236}">
-                <a16:creationId xmlns:a16="http://schemas.microsoft.com/office/drawing/2014/main" id="{16D6CD83-E83A-4427-9C57-425F42129522}"/>
+                <a16:creationId xmlns:a16="http://schemas.microsoft.com/office/drawing/2014/main" id="{E590E9D8-B229-4D67-8471-B4272B04010B}"/>
               </a:ext>
             </a:extLst>
           </p:cNvPr>
@@ -7219,7 +7138,7 @@
           <p:cNvPr id="534" name="Takeaway">
             <a:extLst xmlns:a="http://schemas.openxmlformats.org/drawingml/2006/main">
               <a:ext uri="{FF2B5EF4-FFF2-40B4-BE49-F238E27FC236}">
-                <a16:creationId xmlns:a16="http://schemas.microsoft.com/office/drawing/2014/main" id="{AB61BAC7-0783-489E-A86F-70C2CD5BD4C7}"/>
+                <a16:creationId xmlns:a16="http://schemas.microsoft.com/office/drawing/2014/main" id="{663C218A-9371-4441-AE8D-3EAF00F1959B}"/>
               </a:ext>
             </a:extLst>
           </p:cNvPr>
@@ -8309,7 +8228,7 @@
           <p:cNvPr id="534" name="Takeaway">
             <a:extLst xmlns:a="http://schemas.openxmlformats.org/drawingml/2006/main">
               <a:ext uri="{FF2B5EF4-FFF2-40B4-BE49-F238E27FC236}">
-                <a16:creationId xmlns:a16="http://schemas.microsoft.com/office/drawing/2014/main" id="{CC80A59F-9179-4ECC-901C-30A170F772A3}"/>
+                <a16:creationId xmlns:a16="http://schemas.microsoft.com/office/drawing/2014/main" id="{E2D734E2-BBB4-4EAF-9FC9-D6F526BA230E}"/>
               </a:ext>
             </a:extLst>
           </p:cNvPr>
@@ -9596,7 +9515,7 @@
           <p:cNvPr id="534" name="Takeaway">
             <a:extLst xmlns:a="http://schemas.openxmlformats.org/drawingml/2006/main">
               <a:ext uri="{FF2B5EF4-FFF2-40B4-BE49-F238E27FC236}">
-                <a16:creationId xmlns:a16="http://schemas.microsoft.com/office/drawing/2014/main" id="{696FB48D-3710-4F5A-9D17-6E3DF89546D5}"/>
+                <a16:creationId xmlns:a16="http://schemas.microsoft.com/office/drawing/2014/main" id="{8C9FD48A-BE67-4A7E-9884-B3B14F2CAFCE}"/>
               </a:ext>
             </a:extLst>
           </p:cNvPr>
@@ -9905,7 +9824,7 @@
                 <a:ea typeface="Arial"/>
                 <a:cs typeface="Arial"/>
               </a:rPr>
-              <a:t>Calls and pointer structures</a:t>
+              <a:t>Saving confirmed inputs</a:t>
             </a:r>
           </a:p>
         </p:txBody>
@@ -10141,7 +10060,7 @@
                 <a:ea typeface="Arial"/>
                 <a:cs typeface="Arial"/>
               </a:rPr>
-              <a:t>call enters a helper; ret returns to the instruction after the call.</a:t>
+              <a:t>Keep a separate text file with one confirmed phase input per line, in order.</a:t>
             </a:r>
           </a:p>
           <a:p xmlns:a="http://schemas.openxmlformats.org/drawingml/2006/main">
@@ -10191,7 +10110,7 @@
                 <a:ea typeface="Arial"/>
                 <a:cs typeface="Arial"/>
               </a:rPr>
-              <a:t>In this example, %rdi holds a node address. The 4-byte data field is at offset 0; the next pointer is at offset 8.</a:t>
+              <a:t>Read bomb.c to check whether your version accepts that file as a command-line argument.</a:t>
             </a:r>
           </a:p>
           <a:p xmlns:a="http://schemas.openxmlformats.org/drawingml/2006/main">
@@ -10241,7 +10160,7 @@
                 <a:ea typeface="Arial"/>
                 <a:cs typeface="Arial"/>
               </a:rPr>
-              <a:t>Which instruction reads data? Which follows a pointer?</a:t>
+              <a:t>Keep your own notes on why each line passes.</a:t>
             </a:r>
           </a:p>
         </p:txBody>
@@ -10275,7 +10194,7 @@
           </a:bodyPr>
           <a:lstStyle xmlns:a="http://schemas.openxmlformats.org/drawingml/2006/main">
             <a:defPPr>
-              <a:defRPr sz="1500">
+              <a:defRPr sz="1800">
                 <a:solidFill>
                   <a:srgbClr val="FFFFFF"/>
                 </a:solidFill>
@@ -10459,17 +10378,17 @@
                 <a:spcPts val="0"/>
               </a:spcAft>
               <a:buNone/>
-              <a:defRPr sz="1500">
-                <a:solidFill>
-                  <a:srgbClr val="FFFFFF"/>
-                </a:solidFill>
-                <a:latin typeface="Consolas"/>
-                <a:ea typeface="Consolas"/>
-                <a:cs typeface="Consolas"/>
-              </a:defRPr>
-            </a:pPr>
-            <a:r>
-              <a:rPr sz="1500">
+              <a:defRPr sz="1800">
+                <a:solidFill>
+                  <a:srgbClr val="FFFFFF"/>
+                </a:solidFill>
+                <a:latin typeface="Consolas"/>
+                <a:ea typeface="Consolas"/>
+                <a:cs typeface="Consolas"/>
+              </a:defRPr>
+            </a:pPr>
+            <a:r>
+              <a:rPr sz="1800">
                 <a:solidFill>
                   <a:srgbClr val="FFFFFF"/>
                 </a:solidFill>
@@ -10477,32 +10396,32 @@
                 <a:ea typeface="Consolas"/>
                 <a:cs typeface="Consolas"/>
               </a:rPr>
-              <a:t>call sum_nodes     # result in eax</a:t>
-            </a:r>
-          </a:p>
-          <a:p xmlns:a="http://schemas.openxmlformats.org/drawingml/2006/main">
-            <a:pPr marL="0" indent="0">
-              <a:lnSpc>
-                <a:spcPct val="112000"/>
-              </a:lnSpc>
-              <a:spcBef>
-                <a:spcPts val="0"/>
-              </a:spcBef>
-              <a:spcAft>
-                <a:spcPts val="0"/>
-              </a:spcAft>
-              <a:buNone/>
-              <a:defRPr sz="1500">
-                <a:solidFill>
-                  <a:srgbClr val="FFFFFF"/>
-                </a:solidFill>
-                <a:latin typeface="Consolas"/>
-                <a:ea typeface="Consolas"/>
-                <a:cs typeface="Consolas"/>
-              </a:defRPr>
-            </a:pPr>
-            <a:r>
-              <a:rPr sz="1500">
+              <a:t># If bomb.c supports a filename</a:t>
+            </a:r>
+          </a:p>
+          <a:p xmlns:a="http://schemas.openxmlformats.org/drawingml/2006/main">
+            <a:pPr marL="0" indent="0">
+              <a:lnSpc>
+                <a:spcPct val="112000"/>
+              </a:lnSpc>
+              <a:spcBef>
+                <a:spcPts val="0"/>
+              </a:spcBef>
+              <a:spcAft>
+                <a:spcPts val="0"/>
+              </a:spcAft>
+              <a:buNone/>
+              <a:defRPr sz="1800">
+                <a:solidFill>
+                  <a:srgbClr val="FFFFFF"/>
+                </a:solidFill>
+                <a:latin typeface="Consolas"/>
+                <a:ea typeface="Consolas"/>
+                <a:cs typeface="Consolas"/>
+              </a:defRPr>
+            </a:pPr>
+            <a:r>
+              <a:rPr sz="1800">
                 <a:solidFill>
                   <a:srgbClr val="FFFFFF"/>
                 </a:solidFill>
@@ -10510,32 +10429,49 @@
                 <a:ea typeface="Consolas"/>
                 <a:cs typeface="Consolas"/>
               </a:rPr>
-              <a:t># Helper function</a:t>
-            </a:r>
-          </a:p>
-          <a:p xmlns:a="http://schemas.openxmlformats.org/drawingml/2006/main">
-            <a:pPr marL="0" indent="0">
-              <a:lnSpc>
-                <a:spcPct val="112000"/>
-              </a:lnSpc>
-              <a:spcBef>
-                <a:spcPts val="0"/>
-              </a:spcBef>
-              <a:spcAft>
-                <a:spcPts val="0"/>
-              </a:spcAft>
-              <a:buNone/>
-              <a:defRPr sz="1500">
-                <a:solidFill>
-                  <a:srgbClr val="FFFFFF"/>
-                </a:solidFill>
-                <a:latin typeface="Consolas"/>
-                <a:ea typeface="Consolas"/>
-                <a:cs typeface="Consolas"/>
-              </a:defRPr>
-            </a:pPr>
-            <a:r>
-              <a:rPr sz="1500">
+              <a:t>(gdb) run answers.txt</a:t>
+            </a:r>
+          </a:p>
+          <a:p xmlns:a="http://schemas.openxmlformats.org/drawingml/2006/main">
+            <a:pPr marL="0" indent="0">
+              <a:lnSpc>
+                <a:spcPct val="112000"/>
+              </a:lnSpc>
+              <a:spcBef>
+                <a:spcPts val="0"/>
+              </a:spcBef>
+              <a:spcAft>
+                <a:spcPts val="0"/>
+              </a:spcAft>
+              <a:buNone/>
+            </a:pPr>
+            <a:r>
+              <a:t/>
+            </a:r>
+          </a:p>
+          <a:p xmlns:a="http://schemas.openxmlformats.org/drawingml/2006/main">
+            <a:pPr marL="0" indent="0">
+              <a:lnSpc>
+                <a:spcPct val="112000"/>
+              </a:lnSpc>
+              <a:spcBef>
+                <a:spcPts val="0"/>
+              </a:spcBef>
+              <a:spcAft>
+                <a:spcPts val="0"/>
+              </a:spcAft>
+              <a:buNone/>
+              <a:defRPr sz="1800">
+                <a:solidFill>
+                  <a:srgbClr val="FFFFFF"/>
+                </a:solidFill>
+                <a:latin typeface="Consolas"/>
+                <a:ea typeface="Consolas"/>
+                <a:cs typeface="Consolas"/>
+              </a:defRPr>
+            </a:pPr>
+            <a:r>
+              <a:rPr sz="1800">
                 <a:solidFill>
                   <a:srgbClr val="FFFFFF"/>
                 </a:solidFill>
@@ -10543,32 +10479,32 @@
                 <a:ea typeface="Consolas"/>
                 <a:cs typeface="Consolas"/>
               </a:rPr>
-              <a:t>sum_nodes:</a:t>
-            </a:r>
-          </a:p>
-          <a:p xmlns:a="http://schemas.openxmlformats.org/drawingml/2006/main">
-            <a:pPr marL="0" indent="0">
-              <a:lnSpc>
-                <a:spcPct val="112000"/>
-              </a:lnSpc>
-              <a:spcBef>
-                <a:spcPts val="0"/>
-              </a:spcBef>
-              <a:spcAft>
-                <a:spcPts val="0"/>
-              </a:spcAft>
-              <a:buNone/>
-              <a:defRPr sz="1500">
-                <a:solidFill>
-                  <a:srgbClr val="FFFFFF"/>
-                </a:solidFill>
-                <a:latin typeface="Consolas"/>
-                <a:ea typeface="Consolas"/>
-                <a:cs typeface="Consolas"/>
-              </a:defRPr>
-            </a:pPr>
-            <a:r>
-              <a:rPr sz="1500">
+              <a:t># Otherwise, stdin redirection</a:t>
+            </a:r>
+          </a:p>
+          <a:p xmlns:a="http://schemas.openxmlformats.org/drawingml/2006/main">
+            <a:pPr marL="0" indent="0">
+              <a:lnSpc>
+                <a:spcPct val="112000"/>
+              </a:lnSpc>
+              <a:spcBef>
+                <a:spcPts val="0"/>
+              </a:spcBef>
+              <a:spcAft>
+                <a:spcPts val="0"/>
+              </a:spcAft>
+              <a:buNone/>
+              <a:defRPr sz="1800">
+                <a:solidFill>
+                  <a:srgbClr val="FFFFFF"/>
+                </a:solidFill>
+                <a:latin typeface="Consolas"/>
+                <a:ea typeface="Consolas"/>
+                <a:cs typeface="Consolas"/>
+              </a:defRPr>
+            </a:pPr>
+            <a:r>
+              <a:rPr sz="1800">
                 <a:solidFill>
                   <a:srgbClr val="FFFFFF"/>
                 </a:solidFill>
@@ -10576,32 +10512,49 @@
                 <a:ea typeface="Consolas"/>
                 <a:cs typeface="Consolas"/>
               </a:rPr>
-              <a:t>  xorl %eax, %eax</a:t>
-            </a:r>
-          </a:p>
-          <a:p xmlns:a="http://schemas.openxmlformats.org/drawingml/2006/main">
-            <a:pPr marL="0" indent="0">
-              <a:lnSpc>
-                <a:spcPct val="112000"/>
-              </a:lnSpc>
-              <a:spcBef>
-                <a:spcPts val="0"/>
-              </a:spcBef>
-              <a:spcAft>
-                <a:spcPts val="0"/>
-              </a:spcAft>
-              <a:buNone/>
-              <a:defRPr sz="1500">
-                <a:solidFill>
-                  <a:srgbClr val="FFFFFF"/>
-                </a:solidFill>
-                <a:latin typeface="Consolas"/>
-                <a:ea typeface="Consolas"/>
-                <a:cs typeface="Consolas"/>
-              </a:defRPr>
-            </a:pPr>
-            <a:r>
-              <a:rPr sz="1500">
+              <a:t>(gdb) run &lt; answers.txt</a:t>
+            </a:r>
+          </a:p>
+          <a:p xmlns:a="http://schemas.openxmlformats.org/drawingml/2006/main">
+            <a:pPr marL="0" indent="0">
+              <a:lnSpc>
+                <a:spcPct val="112000"/>
+              </a:lnSpc>
+              <a:spcBef>
+                <a:spcPts val="0"/>
+              </a:spcBef>
+              <a:spcAft>
+                <a:spcPts val="0"/>
+              </a:spcAft>
+              <a:buNone/>
+            </a:pPr>
+            <a:r>
+              <a:t/>
+            </a:r>
+          </a:p>
+          <a:p xmlns:a="http://schemas.openxmlformats.org/drawingml/2006/main">
+            <a:pPr marL="0" indent="0">
+              <a:lnSpc>
+                <a:spcPct val="112000"/>
+              </a:lnSpc>
+              <a:spcBef>
+                <a:spcPts val="0"/>
+              </a:spcBef>
+              <a:spcAft>
+                <a:spcPts val="0"/>
+              </a:spcAft>
+              <a:buNone/>
+              <a:defRPr sz="1800">
+                <a:solidFill>
+                  <a:srgbClr val="FFFFFF"/>
+                </a:solidFill>
+                <a:latin typeface="Consolas"/>
+                <a:ea typeface="Consolas"/>
+                <a:cs typeface="Consolas"/>
+              </a:defRPr>
+            </a:pPr>
+            <a:r>
+              <a:rPr sz="1800">
                 <a:solidFill>
                   <a:srgbClr val="FFFFFF"/>
                 </a:solidFill>
@@ -10609,32 +10562,32 @@
                 <a:ea typeface="Consolas"/>
                 <a:cs typeface="Consolas"/>
               </a:rPr>
-              <a:t>visit:</a:t>
-            </a:r>
-          </a:p>
-          <a:p xmlns:a="http://schemas.openxmlformats.org/drawingml/2006/main">
-            <a:pPr marL="0" indent="0">
-              <a:lnSpc>
-                <a:spcPct val="112000"/>
-              </a:lnSpc>
-              <a:spcBef>
-                <a:spcPts val="0"/>
-              </a:spcBef>
-              <a:spcAft>
-                <a:spcPts val="0"/>
-              </a:spcAft>
-              <a:buNone/>
-              <a:defRPr sz="1500">
-                <a:solidFill>
-                  <a:srgbClr val="FFFFFF"/>
-                </a:solidFill>
-                <a:latin typeface="Consolas"/>
-                <a:ea typeface="Consolas"/>
-                <a:cs typeface="Consolas"/>
-              </a:defRPr>
-            </a:pPr>
-            <a:r>
-              <a:rPr sz="1500">
+              <a:t># Breakpoints remain in this session</a:t>
+            </a:r>
+          </a:p>
+          <a:p xmlns:a="http://schemas.openxmlformats.org/drawingml/2006/main">
+            <a:pPr marL="0" indent="0">
+              <a:lnSpc>
+                <a:spcPct val="112000"/>
+              </a:lnSpc>
+              <a:spcBef>
+                <a:spcPts val="0"/>
+              </a:spcBef>
+              <a:spcAft>
+                <a:spcPts val="0"/>
+              </a:spcAft>
+              <a:buNone/>
+              <a:defRPr sz="1800">
+                <a:solidFill>
+                  <a:srgbClr val="FFFFFF"/>
+                </a:solidFill>
+                <a:latin typeface="Consolas"/>
+                <a:ea typeface="Consolas"/>
+                <a:cs typeface="Consolas"/>
+              </a:defRPr>
+            </a:pPr>
+            <a:r>
+              <a:rPr sz="1800">
                 <a:solidFill>
                   <a:srgbClr val="FFFFFF"/>
                 </a:solidFill>
@@ -10642,205 +10595,7 @@
                 <a:ea typeface="Consolas"/>
                 <a:cs typeface="Consolas"/>
               </a:rPr>
-              <a:t>  testq %rdi, %rdi</a:t>
-            </a:r>
-          </a:p>
-          <a:p xmlns:a="http://schemas.openxmlformats.org/drawingml/2006/main">
-            <a:pPr marL="0" indent="0">
-              <a:lnSpc>
-                <a:spcPct val="112000"/>
-              </a:lnSpc>
-              <a:spcBef>
-                <a:spcPts val="0"/>
-              </a:spcBef>
-              <a:spcAft>
-                <a:spcPts val="0"/>
-              </a:spcAft>
-              <a:buNone/>
-              <a:defRPr sz="1500">
-                <a:solidFill>
-                  <a:srgbClr val="FFFFFF"/>
-                </a:solidFill>
-                <a:latin typeface="Consolas"/>
-                <a:ea typeface="Consolas"/>
-                <a:cs typeface="Consolas"/>
-              </a:defRPr>
-            </a:pPr>
-            <a:r>
-              <a:rPr sz="1500">
-                <a:solidFill>
-                  <a:srgbClr val="FFFFFF"/>
-                </a:solidFill>
-                <a:latin typeface="Consolas"/>
-                <a:ea typeface="Consolas"/>
-                <a:cs typeface="Consolas"/>
-              </a:rPr>
-              <a:t>  je done</a:t>
-            </a:r>
-          </a:p>
-          <a:p xmlns:a="http://schemas.openxmlformats.org/drawingml/2006/main">
-            <a:pPr marL="0" indent="0">
-              <a:lnSpc>
-                <a:spcPct val="112000"/>
-              </a:lnSpc>
-              <a:spcBef>
-                <a:spcPts val="0"/>
-              </a:spcBef>
-              <a:spcAft>
-                <a:spcPts val="0"/>
-              </a:spcAft>
-              <a:buNone/>
-              <a:defRPr sz="1500">
-                <a:solidFill>
-                  <a:srgbClr val="FFFFFF"/>
-                </a:solidFill>
-                <a:latin typeface="Consolas"/>
-                <a:ea typeface="Consolas"/>
-                <a:cs typeface="Consolas"/>
-              </a:defRPr>
-            </a:pPr>
-            <a:r>
-              <a:rPr sz="1500">
-                <a:solidFill>
-                  <a:srgbClr val="FFFFFF"/>
-                </a:solidFill>
-                <a:latin typeface="Consolas"/>
-                <a:ea typeface="Consolas"/>
-                <a:cs typeface="Consolas"/>
-              </a:rPr>
-              <a:t>  addl (%rdi), %eax</a:t>
-            </a:r>
-          </a:p>
-          <a:p xmlns:a="http://schemas.openxmlformats.org/drawingml/2006/main">
-            <a:pPr marL="0" indent="0">
-              <a:lnSpc>
-                <a:spcPct val="112000"/>
-              </a:lnSpc>
-              <a:spcBef>
-                <a:spcPts val="0"/>
-              </a:spcBef>
-              <a:spcAft>
-                <a:spcPts val="0"/>
-              </a:spcAft>
-              <a:buNone/>
-              <a:defRPr sz="1500">
-                <a:solidFill>
-                  <a:srgbClr val="FFFFFF"/>
-                </a:solidFill>
-                <a:latin typeface="Consolas"/>
-                <a:ea typeface="Consolas"/>
-                <a:cs typeface="Consolas"/>
-              </a:defRPr>
-            </a:pPr>
-            <a:r>
-              <a:rPr sz="1500">
-                <a:solidFill>
-                  <a:srgbClr val="FFFFFF"/>
-                </a:solidFill>
-                <a:latin typeface="Consolas"/>
-                <a:ea typeface="Consolas"/>
-                <a:cs typeface="Consolas"/>
-              </a:rPr>
-              <a:t>  movq 8(%rdi), %rdi</a:t>
-            </a:r>
-          </a:p>
-          <a:p xmlns:a="http://schemas.openxmlformats.org/drawingml/2006/main">
-            <a:pPr marL="0" indent="0">
-              <a:lnSpc>
-                <a:spcPct val="112000"/>
-              </a:lnSpc>
-              <a:spcBef>
-                <a:spcPts val="0"/>
-              </a:spcBef>
-              <a:spcAft>
-                <a:spcPts val="0"/>
-              </a:spcAft>
-              <a:buNone/>
-              <a:defRPr sz="1500">
-                <a:solidFill>
-                  <a:srgbClr val="FFFFFF"/>
-                </a:solidFill>
-                <a:latin typeface="Consolas"/>
-                <a:ea typeface="Consolas"/>
-                <a:cs typeface="Consolas"/>
-              </a:defRPr>
-            </a:pPr>
-            <a:r>
-              <a:rPr sz="1500">
-                <a:solidFill>
-                  <a:srgbClr val="FFFFFF"/>
-                </a:solidFill>
-                <a:latin typeface="Consolas"/>
-                <a:ea typeface="Consolas"/>
-                <a:cs typeface="Consolas"/>
-              </a:rPr>
-              <a:t>  jmp visit</a:t>
-            </a:r>
-          </a:p>
-          <a:p xmlns:a="http://schemas.openxmlformats.org/drawingml/2006/main">
-            <a:pPr marL="0" indent="0">
-              <a:lnSpc>
-                <a:spcPct val="112000"/>
-              </a:lnSpc>
-              <a:spcBef>
-                <a:spcPts val="0"/>
-              </a:spcBef>
-              <a:spcAft>
-                <a:spcPts val="0"/>
-              </a:spcAft>
-              <a:buNone/>
-              <a:defRPr sz="1500">
-                <a:solidFill>
-                  <a:srgbClr val="FFFFFF"/>
-                </a:solidFill>
-                <a:latin typeface="Consolas"/>
-                <a:ea typeface="Consolas"/>
-                <a:cs typeface="Consolas"/>
-              </a:defRPr>
-            </a:pPr>
-            <a:r>
-              <a:rPr sz="1500">
-                <a:solidFill>
-                  <a:srgbClr val="FFFFFF"/>
-                </a:solidFill>
-                <a:latin typeface="Consolas"/>
-                <a:ea typeface="Consolas"/>
-                <a:cs typeface="Consolas"/>
-              </a:rPr>
-              <a:t>done:</a:t>
-            </a:r>
-          </a:p>
-          <a:p xmlns:a="http://schemas.openxmlformats.org/drawingml/2006/main">
-            <a:pPr marL="0" indent="0">
-              <a:lnSpc>
-                <a:spcPct val="112000"/>
-              </a:lnSpc>
-              <a:spcBef>
-                <a:spcPts val="0"/>
-              </a:spcBef>
-              <a:spcAft>
-                <a:spcPts val="0"/>
-              </a:spcAft>
-              <a:buNone/>
-              <a:defRPr sz="1500">
-                <a:solidFill>
-                  <a:srgbClr val="FFFFFF"/>
-                </a:solidFill>
-                <a:latin typeface="Consolas"/>
-                <a:ea typeface="Consolas"/>
-                <a:cs typeface="Consolas"/>
-              </a:defRPr>
-            </a:pPr>
-            <a:r>
-              <a:rPr sz="1500">
-                <a:solidFill>
-                  <a:srgbClr val="FFFFFF"/>
-                </a:solidFill>
-                <a:latin typeface="Consolas"/>
-                <a:ea typeface="Consolas"/>
-                <a:cs typeface="Consolas"/>
-              </a:rPr>
-              <a:t>  ret</a:t>
+              <a:t>(gdb) info breakpoints</a:t>
             </a:r>
           </a:p>
         </p:txBody>
@@ -10850,7 +10605,7 @@
           <p:cNvPr id="534" name="Takeaway">
             <a:extLst xmlns:a="http://schemas.openxmlformats.org/drawingml/2006/main">
               <a:ext uri="{FF2B5EF4-FFF2-40B4-BE49-F238E27FC236}">
-                <a16:creationId xmlns:a16="http://schemas.microsoft.com/office/drawing/2014/main" id="{086044BC-B041-4D50-8D58-A1CC71839590}"/>
+                <a16:creationId xmlns:a16="http://schemas.microsoft.com/office/drawing/2014/main" id="{4C6AA319-8830-4939-9B82-3E9D177A0E07}"/>
               </a:ext>
             </a:extLst>
           </p:cNvPr>
@@ -10918,7 +10673,7 @@
                 <a:ea typeface="Arial"/>
                 <a:cs typeface="Arial"/>
               </a:rPr>
-              <a:t>Toy linked-list traversal. Field offsets and checks in your bomb may differ.</a:t>
+              <a:t>An argument file and stdin redirection handle end-of-file differently. Check your version before relying on either.</a:t>
             </a:r>
           </a:p>
         </p:txBody>
@@ -11159,7 +10914,7 @@
                 <a:ea typeface="Arial"/>
                 <a:cs typeface="Arial"/>
               </a:rPr>
-              <a:t>Saving confirmed inputs</a:t>
+              <a:t>A phase investigation</a:t>
             </a:r>
           </a:p>
         </p:txBody>
@@ -11395,7 +11150,7 @@
                 <a:ea typeface="Arial"/>
                 <a:cs typeface="Arial"/>
               </a:rPr>
-              <a:t>Keep a separate text file with one confirmed phase input per line, in order.</a:t>
+              <a:t>Pause at the phase entry.</a:t>
             </a:r>
           </a:p>
           <a:p xmlns:a="http://schemas.openxmlformats.org/drawingml/2006/main">
@@ -11445,7 +11200,7 @@
                 <a:ea typeface="Arial"/>
                 <a:cs typeface="Arial"/>
               </a:rPr>
-              <a:t>Read bomb.c to check whether your version accepts that file as a command-line argument.</a:t>
+              <a:t>Identify the input format and failure branches.</a:t>
             </a:r>
           </a:p>
           <a:p xmlns:a="http://schemas.openxmlformats.org/drawingml/2006/main">
@@ -11495,7 +11250,57 @@
                 <a:ea typeface="Arial"/>
                 <a:cs typeface="Arial"/>
               </a:rPr>
-              <a:t>Keep your own notes on why each line passes.</a:t>
+              <a:t>Track the registers or memory that each check uses.</a:t>
+            </a:r>
+          </a:p>
+          <a:p xmlns:a="http://schemas.openxmlformats.org/drawingml/2006/main">
+            <a:pPr marL="0" indent="0">
+              <a:lnSpc>
+                <a:spcPct val="112000"/>
+              </a:lnSpc>
+              <a:spcBef>
+                <a:spcPts val="0"/>
+              </a:spcBef>
+              <a:spcAft>
+                <a:spcPts val="0"/>
+              </a:spcAft>
+              <a:buNone/>
+            </a:pPr>
+            <a:r>
+              <a:t/>
+            </a:r>
+          </a:p>
+          <a:p xmlns:a="http://schemas.openxmlformats.org/drawingml/2006/main">
+            <a:pPr marL="0" indent="0">
+              <a:lnSpc>
+                <a:spcPct val="112000"/>
+              </a:lnSpc>
+              <a:spcBef>
+                <a:spcPts val="0"/>
+              </a:spcBef>
+              <a:spcAft>
+                <a:spcPts val="0"/>
+              </a:spcAft>
+              <a:buNone/>
+              <a:defRPr sz="1875">
+                <a:solidFill>
+                  <a:srgbClr val="FFFFFF"/>
+                </a:solidFill>
+                <a:latin typeface="Arial"/>
+                <a:ea typeface="Arial"/>
+                <a:cs typeface="Arial"/>
+              </a:defRPr>
+            </a:pPr>
+            <a:r>
+              <a:rPr sz="1875">
+                <a:solidFill>
+                  <a:srgbClr val="FFFFFF"/>
+                </a:solidFill>
+                <a:latin typeface="Arial"/>
+                <a:ea typeface="Arial"/>
+                <a:cs typeface="Arial"/>
+              </a:rPr>
+              <a:t>Test a candidate only after you can explain it.</a:t>
             </a:r>
           </a:p>
         </p:txBody>
@@ -11731,7 +11536,24 @@
                 <a:ea typeface="Consolas"/>
                 <a:cs typeface="Consolas"/>
               </a:rPr>
-              <a:t># If bomb.c supports a filename</a:t>
+              <a:t>Useful notes to keep</a:t>
+            </a:r>
+          </a:p>
+          <a:p xmlns:a="http://schemas.openxmlformats.org/drawingml/2006/main">
+            <a:pPr marL="0" indent="0">
+              <a:lnSpc>
+                <a:spcPct val="112000"/>
+              </a:lnSpc>
+              <a:spcBef>
+                <a:spcPts val="0"/>
+              </a:spcBef>
+              <a:spcAft>
+                <a:spcPts val="0"/>
+              </a:spcAft>
+              <a:buNone/>
+            </a:pPr>
+            <a:r>
+              <a:t/>
             </a:r>
           </a:p>
           <a:p xmlns:a="http://schemas.openxmlformats.org/drawingml/2006/main">
@@ -11764,24 +11586,7 @@
                 <a:ea typeface="Consolas"/>
                 <a:cs typeface="Consolas"/>
               </a:rPr>
-              <a:t>(gdb) run answers.txt</a:t>
-            </a:r>
-          </a:p>
-          <a:p xmlns:a="http://schemas.openxmlformats.org/drawingml/2006/main">
-            <a:pPr marL="0" indent="0">
-              <a:lnSpc>
-                <a:spcPct val="112000"/>
-              </a:lnSpc>
-              <a:spcBef>
-                <a:spcPts val="0"/>
-              </a:spcBef>
-              <a:spcAft>
-                <a:spcPts val="0"/>
-              </a:spcAft>
-              <a:buNone/>
-            </a:pPr>
-            <a:r>
-              <a:t/>
+              <a:t>Function and instruction address</a:t>
             </a:r>
           </a:p>
           <a:p xmlns:a="http://schemas.openxmlformats.org/drawingml/2006/main">
@@ -11814,7 +11619,7 @@
                 <a:ea typeface="Consolas"/>
                 <a:cs typeface="Consolas"/>
               </a:rPr>
-              <a:t># Otherwise, stdin redirection</a:t>
+              <a:t>Input fields</a:t>
             </a:r>
           </a:p>
           <a:p xmlns:a="http://schemas.openxmlformats.org/drawingml/2006/main">
@@ -11847,24 +11652,7 @@
                 <a:ea typeface="Consolas"/>
                 <a:cs typeface="Consolas"/>
               </a:rPr>
-              <a:t>(gdb) run &lt; answers.txt</a:t>
-            </a:r>
-          </a:p>
-          <a:p xmlns:a="http://schemas.openxmlformats.org/drawingml/2006/main">
-            <a:pPr marL="0" indent="0">
-              <a:lnSpc>
-                <a:spcPct val="112000"/>
-              </a:lnSpc>
-              <a:spcBef>
-                <a:spcPts val="0"/>
-              </a:spcBef>
-              <a:spcAft>
-                <a:spcPts val="0"/>
-              </a:spcAft>
-              <a:buNone/>
-            </a:pPr>
-            <a:r>
-              <a:t/>
+              <a:t>Condition required to pass</a:t>
             </a:r>
           </a:p>
           <a:p xmlns:a="http://schemas.openxmlformats.org/drawingml/2006/main">
@@ -11897,7 +11685,7 @@
                 <a:ea typeface="Consolas"/>
                 <a:cs typeface="Consolas"/>
               </a:rPr>
-              <a:t># Breakpoints remain in this session</a:t>
+              <a:t>Observed register or memory values</a:t>
             </a:r>
           </a:p>
           <a:p xmlns:a="http://schemas.openxmlformats.org/drawingml/2006/main">
@@ -11930,7 +11718,7 @@
                 <a:ea typeface="Consolas"/>
                 <a:cs typeface="Consolas"/>
               </a:rPr>
-              <a:t>(gdb) info breakpoints</a:t>
+              <a:t>Reason for the candidate input</a:t>
             </a:r>
           </a:p>
         </p:txBody>
@@ -11940,1130 +11728,7 @@
           <p:cNvPr id="534" name="Takeaway">
             <a:extLst xmlns:a="http://schemas.openxmlformats.org/drawingml/2006/main">
               <a:ext uri="{FF2B5EF4-FFF2-40B4-BE49-F238E27FC236}">
-                <a16:creationId xmlns:a16="http://schemas.microsoft.com/office/drawing/2014/main" id="{5490A65B-76B8-4DB0-AA1D-B3FEC2A78DAB}"/>
-              </a:ext>
-            </a:extLst>
-          </p:cNvPr>
-          <p:cNvSpPr>
-            <a:spLocks xmlns:a="http://schemas.openxmlformats.org/drawingml/2006/main" noGrp="1"/>
-          </p:cNvSpPr>
-          <p:nvPr/>
-        </p:nvSpPr>
-        <p:spPr>
-          <a:xfrm xmlns:a="http://schemas.openxmlformats.org/drawingml/2006/main">
-            <a:off x="393668" y="5715000"/>
-            <a:ext cx="11404283" cy="466725"/>
-          </a:xfrm>
-          <a:prstGeom xmlns:a="http://schemas.openxmlformats.org/drawingml/2006/main" prst="rect">
-            <a:avLst/>
-          </a:prstGeom>
-          <a:noFill xmlns:a="http://schemas.openxmlformats.org/drawingml/2006/main"/>
-          <a:ln xmlns:a="http://schemas.openxmlformats.org/drawingml/2006/main" w="0">
-            <a:noFill/>
-          </a:ln>
-        </p:spPr>
-        <p:txBody>
-          <a:bodyPr xmlns:a="http://schemas.openxmlformats.org/drawingml/2006/main" lIns="0" tIns="0" rIns="0" bIns="0" anchor="t">
-            <a:noAutofit/>
-          </a:bodyPr>
-          <a:lstStyle xmlns:a="http://schemas.openxmlformats.org/drawingml/2006/main">
-            <a:defPPr>
-              <a:defRPr sz="1350">
-                <a:solidFill>
-                  <a:srgbClr val="CCCCCC"/>
-                </a:solidFill>
-                <a:latin typeface="Arial"/>
-                <a:ea typeface="Arial"/>
-                <a:cs typeface="Arial"/>
-              </a:defRPr>
-            </a:defPPr>
-          </a:lstStyle>
-          <a:p xmlns:a="http://schemas.openxmlformats.org/drawingml/2006/main">
-            <a:pPr marL="0" indent="0">
-              <a:lnSpc>
-                <a:spcPct val="112000"/>
-              </a:lnSpc>
-              <a:spcBef>
-                <a:spcPts val="0"/>
-              </a:spcBef>
-              <a:spcAft>
-                <a:spcPts val="0"/>
-              </a:spcAft>
-              <a:buNone/>
-              <a:defRPr sz="1350">
-                <a:solidFill>
-                  <a:srgbClr val="CCCCCC"/>
-                </a:solidFill>
-                <a:latin typeface="Arial"/>
-                <a:ea typeface="Arial"/>
-                <a:cs typeface="Arial"/>
-              </a:defRPr>
-            </a:pPr>
-            <a:r>
-              <a:rPr sz="1350">
-                <a:solidFill>
-                  <a:srgbClr val="CCCCCC"/>
-                </a:solidFill>
-                <a:latin typeface="Arial"/>
-                <a:ea typeface="Arial"/>
-                <a:cs typeface="Arial"/>
-              </a:rPr>
-              <a:t>An argument file and stdin redirection handle end-of-file differently. Check your version before relying on either.</a:t>
-            </a:r>
-          </a:p>
-        </p:txBody>
-      </p:sp>
-    </p:spTree>
-    <p:extLst>
-      <p:ext uri="{BB962C8B-B14F-4D97-AF65-F5344CB8AC3E}">
-        <p14:creationId xmlns:p14="http://schemas.microsoft.com/office/powerpoint/2010/main" val="3667182145"/>
-      </p:ext>
-    </p:extLst>
-  </p:cSld>
-</p:sld>
-</file>
-
-<file path=ppt/slides/slide16.xml><?xml version="1.0" encoding="utf-8"?>
-<p:sld xmlns:p="http://schemas.openxmlformats.org/presentationml/2006/main">
-  <p:cSld>
-    <p:spTree>
-      <p:nvGrpSpPr>
-        <p:cNvPr id="1" name=""/>
-        <p:cNvGrpSpPr/>
-        <p:nvPr/>
-      </p:nvGrpSpPr>
-      <p:grpSpPr>
-        <a:xfrm xmlns:a="http://schemas.openxmlformats.org/drawingml/2006/main"/>
-      </p:grpSpPr>
-      <p:sp>
-        <p:nvSpPr>
-          <p:cNvPr id="3" name="Footer Placeholder 2">
-            <a:extLst xmlns:a="http://schemas.openxmlformats.org/drawingml/2006/main">
-              <a:ext uri="{FF2B5EF4-FFF2-40B4-BE49-F238E27FC236}">
-                <a16:creationId xmlns:a16="http://schemas.microsoft.com/office/drawing/2014/main" id="{39EA4C82-C623-0196-4A95-876ADF5DEE92}"/>
-              </a:ext>
-            </a:extLst>
-          </p:cNvPr>
-          <p:cNvSpPr>
-            <a:spLocks xmlns:a="http://schemas.openxmlformats.org/drawingml/2006/main" noGrp="1"/>
-          </p:cNvSpPr>
-          <p:nvPr>
-            <p:ph type="ftr" idx="3"/>
-          </p:nvPr>
-        </p:nvSpPr>
-        <p:spPr>
-          <a:xfrm xmlns:a="http://schemas.openxmlformats.org/drawingml/2006/main">
-            <a:off x="393700" y="6279952"/>
-            <a:ext cx="3568700" cy="241240"/>
-          </a:xfrm>
-        </p:spPr>
-        <p:txBody>
-          <a:bodyPr xmlns:a="http://schemas.openxmlformats.org/drawingml/2006/main" lIns="0" tIns="0" rIns="0" bIns="0" anchor="t">
-            <a:noAutofit/>
-          </a:bodyPr>
-          <a:lstStyle xmlns:a="http://schemas.openxmlformats.org/drawingml/2006/main">
-            <a:defPPr>
-              <a:defRPr sz="1125">
-                <a:solidFill>
-                  <a:srgbClr val="FFFFFF"/>
-                </a:solidFill>
-                <a:latin typeface="Arial"/>
-                <a:ea typeface="Arial"/>
-                <a:cs typeface="Arial"/>
-              </a:defRPr>
-            </a:defPPr>
-          </a:lstStyle>
-          <a:p xmlns:a="http://schemas.openxmlformats.org/drawingml/2006/main">
-            <a:pPr marL="0" indent="0">
-              <a:lnSpc>
-                <a:spcPct val="112000"/>
-              </a:lnSpc>
-              <a:spcBef>
-                <a:spcPts val="0"/>
-              </a:spcBef>
-              <a:spcAft>
-                <a:spcPts val="0"/>
-              </a:spcAft>
-              <a:buNone/>
-              <a:defRPr sz="1125">
-                <a:solidFill>
-                  <a:srgbClr val="FFFFFF"/>
-                </a:solidFill>
-                <a:latin typeface="Arial"/>
-                <a:ea typeface="Arial"/>
-                <a:cs typeface="Arial"/>
-              </a:defRPr>
-            </a:pPr>
-            <a:r>
-              <a:rPr sz="1125">
-                <a:solidFill>
-                  <a:srgbClr val="FFFFFF"/>
-                </a:solidFill>
-                <a:latin typeface="Arial"/>
-                <a:ea typeface="Arial"/>
-                <a:cs typeface="Arial"/>
-              </a:rPr>
-              <a:t>CS 211 · Recitation 05</a:t>
-            </a:r>
-          </a:p>
-        </p:txBody>
-      </p:sp>
-      <p:sp>
-        <p:nvSpPr>
-          <p:cNvPr id="532" name="Google Shape;532;p58">
-            <a:extLst xmlns:a="http://schemas.openxmlformats.org/drawingml/2006/main">
-              <a:ext uri="{FF2B5EF4-FFF2-40B4-BE49-F238E27FC236}">
-                <a16:creationId xmlns:a16="http://schemas.microsoft.com/office/drawing/2014/main" id="{1BCBE750-7048-686D-1472-52C53362D6CD}"/>
-              </a:ext>
-            </a:extLst>
-          </p:cNvPr>
-          <p:cNvSpPr>
-            <a:spLocks xmlns:a="http://schemas.openxmlformats.org/drawingml/2006/main" noGrp="1"/>
-          </p:cNvSpPr>
-          <p:nvPr>
-            <p:ph type="sldNum" idx="4"/>
-          </p:nvPr>
-        </p:nvSpPr>
-        <p:spPr>
-          <a:xfrm xmlns:a="http://schemas.openxmlformats.org/drawingml/2006/main">
-            <a:off x="11279332" y="6279294"/>
-            <a:ext cx="518968" cy="241240"/>
-          </a:xfrm>
-        </p:spPr>
-        <p:txBody>
-          <a:bodyPr xmlns:a="http://schemas.openxmlformats.org/drawingml/2006/main" spcFirstLastPara="1" vert="horz" wrap="square" lIns="0" tIns="0" rIns="0" bIns="0" anchor="t">
-            <a:noAutofit/>
-          </a:bodyPr>
-          <a:lstStyle xmlns:a="http://schemas.openxmlformats.org/drawingml/2006/main">
-            <a:defPPr>
-              <a:defRPr sz="1125">
-                <a:solidFill>
-                  <a:srgbClr val="FFFFFF"/>
-                </a:solidFill>
-                <a:latin typeface="Arial"/>
-                <a:ea typeface="Arial"/>
-                <a:cs typeface="Arial"/>
-              </a:defRPr>
-            </a:defPPr>
-          </a:lstStyle>
-          <a:p xmlns:a="http://schemas.openxmlformats.org/drawingml/2006/main">
-            <a:pPr marL="0" indent="0">
-              <a:lnSpc>
-                <a:spcPct val="112000"/>
-              </a:lnSpc>
-              <a:spcBef>
-                <a:spcPts val="0"/>
-              </a:spcBef>
-              <a:spcAft>
-                <a:spcPts val="0"/>
-              </a:spcAft>
-              <a:buNone/>
-              <a:defRPr sz="1125">
-                <a:solidFill>
-                  <a:srgbClr val="FFFFFF"/>
-                </a:solidFill>
-                <a:latin typeface="Arial"/>
-                <a:ea typeface="Arial"/>
-                <a:cs typeface="Arial"/>
-              </a:defRPr>
-            </a:pPr>
-            <a:r>
-              <a:rPr sz="1125">
-                <a:solidFill>
-                  <a:srgbClr val="FFFFFF"/>
-                </a:solidFill>
-                <a:latin typeface="Arial"/>
-                <a:ea typeface="Arial"/>
-                <a:cs typeface="Arial"/>
-              </a:rPr>
-              <a:t>16</a:t>
-            </a:r>
-          </a:p>
-        </p:txBody>
-      </p:sp>
-      <p:sp>
-        <p:nvSpPr>
-          <p:cNvPr id="533" name="Google Shape;533;p58">
-            <a:extLst xmlns:a="http://schemas.openxmlformats.org/drawingml/2006/main">
-              <a:ext uri="{FF2B5EF4-FFF2-40B4-BE49-F238E27FC236}">
-                <a16:creationId xmlns:a16="http://schemas.microsoft.com/office/drawing/2014/main" id="{1B5D55CD-1C17-7CD8-F26A-2DD65B067687}"/>
-              </a:ext>
-            </a:extLst>
-          </p:cNvPr>
-          <p:cNvSpPr>
-            <a:spLocks xmlns:a="http://schemas.openxmlformats.org/drawingml/2006/main" noGrp="1"/>
-          </p:cNvSpPr>
-          <p:nvPr>
-            <p:ph type="title" idx="0"/>
-          </p:nvPr>
-        </p:nvSpPr>
-        <p:spPr>
-          <a:xfrm xmlns:a="http://schemas.openxmlformats.org/drawingml/2006/main">
-            <a:off x="393700" y="344008"/>
-            <a:ext cx="11404600" cy="1047491"/>
-          </a:xfrm>
-        </p:spPr>
-        <p:txBody>
-          <a:bodyPr xmlns:a="http://schemas.openxmlformats.org/drawingml/2006/main" spcFirstLastPara="1" vert="horz" wrap="square" lIns="0" tIns="0" rIns="0" bIns="0" anchor="t">
-            <a:noAutofit/>
-          </a:bodyPr>
-          <a:lstStyle xmlns:a="http://schemas.openxmlformats.org/drawingml/2006/main">
-            <a:defPPr>
-              <a:defRPr sz="3150">
-                <a:solidFill>
-                  <a:srgbClr val="FFFFFF"/>
-                </a:solidFill>
-                <a:latin typeface="Arial"/>
-                <a:ea typeface="Arial"/>
-                <a:cs typeface="Arial"/>
-              </a:defRPr>
-            </a:defPPr>
-          </a:lstStyle>
-          <a:p xmlns:a="http://schemas.openxmlformats.org/drawingml/2006/main">
-            <a:pPr marL="0" indent="0">
-              <a:lnSpc>
-                <a:spcPct val="112000"/>
-              </a:lnSpc>
-              <a:spcBef>
-                <a:spcPts val="0"/>
-              </a:spcBef>
-              <a:spcAft>
-                <a:spcPts val="0"/>
-              </a:spcAft>
-              <a:buNone/>
-              <a:defRPr sz="3150">
-                <a:solidFill>
-                  <a:srgbClr val="FFFFFF"/>
-                </a:solidFill>
-                <a:latin typeface="Arial"/>
-                <a:ea typeface="Arial"/>
-                <a:cs typeface="Arial"/>
-              </a:defRPr>
-            </a:pPr>
-            <a:r>
-              <a:rPr sz="3150">
-                <a:solidFill>
-                  <a:srgbClr val="FFFFFF"/>
-                </a:solidFill>
-                <a:latin typeface="Arial"/>
-                <a:ea typeface="Arial"/>
-                <a:cs typeface="Arial"/>
-              </a:rPr>
-              <a:t>A phase investigation</a:t>
-            </a:r>
-          </a:p>
-        </p:txBody>
-      </p:sp>
-      <p:sp>
-        <p:nvSpPr>
-          <p:cNvPr id="7" name="Google Shape;534;p58">
-            <a:extLst xmlns:a="http://schemas.openxmlformats.org/drawingml/2006/main">
-              <a:ext uri="{FF2B5EF4-FFF2-40B4-BE49-F238E27FC236}">
-                <a16:creationId xmlns:a16="http://schemas.microsoft.com/office/drawing/2014/main" id="{3A923FEE-B8D2-CD3A-ABBD-21770B40AA24}"/>
-              </a:ext>
-            </a:extLst>
-          </p:cNvPr>
-          <p:cNvSpPr>
-            <a:spLocks xmlns:a="http://schemas.openxmlformats.org/drawingml/2006/main" noGrp="1"/>
-          </p:cNvSpPr>
-          <p:nvPr/>
-        </p:nvSpPr>
-        <p:spPr>
-          <a:xfrm xmlns:a="http://schemas.openxmlformats.org/drawingml/2006/main">
-            <a:off x="393700" y="2031999"/>
-            <a:ext cx="5537200" cy="3534787"/>
-          </a:xfrm>
-          <a:prstGeom xmlns:a="http://schemas.openxmlformats.org/drawingml/2006/main" prst="rect">
-            <a:avLst/>
-          </a:prstGeom>
-        </p:spPr>
-        <p:txBody>
-          <a:bodyPr xmlns:a="http://schemas.openxmlformats.org/drawingml/2006/main" spcFirstLastPara="1" vert="horz" wrap="square" lIns="0" tIns="0" rIns="0" bIns="0" anchor="t">
-            <a:noAutofit/>
-          </a:bodyPr>
-          <a:lstStyle xmlns:a="http://schemas.openxmlformats.org/drawingml/2006/main">
-            <a:defPPr>
-              <a:defRPr sz="1875">
-                <a:solidFill>
-                  <a:srgbClr val="FFFFFF"/>
-                </a:solidFill>
-                <a:latin typeface="Arial"/>
-                <a:ea typeface="Arial"/>
-                <a:cs typeface="Arial"/>
-              </a:defRPr>
-            </a:defPPr>
-            <a:lvl1pPr marL="228600" indent="-228600" algn="l" defTabSz="914400">
-              <a:lnSpc>
-                <a:spcPct val="90000"/>
-              </a:lnSpc>
-              <a:spcBef>
-                <a:spcPts val="1000"/>
-              </a:spcBef>
-              <a:buFont typeface="Arial"/>
-              <a:buChar char="•"/>
-              <a:defRPr sz="2400" kern="1200">
-                <a:solidFill>
-                  <a:schemeClr val="tx1"/>
-                </a:solidFill>
-                <a:latin typeface="+mn-lt"/>
-                <a:ea typeface="+mn-lt"/>
-                <a:cs typeface="+mn-lt"/>
-              </a:defRPr>
-            </a:lvl1pPr>
-            <a:lvl2pPr marL="685800" indent="-228600" algn="l" defTabSz="914400">
-              <a:lnSpc>
-                <a:spcPct val="90000"/>
-              </a:lnSpc>
-              <a:spcBef>
-                <a:spcPts val="500"/>
-              </a:spcBef>
-              <a:buFont typeface="Arial"/>
-              <a:buChar char="•"/>
-              <a:defRPr sz="2000" kern="1200">
-                <a:solidFill>
-                  <a:schemeClr val="tx1"/>
-                </a:solidFill>
-                <a:latin typeface="+mn-lt"/>
-                <a:ea typeface="+mn-lt"/>
-                <a:cs typeface="+mn-lt"/>
-              </a:defRPr>
-            </a:lvl2pPr>
-            <a:lvl3pPr marL="1143000" indent="-228600" algn="l" defTabSz="914400">
-              <a:lnSpc>
-                <a:spcPct val="90000"/>
-              </a:lnSpc>
-              <a:spcBef>
-                <a:spcPts val="500"/>
-              </a:spcBef>
-              <a:buFont typeface="Arial"/>
-              <a:buChar char="•"/>
-              <a:defRPr sz="1800" kern="1200">
-                <a:solidFill>
-                  <a:schemeClr val="tx1"/>
-                </a:solidFill>
-                <a:latin typeface="+mn-lt"/>
-                <a:ea typeface="+mn-lt"/>
-                <a:cs typeface="+mn-lt"/>
-              </a:defRPr>
-            </a:lvl3pPr>
-            <a:lvl4pPr marL="1600200" indent="-228600" algn="l" defTabSz="914400">
-              <a:lnSpc>
-                <a:spcPct val="90000"/>
-              </a:lnSpc>
-              <a:spcBef>
-                <a:spcPts val="500"/>
-              </a:spcBef>
-              <a:buFont typeface="Arial"/>
-              <a:buChar char="•"/>
-              <a:defRPr sz="1800" kern="1200">
-                <a:solidFill>
-                  <a:schemeClr val="tx1"/>
-                </a:solidFill>
-                <a:latin typeface="+mn-lt"/>
-                <a:ea typeface="+mn-lt"/>
-                <a:cs typeface="+mn-lt"/>
-              </a:defRPr>
-            </a:lvl4pPr>
-            <a:lvl5pPr marL="2057400" indent="-228600" algn="l" defTabSz="914400">
-              <a:lnSpc>
-                <a:spcPct val="90000"/>
-              </a:lnSpc>
-              <a:spcBef>
-                <a:spcPts val="500"/>
-              </a:spcBef>
-              <a:buFont typeface="Arial"/>
-              <a:buChar char="•"/>
-              <a:defRPr sz="1800" kern="1200">
-                <a:solidFill>
-                  <a:schemeClr val="tx1"/>
-                </a:solidFill>
-                <a:latin typeface="+mn-lt"/>
-                <a:ea typeface="+mn-lt"/>
-                <a:cs typeface="+mn-lt"/>
-              </a:defRPr>
-            </a:lvl5pPr>
-            <a:lvl6pPr marL="2514600" indent="-228600" algn="l" defTabSz="914400">
-              <a:lnSpc>
-                <a:spcPct val="90000"/>
-              </a:lnSpc>
-              <a:spcBef>
-                <a:spcPts val="500"/>
-              </a:spcBef>
-              <a:buFont typeface="Arial"/>
-              <a:buChar char="•"/>
-              <a:defRPr sz="1800" kern="1200">
-                <a:solidFill>
-                  <a:schemeClr val="tx1"/>
-                </a:solidFill>
-                <a:latin typeface="+mn-lt"/>
-                <a:ea typeface="+mn-lt"/>
-                <a:cs typeface="+mn-lt"/>
-              </a:defRPr>
-            </a:lvl6pPr>
-            <a:lvl7pPr marL="2971800" indent="-228600" algn="l" defTabSz="914400">
-              <a:lnSpc>
-                <a:spcPct val="90000"/>
-              </a:lnSpc>
-              <a:spcBef>
-                <a:spcPts val="500"/>
-              </a:spcBef>
-              <a:buFont typeface="Arial"/>
-              <a:buChar char="•"/>
-              <a:defRPr sz="1800" kern="1200">
-                <a:solidFill>
-                  <a:schemeClr val="tx1"/>
-                </a:solidFill>
-                <a:latin typeface="+mn-lt"/>
-                <a:ea typeface="+mn-lt"/>
-                <a:cs typeface="+mn-lt"/>
-              </a:defRPr>
-            </a:lvl7pPr>
-            <a:lvl8pPr marL="3429000" indent="-228600" algn="l" defTabSz="914400">
-              <a:lnSpc>
-                <a:spcPct val="90000"/>
-              </a:lnSpc>
-              <a:spcBef>
-                <a:spcPts val="500"/>
-              </a:spcBef>
-              <a:buFont typeface="Arial"/>
-              <a:buChar char="•"/>
-              <a:defRPr sz="1800" kern="1200">
-                <a:solidFill>
-                  <a:schemeClr val="tx1"/>
-                </a:solidFill>
-                <a:latin typeface="+mn-lt"/>
-                <a:ea typeface="+mn-lt"/>
-                <a:cs typeface="+mn-lt"/>
-              </a:defRPr>
-            </a:lvl8pPr>
-            <a:lvl9pPr marL="3886200" indent="-228600" algn="l" defTabSz="914400">
-              <a:lnSpc>
-                <a:spcPct val="90000"/>
-              </a:lnSpc>
-              <a:spcBef>
-                <a:spcPts val="500"/>
-              </a:spcBef>
-              <a:buFont typeface="Arial"/>
-              <a:buChar char="•"/>
-              <a:defRPr sz="1800" kern="1200">
-                <a:solidFill>
-                  <a:schemeClr val="tx1"/>
-                </a:solidFill>
-                <a:latin typeface="+mn-lt"/>
-                <a:ea typeface="+mn-lt"/>
-                <a:cs typeface="+mn-lt"/>
-              </a:defRPr>
-            </a:lvl9pPr>
-          </a:lstStyle>
-          <a:p xmlns:a="http://schemas.openxmlformats.org/drawingml/2006/main">
-            <a:pPr marL="0" indent="0">
-              <a:lnSpc>
-                <a:spcPct val="112000"/>
-              </a:lnSpc>
-              <a:spcBef>
-                <a:spcPts val="0"/>
-              </a:spcBef>
-              <a:spcAft>
-                <a:spcPts val="0"/>
-              </a:spcAft>
-              <a:buNone/>
-              <a:defRPr sz="1875">
-                <a:solidFill>
-                  <a:srgbClr val="FFFFFF"/>
-                </a:solidFill>
-                <a:latin typeface="Arial"/>
-                <a:ea typeface="Arial"/>
-                <a:cs typeface="Arial"/>
-              </a:defRPr>
-            </a:pPr>
-            <a:r>
-              <a:rPr sz="1875">
-                <a:solidFill>
-                  <a:srgbClr val="FFFFFF"/>
-                </a:solidFill>
-                <a:latin typeface="Arial"/>
-                <a:ea typeface="Arial"/>
-                <a:cs typeface="Arial"/>
-              </a:rPr>
-              <a:t>Pause at the phase entry.</a:t>
-            </a:r>
-          </a:p>
-          <a:p xmlns:a="http://schemas.openxmlformats.org/drawingml/2006/main">
-            <a:pPr marL="0" indent="0">
-              <a:lnSpc>
-                <a:spcPct val="112000"/>
-              </a:lnSpc>
-              <a:spcBef>
-                <a:spcPts val="0"/>
-              </a:spcBef>
-              <a:spcAft>
-                <a:spcPts val="0"/>
-              </a:spcAft>
-              <a:buNone/>
-            </a:pPr>
-            <a:r>
-              <a:t/>
-            </a:r>
-          </a:p>
-          <a:p xmlns:a="http://schemas.openxmlformats.org/drawingml/2006/main">
-            <a:pPr marL="0" indent="0">
-              <a:lnSpc>
-                <a:spcPct val="112000"/>
-              </a:lnSpc>
-              <a:spcBef>
-                <a:spcPts val="0"/>
-              </a:spcBef>
-              <a:spcAft>
-                <a:spcPts val="0"/>
-              </a:spcAft>
-              <a:buNone/>
-              <a:defRPr sz="1875">
-                <a:solidFill>
-                  <a:srgbClr val="FFFFFF"/>
-                </a:solidFill>
-                <a:latin typeface="Arial"/>
-                <a:ea typeface="Arial"/>
-                <a:cs typeface="Arial"/>
-              </a:defRPr>
-            </a:pPr>
-            <a:r>
-              <a:rPr sz="1875">
-                <a:solidFill>
-                  <a:srgbClr val="FFFFFF"/>
-                </a:solidFill>
-                <a:latin typeface="Arial"/>
-                <a:ea typeface="Arial"/>
-                <a:cs typeface="Arial"/>
-              </a:rPr>
-              <a:t>Identify the input format and failure branches.</a:t>
-            </a:r>
-          </a:p>
-          <a:p xmlns:a="http://schemas.openxmlformats.org/drawingml/2006/main">
-            <a:pPr marL="0" indent="0">
-              <a:lnSpc>
-                <a:spcPct val="112000"/>
-              </a:lnSpc>
-              <a:spcBef>
-                <a:spcPts val="0"/>
-              </a:spcBef>
-              <a:spcAft>
-                <a:spcPts val="0"/>
-              </a:spcAft>
-              <a:buNone/>
-            </a:pPr>
-            <a:r>
-              <a:t/>
-            </a:r>
-          </a:p>
-          <a:p xmlns:a="http://schemas.openxmlformats.org/drawingml/2006/main">
-            <a:pPr marL="0" indent="0">
-              <a:lnSpc>
-                <a:spcPct val="112000"/>
-              </a:lnSpc>
-              <a:spcBef>
-                <a:spcPts val="0"/>
-              </a:spcBef>
-              <a:spcAft>
-                <a:spcPts val="0"/>
-              </a:spcAft>
-              <a:buNone/>
-              <a:defRPr sz="1875">
-                <a:solidFill>
-                  <a:srgbClr val="FFFFFF"/>
-                </a:solidFill>
-                <a:latin typeface="Arial"/>
-                <a:ea typeface="Arial"/>
-                <a:cs typeface="Arial"/>
-              </a:defRPr>
-            </a:pPr>
-            <a:r>
-              <a:rPr sz="1875">
-                <a:solidFill>
-                  <a:srgbClr val="FFFFFF"/>
-                </a:solidFill>
-                <a:latin typeface="Arial"/>
-                <a:ea typeface="Arial"/>
-                <a:cs typeface="Arial"/>
-              </a:rPr>
-              <a:t>Track the registers or memory that each check uses.</a:t>
-            </a:r>
-          </a:p>
-          <a:p xmlns:a="http://schemas.openxmlformats.org/drawingml/2006/main">
-            <a:pPr marL="0" indent="0">
-              <a:lnSpc>
-                <a:spcPct val="112000"/>
-              </a:lnSpc>
-              <a:spcBef>
-                <a:spcPts val="0"/>
-              </a:spcBef>
-              <a:spcAft>
-                <a:spcPts val="0"/>
-              </a:spcAft>
-              <a:buNone/>
-            </a:pPr>
-            <a:r>
-              <a:t/>
-            </a:r>
-          </a:p>
-          <a:p xmlns:a="http://schemas.openxmlformats.org/drawingml/2006/main">
-            <a:pPr marL="0" indent="0">
-              <a:lnSpc>
-                <a:spcPct val="112000"/>
-              </a:lnSpc>
-              <a:spcBef>
-                <a:spcPts val="0"/>
-              </a:spcBef>
-              <a:spcAft>
-                <a:spcPts val="0"/>
-              </a:spcAft>
-              <a:buNone/>
-              <a:defRPr sz="1875">
-                <a:solidFill>
-                  <a:srgbClr val="FFFFFF"/>
-                </a:solidFill>
-                <a:latin typeface="Arial"/>
-                <a:ea typeface="Arial"/>
-                <a:cs typeface="Arial"/>
-              </a:defRPr>
-            </a:pPr>
-            <a:r>
-              <a:rPr sz="1875">
-                <a:solidFill>
-                  <a:srgbClr val="FFFFFF"/>
-                </a:solidFill>
-                <a:latin typeface="Arial"/>
-                <a:ea typeface="Arial"/>
-                <a:cs typeface="Arial"/>
-              </a:rPr>
-              <a:t>Test a candidate only after you can explain it.</a:t>
-            </a:r>
-          </a:p>
-        </p:txBody>
-      </p:sp>
-      <p:sp>
-        <p:nvSpPr>
-          <p:cNvPr id="8" name="Content Placeholder 3">
-            <a:extLst xmlns:a="http://schemas.openxmlformats.org/drawingml/2006/main">
-              <a:ext uri="{FF2B5EF4-FFF2-40B4-BE49-F238E27FC236}">
-                <a16:creationId xmlns:a16="http://schemas.microsoft.com/office/drawing/2014/main" id="{2EE8F343-A95F-2AAA-FE9E-A6C31E298DF7}"/>
-              </a:ext>
-            </a:extLst>
-          </p:cNvPr>
-          <p:cNvSpPr>
-            <a:spLocks xmlns:a="http://schemas.openxmlformats.org/drawingml/2006/main" noGrp="1"/>
-          </p:cNvSpPr>
-          <p:nvPr/>
-        </p:nvSpPr>
-        <p:spPr>
-          <a:xfrm xmlns:a="http://schemas.openxmlformats.org/drawingml/2006/main">
-            <a:off x="6256618" y="2031999"/>
-            <a:ext cx="5537200" cy="3534787"/>
-          </a:xfrm>
-          <a:prstGeom xmlns:a="http://schemas.openxmlformats.org/drawingml/2006/main" prst="rect">
-            <a:avLst/>
-          </a:prstGeom>
-        </p:spPr>
-        <p:txBody>
-          <a:bodyPr xmlns:a="http://schemas.openxmlformats.org/drawingml/2006/main" lIns="0" tIns="0" rIns="0" bIns="0" anchor="t">
-            <a:noAutofit/>
-          </a:bodyPr>
-          <a:lstStyle xmlns:a="http://schemas.openxmlformats.org/drawingml/2006/main">
-            <a:defPPr>
-              <a:defRPr sz="1800">
-                <a:solidFill>
-                  <a:srgbClr val="FFFFFF"/>
-                </a:solidFill>
-                <a:latin typeface="Consolas"/>
-                <a:ea typeface="Consolas"/>
-                <a:cs typeface="Consolas"/>
-              </a:defRPr>
-            </a:defPPr>
-            <a:lvl1pPr marL="228600" indent="-228600" algn="l" defTabSz="914400">
-              <a:lnSpc>
-                <a:spcPct val="90000"/>
-              </a:lnSpc>
-              <a:spcBef>
-                <a:spcPts val="1000"/>
-              </a:spcBef>
-              <a:buFont typeface="Arial"/>
-              <a:buChar char="•"/>
-              <a:defRPr sz="2400" kern="1200">
-                <a:solidFill>
-                  <a:schemeClr val="tx1"/>
-                </a:solidFill>
-                <a:latin typeface="+mn-lt"/>
-                <a:ea typeface="+mn-lt"/>
-                <a:cs typeface="+mn-lt"/>
-              </a:defRPr>
-            </a:lvl1pPr>
-            <a:lvl2pPr marL="685800" indent="-228600" algn="l" defTabSz="914400">
-              <a:lnSpc>
-                <a:spcPct val="90000"/>
-              </a:lnSpc>
-              <a:spcBef>
-                <a:spcPts val="500"/>
-              </a:spcBef>
-              <a:buFont typeface="Arial"/>
-              <a:buChar char="•"/>
-              <a:defRPr sz="2000" kern="1200">
-                <a:solidFill>
-                  <a:schemeClr val="tx1"/>
-                </a:solidFill>
-                <a:latin typeface="+mn-lt"/>
-                <a:ea typeface="+mn-lt"/>
-                <a:cs typeface="+mn-lt"/>
-              </a:defRPr>
-            </a:lvl2pPr>
-            <a:lvl3pPr marL="1143000" indent="-228600" algn="l" defTabSz="914400">
-              <a:lnSpc>
-                <a:spcPct val="90000"/>
-              </a:lnSpc>
-              <a:spcBef>
-                <a:spcPts val="500"/>
-              </a:spcBef>
-              <a:buFont typeface="Arial"/>
-              <a:buChar char="•"/>
-              <a:defRPr sz="1800" kern="1200">
-                <a:solidFill>
-                  <a:schemeClr val="tx1"/>
-                </a:solidFill>
-                <a:latin typeface="+mn-lt"/>
-                <a:ea typeface="+mn-lt"/>
-                <a:cs typeface="+mn-lt"/>
-              </a:defRPr>
-            </a:lvl3pPr>
-            <a:lvl4pPr marL="1600200" indent="-228600" algn="l" defTabSz="914400">
-              <a:lnSpc>
-                <a:spcPct val="90000"/>
-              </a:lnSpc>
-              <a:spcBef>
-                <a:spcPts val="500"/>
-              </a:spcBef>
-              <a:buFont typeface="Arial"/>
-              <a:buChar char="•"/>
-              <a:defRPr sz="1800" kern="1200">
-                <a:solidFill>
-                  <a:schemeClr val="tx1"/>
-                </a:solidFill>
-                <a:latin typeface="+mn-lt"/>
-                <a:ea typeface="+mn-lt"/>
-                <a:cs typeface="+mn-lt"/>
-              </a:defRPr>
-            </a:lvl4pPr>
-            <a:lvl5pPr marL="2057400" indent="-228600" algn="l" defTabSz="914400">
-              <a:lnSpc>
-                <a:spcPct val="90000"/>
-              </a:lnSpc>
-              <a:spcBef>
-                <a:spcPts val="500"/>
-              </a:spcBef>
-              <a:buFont typeface="Arial"/>
-              <a:buChar char="•"/>
-              <a:defRPr sz="1800" kern="1200">
-                <a:solidFill>
-                  <a:schemeClr val="tx1"/>
-                </a:solidFill>
-                <a:latin typeface="+mn-lt"/>
-                <a:ea typeface="+mn-lt"/>
-                <a:cs typeface="+mn-lt"/>
-              </a:defRPr>
-            </a:lvl5pPr>
-            <a:lvl6pPr marL="2514600" indent="-228600" algn="l" defTabSz="914400">
-              <a:lnSpc>
-                <a:spcPct val="90000"/>
-              </a:lnSpc>
-              <a:spcBef>
-                <a:spcPts val="500"/>
-              </a:spcBef>
-              <a:buFont typeface="Arial"/>
-              <a:buChar char="•"/>
-              <a:defRPr sz="1800" kern="1200">
-                <a:solidFill>
-                  <a:schemeClr val="tx1"/>
-                </a:solidFill>
-                <a:latin typeface="+mn-lt"/>
-                <a:ea typeface="+mn-lt"/>
-                <a:cs typeface="+mn-lt"/>
-              </a:defRPr>
-            </a:lvl6pPr>
-            <a:lvl7pPr marL="2971800" indent="-228600" algn="l" defTabSz="914400">
-              <a:lnSpc>
-                <a:spcPct val="90000"/>
-              </a:lnSpc>
-              <a:spcBef>
-                <a:spcPts val="500"/>
-              </a:spcBef>
-              <a:buFont typeface="Arial"/>
-              <a:buChar char="•"/>
-              <a:defRPr sz="1800" kern="1200">
-                <a:solidFill>
-                  <a:schemeClr val="tx1"/>
-                </a:solidFill>
-                <a:latin typeface="+mn-lt"/>
-                <a:ea typeface="+mn-lt"/>
-                <a:cs typeface="+mn-lt"/>
-              </a:defRPr>
-            </a:lvl7pPr>
-            <a:lvl8pPr marL="3429000" indent="-228600" algn="l" defTabSz="914400">
-              <a:lnSpc>
-                <a:spcPct val="90000"/>
-              </a:lnSpc>
-              <a:spcBef>
-                <a:spcPts val="500"/>
-              </a:spcBef>
-              <a:buFont typeface="Arial"/>
-              <a:buChar char="•"/>
-              <a:defRPr sz="1800" kern="1200">
-                <a:solidFill>
-                  <a:schemeClr val="tx1"/>
-                </a:solidFill>
-                <a:latin typeface="+mn-lt"/>
-                <a:ea typeface="+mn-lt"/>
-                <a:cs typeface="+mn-lt"/>
-              </a:defRPr>
-            </a:lvl8pPr>
-            <a:lvl9pPr marL="3886200" indent="-228600" algn="l" defTabSz="914400">
-              <a:lnSpc>
-                <a:spcPct val="90000"/>
-              </a:lnSpc>
-              <a:spcBef>
-                <a:spcPts val="500"/>
-              </a:spcBef>
-              <a:buFont typeface="Arial"/>
-              <a:buChar char="•"/>
-              <a:defRPr sz="1800" kern="1200">
-                <a:solidFill>
-                  <a:schemeClr val="tx1"/>
-                </a:solidFill>
-                <a:latin typeface="+mn-lt"/>
-                <a:ea typeface="+mn-lt"/>
-                <a:cs typeface="+mn-lt"/>
-              </a:defRPr>
-            </a:lvl9pPr>
-          </a:lstStyle>
-          <a:p xmlns:a="http://schemas.openxmlformats.org/drawingml/2006/main">
-            <a:pPr marL="0" indent="0">
-              <a:lnSpc>
-                <a:spcPct val="112000"/>
-              </a:lnSpc>
-              <a:spcBef>
-                <a:spcPts val="0"/>
-              </a:spcBef>
-              <a:spcAft>
-                <a:spcPts val="0"/>
-              </a:spcAft>
-              <a:buNone/>
-              <a:defRPr sz="1800">
-                <a:solidFill>
-                  <a:srgbClr val="FFFFFF"/>
-                </a:solidFill>
-                <a:latin typeface="Consolas"/>
-                <a:ea typeface="Consolas"/>
-                <a:cs typeface="Consolas"/>
-              </a:defRPr>
-            </a:pPr>
-            <a:r>
-              <a:rPr sz="1800">
-                <a:solidFill>
-                  <a:srgbClr val="FFFFFF"/>
-                </a:solidFill>
-                <a:latin typeface="Consolas"/>
-                <a:ea typeface="Consolas"/>
-                <a:cs typeface="Consolas"/>
-              </a:rPr>
-              <a:t>Useful notes to keep</a:t>
-            </a:r>
-          </a:p>
-          <a:p xmlns:a="http://schemas.openxmlformats.org/drawingml/2006/main">
-            <a:pPr marL="0" indent="0">
-              <a:lnSpc>
-                <a:spcPct val="112000"/>
-              </a:lnSpc>
-              <a:spcBef>
-                <a:spcPts val="0"/>
-              </a:spcBef>
-              <a:spcAft>
-                <a:spcPts val="0"/>
-              </a:spcAft>
-              <a:buNone/>
-            </a:pPr>
-            <a:r>
-              <a:t/>
-            </a:r>
-          </a:p>
-          <a:p xmlns:a="http://schemas.openxmlformats.org/drawingml/2006/main">
-            <a:pPr marL="0" indent="0">
-              <a:lnSpc>
-                <a:spcPct val="112000"/>
-              </a:lnSpc>
-              <a:spcBef>
-                <a:spcPts val="0"/>
-              </a:spcBef>
-              <a:spcAft>
-                <a:spcPts val="0"/>
-              </a:spcAft>
-              <a:buNone/>
-              <a:defRPr sz="1800">
-                <a:solidFill>
-                  <a:srgbClr val="FFFFFF"/>
-                </a:solidFill>
-                <a:latin typeface="Consolas"/>
-                <a:ea typeface="Consolas"/>
-                <a:cs typeface="Consolas"/>
-              </a:defRPr>
-            </a:pPr>
-            <a:r>
-              <a:rPr sz="1800">
-                <a:solidFill>
-                  <a:srgbClr val="FFFFFF"/>
-                </a:solidFill>
-                <a:latin typeface="Consolas"/>
-                <a:ea typeface="Consolas"/>
-                <a:cs typeface="Consolas"/>
-              </a:rPr>
-              <a:t>Function and instruction address</a:t>
-            </a:r>
-          </a:p>
-          <a:p xmlns:a="http://schemas.openxmlformats.org/drawingml/2006/main">
-            <a:pPr marL="0" indent="0">
-              <a:lnSpc>
-                <a:spcPct val="112000"/>
-              </a:lnSpc>
-              <a:spcBef>
-                <a:spcPts val="0"/>
-              </a:spcBef>
-              <a:spcAft>
-                <a:spcPts val="0"/>
-              </a:spcAft>
-              <a:buNone/>
-              <a:defRPr sz="1800">
-                <a:solidFill>
-                  <a:srgbClr val="FFFFFF"/>
-                </a:solidFill>
-                <a:latin typeface="Consolas"/>
-                <a:ea typeface="Consolas"/>
-                <a:cs typeface="Consolas"/>
-              </a:defRPr>
-            </a:pPr>
-            <a:r>
-              <a:rPr sz="1800">
-                <a:solidFill>
-                  <a:srgbClr val="FFFFFF"/>
-                </a:solidFill>
-                <a:latin typeface="Consolas"/>
-                <a:ea typeface="Consolas"/>
-                <a:cs typeface="Consolas"/>
-              </a:rPr>
-              <a:t>Input fields</a:t>
-            </a:r>
-          </a:p>
-          <a:p xmlns:a="http://schemas.openxmlformats.org/drawingml/2006/main">
-            <a:pPr marL="0" indent="0">
-              <a:lnSpc>
-                <a:spcPct val="112000"/>
-              </a:lnSpc>
-              <a:spcBef>
-                <a:spcPts val="0"/>
-              </a:spcBef>
-              <a:spcAft>
-                <a:spcPts val="0"/>
-              </a:spcAft>
-              <a:buNone/>
-              <a:defRPr sz="1800">
-                <a:solidFill>
-                  <a:srgbClr val="FFFFFF"/>
-                </a:solidFill>
-                <a:latin typeface="Consolas"/>
-                <a:ea typeface="Consolas"/>
-                <a:cs typeface="Consolas"/>
-              </a:defRPr>
-            </a:pPr>
-            <a:r>
-              <a:rPr sz="1800">
-                <a:solidFill>
-                  <a:srgbClr val="FFFFFF"/>
-                </a:solidFill>
-                <a:latin typeface="Consolas"/>
-                <a:ea typeface="Consolas"/>
-                <a:cs typeface="Consolas"/>
-              </a:rPr>
-              <a:t>Condition required to pass</a:t>
-            </a:r>
-          </a:p>
-          <a:p xmlns:a="http://schemas.openxmlformats.org/drawingml/2006/main">
-            <a:pPr marL="0" indent="0">
-              <a:lnSpc>
-                <a:spcPct val="112000"/>
-              </a:lnSpc>
-              <a:spcBef>
-                <a:spcPts val="0"/>
-              </a:spcBef>
-              <a:spcAft>
-                <a:spcPts val="0"/>
-              </a:spcAft>
-              <a:buNone/>
-              <a:defRPr sz="1800">
-                <a:solidFill>
-                  <a:srgbClr val="FFFFFF"/>
-                </a:solidFill>
-                <a:latin typeface="Consolas"/>
-                <a:ea typeface="Consolas"/>
-                <a:cs typeface="Consolas"/>
-              </a:defRPr>
-            </a:pPr>
-            <a:r>
-              <a:rPr sz="1800">
-                <a:solidFill>
-                  <a:srgbClr val="FFFFFF"/>
-                </a:solidFill>
-                <a:latin typeface="Consolas"/>
-                <a:ea typeface="Consolas"/>
-                <a:cs typeface="Consolas"/>
-              </a:rPr>
-              <a:t>Observed register or memory values</a:t>
-            </a:r>
-          </a:p>
-          <a:p xmlns:a="http://schemas.openxmlformats.org/drawingml/2006/main">
-            <a:pPr marL="0" indent="0">
-              <a:lnSpc>
-                <a:spcPct val="112000"/>
-              </a:lnSpc>
-              <a:spcBef>
-                <a:spcPts val="0"/>
-              </a:spcBef>
-              <a:spcAft>
-                <a:spcPts val="0"/>
-              </a:spcAft>
-              <a:buNone/>
-              <a:defRPr sz="1800">
-                <a:solidFill>
-                  <a:srgbClr val="FFFFFF"/>
-                </a:solidFill>
-                <a:latin typeface="Consolas"/>
-                <a:ea typeface="Consolas"/>
-                <a:cs typeface="Consolas"/>
-              </a:defRPr>
-            </a:pPr>
-            <a:r>
-              <a:rPr sz="1800">
-                <a:solidFill>
-                  <a:srgbClr val="FFFFFF"/>
-                </a:solidFill>
-                <a:latin typeface="Consolas"/>
-                <a:ea typeface="Consolas"/>
-                <a:cs typeface="Consolas"/>
-              </a:rPr>
-              <a:t>Reason for the candidate input</a:t>
-            </a:r>
-          </a:p>
-        </p:txBody>
-      </p:sp>
-      <p:sp>
-        <p:nvSpPr>
-          <p:cNvPr id="534" name="Takeaway">
-            <a:extLst xmlns:a="http://schemas.openxmlformats.org/drawingml/2006/main">
-              <a:ext uri="{FF2B5EF4-FFF2-40B4-BE49-F238E27FC236}">
-                <a16:creationId xmlns:a16="http://schemas.microsoft.com/office/drawing/2014/main" id="{8D4EF907-B2E6-4339-A152-EB297CA73082}"/>
+                <a16:creationId xmlns:a16="http://schemas.microsoft.com/office/drawing/2014/main" id="{D792A128-F40B-40CF-A498-4A79055B2E50}"/>
               </a:ext>
             </a:extLst>
           </p:cNvPr>
@@ -14086,7 +12751,7 @@
           <p:cNvPr id="534" name="Takeaway">
             <a:extLst xmlns:a="http://schemas.openxmlformats.org/drawingml/2006/main">
               <a:ext uri="{FF2B5EF4-FFF2-40B4-BE49-F238E27FC236}">
-                <a16:creationId xmlns:a16="http://schemas.microsoft.com/office/drawing/2014/main" id="{78BDB389-D90F-44E6-A047-1F8E376F78F2}"/>
+                <a16:creationId xmlns:a16="http://schemas.microsoft.com/office/drawing/2014/main" id="{85E8CDB0-76C0-49EA-85FB-C7184CCE6FCA}"/>
               </a:ext>
             </a:extLst>
           </p:cNvPr>
@@ -16171,7 +14836,7 @@
           <p:cNvPr id="534" name="Takeaway">
             <a:extLst xmlns:a="http://schemas.openxmlformats.org/drawingml/2006/main">
               <a:ext uri="{FF2B5EF4-FFF2-40B4-BE49-F238E27FC236}">
-                <a16:creationId xmlns:a16="http://schemas.microsoft.com/office/drawing/2014/main" id="{3272CA29-1403-4D0D-A7F0-B59A38508441}"/>
+                <a16:creationId xmlns:a16="http://schemas.microsoft.com/office/drawing/2014/main" id="{5E0C9901-5AD3-4BC0-9FFC-02D34D32A113}"/>
               </a:ext>
             </a:extLst>
           </p:cNvPr>
@@ -17227,7 +15892,7 @@
           <p:cNvPr id="534" name="Takeaway">
             <a:extLst xmlns:a="http://schemas.openxmlformats.org/drawingml/2006/main">
               <a:ext uri="{FF2B5EF4-FFF2-40B4-BE49-F238E27FC236}">
-                <a16:creationId xmlns:a16="http://schemas.microsoft.com/office/drawing/2014/main" id="{87DD4254-46B5-437D-91D3-D3B77B125AA9}"/>
+                <a16:creationId xmlns:a16="http://schemas.microsoft.com/office/drawing/2014/main" id="{0F231897-DB4A-48A8-82D4-D2FF2651B91C}"/>
               </a:ext>
             </a:extLst>
           </p:cNvPr>
@@ -18333,7 +16998,7 @@
           <p:cNvPr id="534" name="Takeaway">
             <a:extLst xmlns:a="http://schemas.openxmlformats.org/drawingml/2006/main">
               <a:ext uri="{FF2B5EF4-FFF2-40B4-BE49-F238E27FC236}">
-                <a16:creationId xmlns:a16="http://schemas.microsoft.com/office/drawing/2014/main" id="{6F043ED2-D16C-4D2F-8F6C-C0928AF21944}"/>
+                <a16:creationId xmlns:a16="http://schemas.microsoft.com/office/drawing/2014/main" id="{5B53BFD3-DFB9-4BF2-8286-246C0AAC7FD8}"/>
               </a:ext>
             </a:extLst>
           </p:cNvPr>
@@ -19439,7 +18104,7 @@
           <p:cNvPr id="534" name="Takeaway">
             <a:extLst xmlns:a="http://schemas.openxmlformats.org/drawingml/2006/main">
               <a:ext uri="{FF2B5EF4-FFF2-40B4-BE49-F238E27FC236}">
-                <a16:creationId xmlns:a16="http://schemas.microsoft.com/office/drawing/2014/main" id="{880E7F1E-836D-4DC1-A137-879ABC73A7D1}"/>
+                <a16:creationId xmlns:a16="http://schemas.microsoft.com/office/drawing/2014/main" id="{87CDCF4D-4695-48AC-A49D-438EA4DDAD1F}"/>
               </a:ext>
             </a:extLst>
           </p:cNvPr>
@@ -20562,7 +19227,7 @@
           <p:cNvPr id="534" name="Takeaway">
             <a:extLst xmlns:a="http://schemas.openxmlformats.org/drawingml/2006/main">
               <a:ext uri="{FF2B5EF4-FFF2-40B4-BE49-F238E27FC236}">
-                <a16:creationId xmlns:a16="http://schemas.microsoft.com/office/drawing/2014/main" id="{D17E0589-BB46-4792-A357-5A56FE16E302}"/>
+                <a16:creationId xmlns:a16="http://schemas.microsoft.com/office/drawing/2014/main" id="{B07125B4-5A33-4035-B7A7-3AC654DA2F71}"/>
               </a:ext>
             </a:extLst>
           </p:cNvPr>
@@ -21668,7 +20333,7 @@
           <p:cNvPr id="534" name="Takeaway">
             <a:extLst xmlns:a="http://schemas.openxmlformats.org/drawingml/2006/main">
               <a:ext uri="{FF2B5EF4-FFF2-40B4-BE49-F238E27FC236}">
-                <a16:creationId xmlns:a16="http://schemas.microsoft.com/office/drawing/2014/main" id="{C974FA69-7C57-4458-95EC-CE044A1B0620}"/>
+                <a16:creationId xmlns:a16="http://schemas.microsoft.com/office/drawing/2014/main" id="{4D0DE5D7-514C-4CD4-8288-6344973F2F23}"/>
               </a:ext>
             </a:extLst>
           </p:cNvPr>

</xml_diff>